<commit_message>
docs: update Slide 2 (Brief about the idea) with 4 intelligent capabilities and action framework
</commit_message>
<xml_diff>
--- a/docs/TwinForge_AI_Builder_Cup.pptx
+++ b/docs/TwinForge_AI_Builder_Cup.pptx
@@ -6844,640 +6844,7 @@
 </p:sld>
 </file>
 
-<file path=ppt/slides/slide11.xml><?xml version="1.0" encoding="utf-8"?>
-<p:sld xmlns:a="http://schemas.openxmlformats.org/drawingml/2006/main" xmlns:r="http://schemas.openxmlformats.org/officeDocument/2006/relationships" xmlns:mc="http://schemas.openxmlformats.org/markup-compatibility/2006" xmlns:mv="urn:schemas-microsoft-com:mac:vml" xmlns:p="http://schemas.openxmlformats.org/presentationml/2006/main" xmlns:c="http://schemas.openxmlformats.org/drawingml/2006/chart" xmlns:dgm="http://schemas.openxmlformats.org/drawingml/2006/diagram" xmlns:o="urn:schemas-microsoft-com:office:office" xmlns:v="urn:schemas-microsoft-com:vml" xmlns:pvml="urn:schemas-microsoft-com:office:powerpoint" xmlns:com="http://schemas.openxmlformats.org/drawingml/2006/compatibility" xmlns:p14="http://schemas.microsoft.com/office/powerpoint/2010/main" xmlns:p15="http://schemas.microsoft.com/office/powerpoint/2012/main" xmlns:ahyp="http://schemas.microsoft.com/office/drawing/2018/hyperlinkcolor">
-  <p:cSld>
-    <p:spTree>
-      <p:nvGrpSpPr>
-        <p:cNvPr id="131" name="Shape 131"/>
-        <p:cNvGrpSpPr/>
-        <p:nvPr/>
-      </p:nvGrpSpPr>
-      <p:grpSpPr>
-        <a:xfrm>
-          <a:off x="0" y="0"/>
-          <a:ext cx="0" cy="0"/>
-          <a:chOff x="0" y="0"/>
-          <a:chExt cx="0" cy="0"/>
-        </a:xfrm>
-      </p:grpSpPr>
-      <p:pic>
-        <p:nvPicPr>
-          <p:cNvPr id="132" name="Google Shape;132;p23" title="Frame 144.png"/>
-          <p:cNvPicPr preferRelativeResize="0"/>
-          <p:nvPr/>
-        </p:nvPicPr>
-        <p:blipFill rotWithShape="1">
-          <a:blip r:embed="rId3">
-            <a:alphaModFix/>
-          </a:blip>
-          <a:srcRect b="98001" l="0" r="0" t="0"/>
-          <a:stretch/>
-        </p:blipFill>
-        <p:spPr>
-          <a:xfrm>
-            <a:off x="0" y="5093562"/>
-            <a:ext cx="9144000" cy="54275"/>
-          </a:xfrm>
-          <a:prstGeom prst="rect">
-            <a:avLst/>
-          </a:prstGeom>
-          <a:noFill/>
-          <a:ln>
-            <a:noFill/>
-          </a:ln>
-        </p:spPr>
-      </p:pic>
-      <p:pic>
-        <p:nvPicPr>
-          <p:cNvPr id="133" name="Google Shape;133;p23" title="Group 427319979.png"/>
-          <p:cNvPicPr preferRelativeResize="0"/>
-          <p:nvPr/>
-        </p:nvPicPr>
-        <p:blipFill>
-          <a:blip r:embed="rId4">
-            <a:alphaModFix/>
-          </a:blip>
-          <a:stretch>
-            <a:fillRect/>
-          </a:stretch>
-        </p:blipFill>
-        <p:spPr>
-          <a:xfrm>
-            <a:off x="0" y="1"/>
-            <a:ext cx="9144000" cy="507359"/>
-          </a:xfrm>
-          <a:prstGeom prst="rect">
-            <a:avLst/>
-          </a:prstGeom>
-          <a:noFill/>
-          <a:ln>
-            <a:noFill/>
-          </a:ln>
-        </p:spPr>
-      </p:pic>
-      <p:sp>
-        <p:nvSpPr>
-          <p:cNvPr id="134" name="Google Shape;134;p23"/>
-          <p:cNvSpPr/>
-          <p:nvPr/>
-        </p:nvSpPr>
-        <p:spPr>
-          <a:xfrm>
-            <a:off x="-29250" y="5071875"/>
-            <a:ext cx="9173400" cy="97800"/>
-          </a:xfrm>
-          <a:prstGeom prst="rect">
-            <a:avLst/>
-          </a:prstGeom>
-          <a:solidFill>
-            <a:schemeClr val="dk1"/>
-          </a:solidFill>
-          <a:ln>
-            <a:noFill/>
-          </a:ln>
-        </p:spPr>
-        <p:txBody>
-          <a:bodyPr anchorCtr="0" anchor="ctr" bIns="91425" lIns="91425" spcFirstLastPara="1" rIns="91425" wrap="square" tIns="91425">
-            <a:noAutofit/>
-          </a:bodyPr>
-          <a:lstStyle/>
-          <a:p>
-            <a:pPr indent="0" lvl="0" marL="0" rtl="0" algn="ctr">
-              <a:spcBef>
-                <a:spcPts val="0"/>
-              </a:spcBef>
-              <a:spcAft>
-                <a:spcPts val="0"/>
-              </a:spcAft>
-              <a:buNone/>
-            </a:pPr>
-            <a:r>
-              <a:t/>
-            </a:r>
-            <a:endParaRPr/>
-          </a:p>
-        </p:txBody>
-      </p:sp>
-      <p:sp>
-        <p:nvSpPr>
-          <p:cNvPr id="135" name="Google Shape;135;p23"/>
-          <p:cNvSpPr txBox="1"/>
-          <p:nvPr/>
-        </p:nvSpPr>
-        <p:spPr>
-          <a:xfrm>
-            <a:off x="265350" y="663825"/>
-            <a:ext cx="8943000" cy="461900"/>
-          </a:xfrm>
-          <a:prstGeom prst="rect">
-            <a:avLst/>
-          </a:prstGeom>
-          <a:noFill/>
-          <a:ln>
-            <a:noFill/>
-          </a:ln>
-        </p:spPr>
-        <p:txBody>
-          <a:bodyPr anchorCtr="0" anchor="t" bIns="91425" lIns="91425" spcFirstLastPara="1" rIns="91425" wrap="square" tIns="91425">
-            <a:noAutofit/>
-          </a:bodyPr>
-          <a:lstStyle/>
-          <a:p>
-            <a:pPr marL="0" indent="0" algn="l">
-              <a:spcBef>
-                <a:spcPts val="0"/>
-              </a:spcBef>
-              <a:spcAft>
-                <a:spcPts val="0"/>
-              </a:spcAft>
-              <a:buNone/>
-            </a:pPr>
-            <a:r>
-              <a:rPr lang="en-GB" sz="1600" b="0" dirty="0">
-                <a:solidFill>
-                  <a:srgbClr val="000000"/>
-                </a:solidFill>
-                <a:latin typeface="Google Sans Flex Medium"/>
-                <a:ea typeface="Google Sans Flex Medium"/>
-                <a:cs typeface="Google Sans Flex Medium"/>
-                <a:sym typeface="Google Sans Flex Medium"/>
-              </a:rPr>
-              <a:t>Snapshots of the prototype (1/2)</a:t>
-            </a:r>
-            <a:endParaRPr lang="en-GB" sz="1600" dirty="0"/>
-          </a:p>
-        </p:txBody>
-      </p:sp>
-      <p:pic>
-        <p:nvPicPr>
-          <p:cNvPr id="1001" name="Command Center" descr="Command Center"/>
-          <p:cNvPicPr>
-            <a:picLocks noChangeAspect="1"/>
-          </p:cNvPicPr>
-          <p:nvPr/>
-        </p:nvPicPr>
-        <p:blipFill>
-          <a:blip r:embed="rId5"/>
-          <a:stretch>
-            <a:fillRect/>
-          </a:stretch>
-        </p:blipFill>
-        <p:spPr>
-          <a:xfrm>
-            <a:off x="365760" y="1188720"/>
-            <a:ext cx="2606040" cy="1628775"/>
-          </a:xfrm>
-          <a:prstGeom prst="roundRect">
-            <a:avLst>
-              <a:gd name="adj" fmla="val 2807"/>
-            </a:avLst>
-          </a:prstGeom>
-          <a:ln w="9525">
-            <a:solidFill>
-              <a:srgbClr val="DADCE0"/>
-            </a:solidFill>
-          </a:ln>
-          <a:effectLst>
-            <a:outerShdw blurRad="76200" dist="19050" dir="5400000" algn="t" rotWithShape="0">
-              <a:srgbClr val="000000">
-                <a:alpha val="16000"/>
-              </a:srgbClr>
-            </a:outerShdw>
-          </a:effectLst>
-        </p:spPr>
-      </p:pic>
-      <p:sp>
-        <p:nvSpPr>
-          <p:cNvPr id="1002" name="Command Center caption"/>
-          <p:cNvSpPr txBox="1"/>
-          <p:nvPr/>
-        </p:nvSpPr>
-        <p:spPr>
-          <a:xfrm>
-            <a:off x="3081528" y="1188720"/>
-            <a:ext cx="1417320" cy="1628775"/>
-          </a:xfrm>
-          <a:prstGeom prst="rect">
-            <a:avLst/>
-          </a:prstGeom>
-          <a:noFill/>
-          <a:ln>
-            <a:noFill/>
-          </a:ln>
-        </p:spPr>
-        <p:txBody>
-          <a:bodyPr wrap="square" lIns="0" tIns="0" rIns="0" bIns="0" anchor="ctr" rtlCol="0">
-            <a:noAutofit/>
-          </a:bodyPr>
-          <a:lstStyle/>
-          <a:p>
-            <a:pPr marL="0" indent="0" algn="l">
-              <a:spcBef>
-                <a:spcPts val="0"/>
-              </a:spcBef>
-              <a:spcAft>
-                <a:spcPts val="300"/>
-              </a:spcAft>
-              <a:buNone/>
-            </a:pPr>
-            <a:r>
-              <a:rPr lang="en-GB" sz="1200" b="0" dirty="0">
-                <a:solidFill>
-                  <a:srgbClr val="202124"/>
-                </a:solidFill>
-                <a:latin typeface="Google Sans Flex SemiBold"/>
-                <a:ea typeface="Google Sans Flex SemiBold"/>
-                <a:cs typeface="Google Sans Flex SemiBold"/>
-                <a:sym typeface="Google Sans Flex SemiBold"/>
-              </a:rPr>
-              <a:t>Command Center</a:t>
-            </a:r>
-            <a:endParaRPr lang="en-GB" sz="1200" dirty="0"/>
-          </a:p>
-          <a:p>
-            <a:pPr marL="0" indent="0" algn="l">
-              <a:lnSpc>
-                <a:spcPct val="105000"/>
-              </a:lnSpc>
-              <a:spcBef>
-                <a:spcPts val="0"/>
-              </a:spcBef>
-              <a:spcAft>
-                <a:spcPts val="0"/>
-              </a:spcAft>
-              <a:buNone/>
-            </a:pPr>
-            <a:r>
-              <a:rPr lang="en-GB" sz="1050" b="0" dirty="0">
-                <a:solidFill>
-                  <a:srgbClr val="5F6368"/>
-                </a:solidFill>
-                <a:latin typeface="Google Sans Flex"/>
-                <a:ea typeface="Google Sans Flex"/>
-                <a:cs typeface="Google Sans Flex"/>
-                <a:sym typeface="Google Sans Flex"/>
-              </a:rPr>
-              <a:t>The whole plant on one screen during the crisis, with the guided demo panel.</a:t>
-            </a:r>
-            <a:endParaRPr lang="en-GB" sz="1050" dirty="0"/>
-          </a:p>
-        </p:txBody>
-      </p:sp>
-      <p:pic>
-        <p:nvPicPr>
-          <p:cNvPr id="1003" name="AI Operations" descr="AI Operations"/>
-          <p:cNvPicPr>
-            <a:picLocks noChangeAspect="1"/>
-          </p:cNvPicPr>
-          <p:nvPr/>
-        </p:nvPicPr>
-        <p:blipFill>
-          <a:blip r:embed="rId6"/>
-          <a:stretch>
-            <a:fillRect/>
-          </a:stretch>
-        </p:blipFill>
-        <p:spPr>
-          <a:xfrm>
-            <a:off x="4645152" y="1188720"/>
-            <a:ext cx="2606040" cy="1628775"/>
-          </a:xfrm>
-          <a:prstGeom prst="roundRect">
-            <a:avLst>
-              <a:gd name="adj" fmla="val 2807"/>
-            </a:avLst>
-          </a:prstGeom>
-          <a:ln w="9525">
-            <a:solidFill>
-              <a:srgbClr val="DADCE0"/>
-            </a:solidFill>
-          </a:ln>
-          <a:effectLst>
-            <a:outerShdw blurRad="76200" dist="19050" dir="5400000" algn="t" rotWithShape="0">
-              <a:srgbClr val="000000">
-                <a:alpha val="16000"/>
-              </a:srgbClr>
-            </a:outerShdw>
-          </a:effectLst>
-        </p:spPr>
-      </p:pic>
-      <p:sp>
-        <p:nvSpPr>
-          <p:cNvPr id="1004" name="AI Operations caption"/>
-          <p:cNvSpPr txBox="1"/>
-          <p:nvPr/>
-        </p:nvSpPr>
-        <p:spPr>
-          <a:xfrm>
-            <a:off x="7360920" y="1188720"/>
-            <a:ext cx="1417320" cy="1628775"/>
-          </a:xfrm>
-          <a:prstGeom prst="rect">
-            <a:avLst/>
-          </a:prstGeom>
-          <a:noFill/>
-          <a:ln>
-            <a:noFill/>
-          </a:ln>
-        </p:spPr>
-        <p:txBody>
-          <a:bodyPr wrap="square" lIns="0" tIns="0" rIns="0" bIns="0" anchor="ctr" rtlCol="0">
-            <a:noAutofit/>
-          </a:bodyPr>
-          <a:lstStyle/>
-          <a:p>
-            <a:pPr marL="0" indent="0" algn="l">
-              <a:spcBef>
-                <a:spcPts val="0"/>
-              </a:spcBef>
-              <a:spcAft>
-                <a:spcPts val="300"/>
-              </a:spcAft>
-              <a:buNone/>
-            </a:pPr>
-            <a:r>
-              <a:rPr lang="en-GB" sz="1200" b="0" dirty="0">
-                <a:solidFill>
-                  <a:srgbClr val="202124"/>
-                </a:solidFill>
-                <a:latin typeface="Google Sans Flex SemiBold"/>
-                <a:ea typeface="Google Sans Flex SemiBold"/>
-                <a:cs typeface="Google Sans Flex SemiBold"/>
-                <a:sym typeface="Google Sans Flex SemiBold"/>
-              </a:rPr>
-              <a:t>AI Operations</a:t>
-            </a:r>
-            <a:endParaRPr lang="en-GB" sz="1200" dirty="0"/>
-          </a:p>
-          <a:p>
-            <a:pPr marL="0" indent="0" algn="l">
-              <a:lnSpc>
-                <a:spcPct val="105000"/>
-              </a:lnSpc>
-              <a:spcBef>
-                <a:spcPts val="0"/>
-              </a:spcBef>
-              <a:spcAft>
-                <a:spcPts val="0"/>
-              </a:spcAft>
-              <a:buNone/>
-            </a:pPr>
-            <a:r>
-              <a:rPr lang="en-GB" sz="1050" b="0" dirty="0">
-                <a:solidFill>
-                  <a:srgbClr val="5F6368"/>
-                </a:solidFill>
-                <a:latin typeface="Google Sans Flex"/>
-                <a:ea typeface="Google Sans Flex"/>
-                <a:cs typeface="Google Sans Flex"/>
-                <a:sym typeface="Google Sans Flex"/>
-              </a:rPr>
-              <a:t>Six agents stream findings; a trip is predicted about 16 hours ahead.</a:t>
-            </a:r>
-            <a:endParaRPr lang="en-GB" sz="1050" dirty="0"/>
-          </a:p>
-        </p:txBody>
-      </p:sp>
-      <p:pic>
-        <p:nvPicPr>
-          <p:cNvPr id="1005" name="What-If Simulator" descr="What-If Simulator"/>
-          <p:cNvPicPr>
-            <a:picLocks noChangeAspect="1"/>
-          </p:cNvPicPr>
-          <p:nvPr/>
-        </p:nvPicPr>
-        <p:blipFill>
-          <a:blip r:embed="rId7"/>
-          <a:stretch>
-            <a:fillRect/>
-          </a:stretch>
-        </p:blipFill>
-        <p:spPr>
-          <a:xfrm>
-            <a:off x="365760" y="3073527"/>
-            <a:ext cx="2606040" cy="1628775"/>
-          </a:xfrm>
-          <a:prstGeom prst="roundRect">
-            <a:avLst>
-              <a:gd name="adj" fmla="val 2807"/>
-            </a:avLst>
-          </a:prstGeom>
-          <a:ln w="9525">
-            <a:solidFill>
-              <a:srgbClr val="DADCE0"/>
-            </a:solidFill>
-          </a:ln>
-          <a:effectLst>
-            <a:outerShdw blurRad="76200" dist="19050" dir="5400000" algn="t" rotWithShape="0">
-              <a:srgbClr val="000000">
-                <a:alpha val="16000"/>
-              </a:srgbClr>
-            </a:outerShdw>
-          </a:effectLst>
-        </p:spPr>
-      </p:pic>
-      <p:sp>
-        <p:nvSpPr>
-          <p:cNvPr id="1006" name="What-If Simulator caption"/>
-          <p:cNvSpPr txBox="1"/>
-          <p:nvPr/>
-        </p:nvSpPr>
-        <p:spPr>
-          <a:xfrm>
-            <a:off x="3081528" y="3073527"/>
-            <a:ext cx="1417320" cy="1628775"/>
-          </a:xfrm>
-          <a:prstGeom prst="rect">
-            <a:avLst/>
-          </a:prstGeom>
-          <a:noFill/>
-          <a:ln>
-            <a:noFill/>
-          </a:ln>
-        </p:spPr>
-        <p:txBody>
-          <a:bodyPr wrap="square" lIns="0" tIns="0" rIns="0" bIns="0" anchor="ctr" rtlCol="0">
-            <a:noAutofit/>
-          </a:bodyPr>
-          <a:lstStyle/>
-          <a:p>
-            <a:pPr marL="0" indent="0" algn="l">
-              <a:spcBef>
-                <a:spcPts val="0"/>
-              </a:spcBef>
-              <a:spcAft>
-                <a:spcPts val="300"/>
-              </a:spcAft>
-              <a:buNone/>
-            </a:pPr>
-            <a:r>
-              <a:rPr lang="en-GB" sz="1200" b="0" dirty="0">
-                <a:solidFill>
-                  <a:srgbClr val="202124"/>
-                </a:solidFill>
-                <a:latin typeface="Google Sans Flex SemiBold"/>
-                <a:ea typeface="Google Sans Flex SemiBold"/>
-                <a:cs typeface="Google Sans Flex SemiBold"/>
-                <a:sym typeface="Google Sans Flex SemiBold"/>
-              </a:rPr>
-              <a:t>What-If Simulator</a:t>
-            </a:r>
-            <a:endParaRPr lang="en-GB" sz="1200" dirty="0"/>
-          </a:p>
-          <a:p>
-            <a:pPr marL="0" indent="0" algn="l">
-              <a:lnSpc>
-                <a:spcPct val="105000"/>
-              </a:lnSpc>
-              <a:spcBef>
-                <a:spcPts val="0"/>
-              </a:spcBef>
-              <a:spcAft>
-                <a:spcPts val="0"/>
-              </a:spcAft>
-              <a:buNone/>
-            </a:pPr>
-            <a:r>
-              <a:rPr lang="en-GB" sz="1050" b="0" dirty="0">
-                <a:solidFill>
-                  <a:srgbClr val="5F6368"/>
-                </a:solidFill>
-                <a:latin typeface="Google Sans Flex"/>
-                <a:ea typeface="Google Sans Flex"/>
-                <a:cs typeface="Google Sans Flex"/>
-                <a:sym typeface="Google Sans Flex"/>
-              </a:rPr>
-              <a:t>Four plans compared; reroute to Line B + maintain scores 82.2 with no late units.</a:t>
-            </a:r>
-            <a:endParaRPr lang="en-GB" sz="1050" dirty="0"/>
-          </a:p>
-        </p:txBody>
-      </p:sp>
-      <p:pic>
-        <p:nvPicPr>
-          <p:cNvPr id="1007" name="Digital Twin in 3D" descr="Digital Twin in 3D"/>
-          <p:cNvPicPr>
-            <a:picLocks noChangeAspect="1"/>
-          </p:cNvPicPr>
-          <p:nvPr/>
-        </p:nvPicPr>
-        <p:blipFill>
-          <a:blip r:embed="rId8"/>
-          <a:stretch>
-            <a:fillRect/>
-          </a:stretch>
-        </p:blipFill>
-        <p:spPr>
-          <a:xfrm>
-            <a:off x="4645152" y="3073527"/>
-            <a:ext cx="2606040" cy="1628775"/>
-          </a:xfrm>
-          <a:prstGeom prst="roundRect">
-            <a:avLst>
-              <a:gd name="adj" fmla="val 2807"/>
-            </a:avLst>
-          </a:prstGeom>
-          <a:ln w="9525">
-            <a:solidFill>
-              <a:srgbClr val="DADCE0"/>
-            </a:solidFill>
-          </a:ln>
-          <a:effectLst>
-            <a:outerShdw blurRad="76200" dist="19050" dir="5400000" algn="t" rotWithShape="0">
-              <a:srgbClr val="000000">
-                <a:alpha val="16000"/>
-              </a:srgbClr>
-            </a:outerShdw>
-          </a:effectLst>
-        </p:spPr>
-      </p:pic>
-      <p:sp>
-        <p:nvSpPr>
-          <p:cNvPr id="1008" name="Digital Twin in 3D caption"/>
-          <p:cNvSpPr txBox="1"/>
-          <p:nvPr/>
-        </p:nvSpPr>
-        <p:spPr>
-          <a:xfrm>
-            <a:off x="7360920" y="3073527"/>
-            <a:ext cx="1417320" cy="1628775"/>
-          </a:xfrm>
-          <a:prstGeom prst="rect">
-            <a:avLst/>
-          </a:prstGeom>
-          <a:noFill/>
-          <a:ln>
-            <a:noFill/>
-          </a:ln>
-        </p:spPr>
-        <p:txBody>
-          <a:bodyPr wrap="square" lIns="0" tIns="0" rIns="0" bIns="0" anchor="ctr" rtlCol="0">
-            <a:noAutofit/>
-          </a:bodyPr>
-          <a:lstStyle/>
-          <a:p>
-            <a:pPr marL="0" indent="0" algn="l">
-              <a:spcBef>
-                <a:spcPts val="0"/>
-              </a:spcBef>
-              <a:spcAft>
-                <a:spcPts val="300"/>
-              </a:spcAft>
-              <a:buNone/>
-            </a:pPr>
-            <a:r>
-              <a:rPr lang="en-GB" sz="1200" b="0" dirty="0">
-                <a:solidFill>
-                  <a:srgbClr val="202124"/>
-                </a:solidFill>
-                <a:latin typeface="Google Sans Flex SemiBold"/>
-                <a:ea typeface="Google Sans Flex SemiBold"/>
-                <a:cs typeface="Google Sans Flex SemiBold"/>
-                <a:sym typeface="Google Sans Flex SemiBold"/>
-              </a:rPr>
-              <a:t>Digital Twin in 3D</a:t>
-            </a:r>
-            <a:endParaRPr lang="en-GB" sz="1200" dirty="0"/>
-          </a:p>
-          <a:p>
-            <a:pPr marL="0" indent="0" algn="l">
-              <a:lnSpc>
-                <a:spcPct val="105000"/>
-              </a:lnSpc>
-              <a:spcBef>
-                <a:spcPts val="0"/>
-              </a:spcBef>
-              <a:spcAft>
-                <a:spcPts val="0"/>
-              </a:spcAft>
-              <a:buNone/>
-            </a:pPr>
-            <a:r>
-              <a:rPr lang="en-GB" sz="1050" b="0" dirty="0">
-                <a:solidFill>
-                  <a:srgbClr val="5F6368"/>
-                </a:solidFill>
-                <a:latin typeface="Google Sans Flex"/>
-                <a:ea typeface="Google Sans Flex"/>
-                <a:cs typeface="Google Sans Flex"/>
-                <a:sym typeface="Google Sans Flex"/>
-              </a:rPr>
-              <a:t>Orbit the live plant; robots animate and the recommended path is highlighted.</a:t>
-            </a:r>
-            <a:endParaRPr lang="en-GB" sz="1050" dirty="0"/>
-          </a:p>
-        </p:txBody>
-      </p:sp>
-    </p:spTree>
-  </p:cSld>
-  <p:clrMapOvr>
-    <a:masterClrMapping/>
-  </p:clrMapOvr>
-</p:sld>
-</file>
-
-<file path=ppt/slides/slide12.xml><?xml version="1.0" encoding="utf-8"?>
+<file path=ppt/slides/slide10.xml><?xml version="1.0" encoding="utf-8"?>
 <p:sld xmlns:a="http://schemas.openxmlformats.org/drawingml/2006/main" xmlns:r="http://schemas.openxmlformats.org/officeDocument/2006/relationships" xmlns:mc="http://schemas.openxmlformats.org/markup-compatibility/2006" xmlns:mv="urn:schemas-microsoft-com:mac:vml" xmlns:p="http://schemas.openxmlformats.org/presentationml/2006/main" xmlns:c="http://schemas.openxmlformats.org/drawingml/2006/chart" xmlns:dgm="http://schemas.openxmlformats.org/drawingml/2006/diagram" xmlns:o="urn:schemas-microsoft-com:office:office" xmlns:v="urn:schemas-microsoft-com:vml" xmlns:pvml="urn:schemas-microsoft-com:office:powerpoint" xmlns:com="http://schemas.openxmlformats.org/drawingml/2006/compatibility" xmlns:p14="http://schemas.microsoft.com/office/powerpoint/2010/main" xmlns:p15="http://schemas.microsoft.com/office/powerpoint/2012/main" xmlns:ahyp="http://schemas.microsoft.com/office/drawing/2018/hyperlinkcolor">
   <p:cSld>
     <p:spTree>
@@ -10162,7 +9529,7 @@
 </p:sld>
 </file>
 
-<file path=ppt/slides/slide13.xml><?xml version="1.0" encoding="utf-8"?>
+<file path=ppt/slides/slide11.xml><?xml version="1.0" encoding="utf-8"?>
 <p:sld xmlns:a="http://schemas.openxmlformats.org/drawingml/2006/main" xmlns:r="http://schemas.openxmlformats.org/officeDocument/2006/relationships" xmlns:mc="http://schemas.openxmlformats.org/markup-compatibility/2006" xmlns:mv="urn:schemas-microsoft-com:mac:vml" xmlns:p="http://schemas.openxmlformats.org/presentationml/2006/main" xmlns:c="http://schemas.openxmlformats.org/drawingml/2006/chart" xmlns:dgm="http://schemas.openxmlformats.org/drawingml/2006/diagram" xmlns:o="urn:schemas-microsoft-com:office:office" xmlns:v="urn:schemas-microsoft-com:vml" xmlns:pvml="urn:schemas-microsoft-com:office:powerpoint" xmlns:com="http://schemas.openxmlformats.org/drawingml/2006/compatibility" xmlns:p14="http://schemas.microsoft.com/office/powerpoint/2010/main" xmlns:p15="http://schemas.microsoft.com/office/powerpoint/2012/main" xmlns:ahyp="http://schemas.microsoft.com/office/drawing/2018/hyperlinkcolor">
   <p:cSld>
     <p:spTree>
@@ -11469,7 +10836,7 @@
 </p:sld>
 </file>
 
-<file path=ppt/slides/slide14.xml><?xml version="1.0" encoding="utf-8"?>
+<file path=ppt/slides/slide12.xml><?xml version="1.0" encoding="utf-8"?>
 <p:sld xmlns:a="http://schemas.openxmlformats.org/drawingml/2006/main" xmlns:r="http://schemas.openxmlformats.org/officeDocument/2006/relationships" xmlns:mc="http://schemas.openxmlformats.org/markup-compatibility/2006" xmlns:mv="urn:schemas-microsoft-com:mac:vml" xmlns:p="http://schemas.openxmlformats.org/presentationml/2006/main" xmlns:c="http://schemas.openxmlformats.org/drawingml/2006/chart" xmlns:dgm="http://schemas.openxmlformats.org/drawingml/2006/diagram" xmlns:o="urn:schemas-microsoft-com:office:office" xmlns:v="urn:schemas-microsoft-com:vml" xmlns:pvml="urn:schemas-microsoft-com:office:powerpoint" xmlns:com="http://schemas.openxmlformats.org/drawingml/2006/compatibility" xmlns:p14="http://schemas.microsoft.com/office/powerpoint/2010/main" xmlns:p15="http://schemas.microsoft.com/office/powerpoint/2012/main" xmlns:ahyp="http://schemas.microsoft.com/office/drawing/2018/hyperlinkcolor">
   <p:cSld>
     <p:spTree>
@@ -12211,7 +11578,7 @@
 </p:sld>
 </file>
 
-<file path=ppt/slides/slide16.xml><?xml version="1.0" encoding="utf-8"?>
+<file path=ppt/slides/slide13.xml><?xml version="1.0" encoding="utf-8"?>
 <p:sld xmlns:a="http://schemas.openxmlformats.org/drawingml/2006/main" xmlns:r="http://schemas.openxmlformats.org/officeDocument/2006/relationships" xmlns:mc="http://schemas.openxmlformats.org/markup-compatibility/2006" xmlns:mv="urn:schemas-microsoft-com:mac:vml" xmlns:p="http://schemas.openxmlformats.org/presentationml/2006/main" xmlns:c="http://schemas.openxmlformats.org/drawingml/2006/chart" xmlns:dgm="http://schemas.openxmlformats.org/drawingml/2006/diagram" xmlns:o="urn:schemas-microsoft-com:office:office" xmlns:v="urn:schemas-microsoft-com:vml" xmlns:pvml="urn:schemas-microsoft-com:office:powerpoint" xmlns:com="http://schemas.openxmlformats.org/drawingml/2006/compatibility" xmlns:p14="http://schemas.microsoft.com/office/powerpoint/2010/main" xmlns:p15="http://schemas.microsoft.com/office/powerpoint/2012/main" xmlns:ahyp="http://schemas.microsoft.com/office/drawing/2018/hyperlinkcolor">
   <p:cSld>
     <p:spTree>
@@ -12291,640 +11658,7 @@
 </p:sld>
 </file>
 
-<file path=ppt/slides/slide17.xml><?xml version="1.0" encoding="utf-8"?>
-<p:sld xmlns:a="http://schemas.openxmlformats.org/drawingml/2006/main" xmlns:r="http://schemas.openxmlformats.org/officeDocument/2006/relationships" xmlns:mc="http://schemas.openxmlformats.org/markup-compatibility/2006" xmlns:mv="urn:schemas-microsoft-com:mac:vml" xmlns:p="http://schemas.openxmlformats.org/presentationml/2006/main" xmlns:c="http://schemas.openxmlformats.org/drawingml/2006/chart" xmlns:dgm="http://schemas.openxmlformats.org/drawingml/2006/diagram" xmlns:o="urn:schemas-microsoft-com:office:office" xmlns:v="urn:schemas-microsoft-com:vml" xmlns:pvml="urn:schemas-microsoft-com:office:powerpoint" xmlns:com="http://schemas.openxmlformats.org/drawingml/2006/compatibility" xmlns:p14="http://schemas.microsoft.com/office/powerpoint/2010/main" xmlns:p15="http://schemas.microsoft.com/office/powerpoint/2012/main" xmlns:ahyp="http://schemas.microsoft.com/office/drawing/2018/hyperlinkcolor">
-  <p:cSld>
-    <p:spTree>
-      <p:nvGrpSpPr>
-        <p:cNvPr id="131" name="Shape 131"/>
-        <p:cNvGrpSpPr/>
-        <p:nvPr/>
-      </p:nvGrpSpPr>
-      <p:grpSpPr>
-        <a:xfrm>
-          <a:off x="0" y="0"/>
-          <a:ext cx="0" cy="0"/>
-          <a:chOff x="0" y="0"/>
-          <a:chExt cx="0" cy="0"/>
-        </a:xfrm>
-      </p:grpSpPr>
-      <p:pic>
-        <p:nvPicPr>
-          <p:cNvPr id="132" name="Google Shape;132;p23" title="Frame 144.png"/>
-          <p:cNvPicPr preferRelativeResize="0"/>
-          <p:nvPr/>
-        </p:nvPicPr>
-        <p:blipFill rotWithShape="1">
-          <a:blip r:embed="rId3">
-            <a:alphaModFix/>
-          </a:blip>
-          <a:srcRect b="98001" l="0" r="0" t="0"/>
-          <a:stretch/>
-        </p:blipFill>
-        <p:spPr>
-          <a:xfrm>
-            <a:off x="0" y="5093562"/>
-            <a:ext cx="9144000" cy="54275"/>
-          </a:xfrm>
-          <a:prstGeom prst="rect">
-            <a:avLst/>
-          </a:prstGeom>
-          <a:noFill/>
-          <a:ln>
-            <a:noFill/>
-          </a:ln>
-        </p:spPr>
-      </p:pic>
-      <p:pic>
-        <p:nvPicPr>
-          <p:cNvPr id="133" name="Google Shape;133;p23" title="Group 427319979.png"/>
-          <p:cNvPicPr preferRelativeResize="0"/>
-          <p:nvPr/>
-        </p:nvPicPr>
-        <p:blipFill>
-          <a:blip r:embed="rId4">
-            <a:alphaModFix/>
-          </a:blip>
-          <a:stretch>
-            <a:fillRect/>
-          </a:stretch>
-        </p:blipFill>
-        <p:spPr>
-          <a:xfrm>
-            <a:off x="0" y="1"/>
-            <a:ext cx="9144000" cy="507359"/>
-          </a:xfrm>
-          <a:prstGeom prst="rect">
-            <a:avLst/>
-          </a:prstGeom>
-          <a:noFill/>
-          <a:ln>
-            <a:noFill/>
-          </a:ln>
-        </p:spPr>
-      </p:pic>
-      <p:sp>
-        <p:nvSpPr>
-          <p:cNvPr id="134" name="Google Shape;134;p23"/>
-          <p:cNvSpPr/>
-          <p:nvPr/>
-        </p:nvSpPr>
-        <p:spPr>
-          <a:xfrm>
-            <a:off x="-29250" y="5071875"/>
-            <a:ext cx="9173400" cy="97800"/>
-          </a:xfrm>
-          <a:prstGeom prst="rect">
-            <a:avLst/>
-          </a:prstGeom>
-          <a:solidFill>
-            <a:schemeClr val="dk1"/>
-          </a:solidFill>
-          <a:ln>
-            <a:noFill/>
-          </a:ln>
-        </p:spPr>
-        <p:txBody>
-          <a:bodyPr anchorCtr="0" anchor="ctr" bIns="91425" lIns="91425" spcFirstLastPara="1" rIns="91425" wrap="square" tIns="91425">
-            <a:noAutofit/>
-          </a:bodyPr>
-          <a:lstStyle/>
-          <a:p>
-            <a:pPr indent="0" lvl="0" marL="0" rtl="0" algn="ctr">
-              <a:spcBef>
-                <a:spcPts val="0"/>
-              </a:spcBef>
-              <a:spcAft>
-                <a:spcPts val="0"/>
-              </a:spcAft>
-              <a:buNone/>
-            </a:pPr>
-            <a:r>
-              <a:t/>
-            </a:r>
-            <a:endParaRPr/>
-          </a:p>
-        </p:txBody>
-      </p:sp>
-      <p:sp>
-        <p:nvSpPr>
-          <p:cNvPr id="135" name="Google Shape;135;p23"/>
-          <p:cNvSpPr txBox="1"/>
-          <p:nvPr/>
-        </p:nvSpPr>
-        <p:spPr>
-          <a:xfrm>
-            <a:off x="265350" y="663825"/>
-            <a:ext cx="8943000" cy="461900"/>
-          </a:xfrm>
-          <a:prstGeom prst="rect">
-            <a:avLst/>
-          </a:prstGeom>
-          <a:noFill/>
-          <a:ln>
-            <a:noFill/>
-          </a:ln>
-        </p:spPr>
-        <p:txBody>
-          <a:bodyPr anchorCtr="0" anchor="t" bIns="91425" lIns="91425" spcFirstLastPara="1" rIns="91425" wrap="square" tIns="91425">
-            <a:noAutofit/>
-          </a:bodyPr>
-          <a:lstStyle/>
-          <a:p>
-            <a:pPr marL="0" indent="0" algn="l">
-              <a:spcBef>
-                <a:spcPts val="0"/>
-              </a:spcBef>
-              <a:spcAft>
-                <a:spcPts val="0"/>
-              </a:spcAft>
-              <a:buNone/>
-            </a:pPr>
-            <a:r>
-              <a:rPr lang="en-GB" sz="1600" b="0" dirty="0">
-                <a:solidFill>
-                  <a:srgbClr val="000000"/>
-                </a:solidFill>
-                <a:latin typeface="Google Sans Flex Medium"/>
-                <a:ea typeface="Google Sans Flex Medium"/>
-                <a:cs typeface="Google Sans Flex Medium"/>
-                <a:sym typeface="Google Sans Flex Medium"/>
-              </a:rPr>
-              <a:t>Snapshots of the prototype (2/2)</a:t>
-            </a:r>
-            <a:endParaRPr lang="en-GB" sz="1600" dirty="0"/>
-          </a:p>
-        </p:txBody>
-      </p:sp>
-      <p:pic>
-        <p:nvPicPr>
-          <p:cNvPr id="1001" name="Approvals" descr="Approvals"/>
-          <p:cNvPicPr>
-            <a:picLocks noChangeAspect="1"/>
-          </p:cNvPicPr>
-          <p:nvPr/>
-        </p:nvPicPr>
-        <p:blipFill>
-          <a:blip r:embed="rId5"/>
-          <a:stretch>
-            <a:fillRect/>
-          </a:stretch>
-        </p:blipFill>
-        <p:spPr>
-          <a:xfrm>
-            <a:off x="365760" y="1188720"/>
-            <a:ext cx="2606040" cy="1628775"/>
-          </a:xfrm>
-          <a:prstGeom prst="roundRect">
-            <a:avLst>
-              <a:gd name="adj" fmla="val 2807"/>
-            </a:avLst>
-          </a:prstGeom>
-          <a:ln w="9525">
-            <a:solidFill>
-              <a:srgbClr val="DADCE0"/>
-            </a:solidFill>
-          </a:ln>
-          <a:effectLst>
-            <a:outerShdw blurRad="76200" dist="19050" dir="5400000" algn="t" rotWithShape="0">
-              <a:srgbClr val="000000">
-                <a:alpha val="16000"/>
-              </a:srgbClr>
-            </a:outerShdw>
-          </a:effectLst>
-        </p:spPr>
-      </p:pic>
-      <p:sp>
-        <p:nvSpPr>
-          <p:cNvPr id="1002" name="Approvals caption"/>
-          <p:cNvSpPr txBox="1"/>
-          <p:nvPr/>
-        </p:nvSpPr>
-        <p:spPr>
-          <a:xfrm>
-            <a:off x="3081528" y="1188720"/>
-            <a:ext cx="1417320" cy="1628775"/>
-          </a:xfrm>
-          <a:prstGeom prst="rect">
-            <a:avLst/>
-          </a:prstGeom>
-          <a:noFill/>
-          <a:ln>
-            <a:noFill/>
-          </a:ln>
-        </p:spPr>
-        <p:txBody>
-          <a:bodyPr wrap="square" lIns="0" tIns="0" rIns="0" bIns="0" anchor="ctr" rtlCol="0">
-            <a:noAutofit/>
-          </a:bodyPr>
-          <a:lstStyle/>
-          <a:p>
-            <a:pPr marL="0" indent="0" algn="l">
-              <a:spcBef>
-                <a:spcPts val="0"/>
-              </a:spcBef>
-              <a:spcAft>
-                <a:spcPts val="300"/>
-              </a:spcAft>
-              <a:buNone/>
-            </a:pPr>
-            <a:r>
-              <a:rPr lang="en-GB" sz="1200" b="0" dirty="0">
-                <a:solidFill>
-                  <a:srgbClr val="202124"/>
-                </a:solidFill>
-                <a:latin typeface="Google Sans Flex SemiBold"/>
-                <a:ea typeface="Google Sans Flex SemiBold"/>
-                <a:cs typeface="Google Sans Flex SemiBold"/>
-                <a:sym typeface="Google Sans Flex SemiBold"/>
-              </a:rPr>
-              <a:t>Approvals</a:t>
-            </a:r>
-            <a:endParaRPr lang="en-GB" sz="1200" dirty="0"/>
-          </a:p>
-          <a:p>
-            <a:pPr marL="0" indent="0" algn="l">
-              <a:lnSpc>
-                <a:spcPct val="105000"/>
-              </a:lnSpc>
-              <a:spcBef>
-                <a:spcPts val="0"/>
-              </a:spcBef>
-              <a:spcAft>
-                <a:spcPts val="0"/>
-              </a:spcAft>
-              <a:buNone/>
-            </a:pPr>
-            <a:r>
-              <a:rPr lang="en-GB" sz="1050" b="0" dirty="0">
-                <a:solidFill>
-                  <a:srgbClr val="5F6368"/>
-                </a:solidFill>
-                <a:latin typeface="Google Sans Flex"/>
-                <a:ea typeface="Google Sans Flex"/>
-                <a:cs typeface="Google Sans Flex"/>
-                <a:sym typeface="Google Sans Flex"/>
-              </a:rPr>
-              <a:t>The approved plan ran: Line B took over and the failing robot is healthy again.</a:t>
-            </a:r>
-            <a:endParaRPr lang="en-GB" sz="1050" dirty="0"/>
-          </a:p>
-        </p:txBody>
-      </p:sp>
-      <p:pic>
-        <p:nvPicPr>
-          <p:cNvPr id="1003" name="Visual Quality" descr="Visual Quality"/>
-          <p:cNvPicPr>
-            <a:picLocks noChangeAspect="1"/>
-          </p:cNvPicPr>
-          <p:nvPr/>
-        </p:nvPicPr>
-        <p:blipFill>
-          <a:blip r:embed="rId6"/>
-          <a:stretch>
-            <a:fillRect/>
-          </a:stretch>
-        </p:blipFill>
-        <p:spPr>
-          <a:xfrm>
-            <a:off x="4645152" y="1188720"/>
-            <a:ext cx="2606040" cy="1628775"/>
-          </a:xfrm>
-          <a:prstGeom prst="roundRect">
-            <a:avLst>
-              <a:gd name="adj" fmla="val 2807"/>
-            </a:avLst>
-          </a:prstGeom>
-          <a:ln w="9525">
-            <a:solidFill>
-              <a:srgbClr val="DADCE0"/>
-            </a:solidFill>
-          </a:ln>
-          <a:effectLst>
-            <a:outerShdw blurRad="76200" dist="19050" dir="5400000" algn="t" rotWithShape="0">
-              <a:srgbClr val="000000">
-                <a:alpha val="16000"/>
-              </a:srgbClr>
-            </a:outerShdw>
-          </a:effectLst>
-        </p:spPr>
-      </p:pic>
-      <p:sp>
-        <p:nvSpPr>
-          <p:cNvPr id="1004" name="Visual Quality caption"/>
-          <p:cNvSpPr txBox="1"/>
-          <p:nvPr/>
-        </p:nvSpPr>
-        <p:spPr>
-          <a:xfrm>
-            <a:off x="7360920" y="1188720"/>
-            <a:ext cx="1417320" cy="1628775"/>
-          </a:xfrm>
-          <a:prstGeom prst="rect">
-            <a:avLst/>
-          </a:prstGeom>
-          <a:noFill/>
-          <a:ln>
-            <a:noFill/>
-          </a:ln>
-        </p:spPr>
-        <p:txBody>
-          <a:bodyPr wrap="square" lIns="0" tIns="0" rIns="0" bIns="0" anchor="ctr" rtlCol="0">
-            <a:noAutofit/>
-          </a:bodyPr>
-          <a:lstStyle/>
-          <a:p>
-            <a:pPr marL="0" indent="0" algn="l">
-              <a:spcBef>
-                <a:spcPts val="0"/>
-              </a:spcBef>
-              <a:spcAft>
-                <a:spcPts val="300"/>
-              </a:spcAft>
-              <a:buNone/>
-            </a:pPr>
-            <a:r>
-              <a:rPr lang="en-GB" sz="1200" b="0" dirty="0">
-                <a:solidFill>
-                  <a:srgbClr val="202124"/>
-                </a:solidFill>
-                <a:latin typeface="Google Sans Flex SemiBold"/>
-                <a:ea typeface="Google Sans Flex SemiBold"/>
-                <a:cs typeface="Google Sans Flex SemiBold"/>
-                <a:sym typeface="Google Sans Flex SemiBold"/>
-              </a:rPr>
-              <a:t>Visual Quality</a:t>
-            </a:r>
-            <a:endParaRPr lang="en-GB" sz="1200" dirty="0"/>
-          </a:p>
-          <a:p>
-            <a:pPr marL="0" indent="0" algn="l">
-              <a:lnSpc>
-                <a:spcPct val="105000"/>
-              </a:lnSpc>
-              <a:spcBef>
-                <a:spcPts val="0"/>
-              </a:spcBef>
-              <a:spcAft>
-                <a:spcPts val="0"/>
-              </a:spcAft>
-              <a:buNone/>
-            </a:pPr>
-            <a:r>
-              <a:rPr lang="en-GB" sz="1050" b="0" dirty="0">
-                <a:solidFill>
-                  <a:srgbClr val="5F6368"/>
-                </a:solidFill>
-                <a:latin typeface="Google Sans Flex"/>
-                <a:ea typeface="Google Sans Flex"/>
-                <a:cs typeface="Google Sans Flex"/>
-                <a:sym typeface="Google Sans Flex"/>
-              </a:rPr>
-              <a:t>FPY, DPMO and defect Pareto; robot vibration tracks Line A rejects (r = 0.89).</a:t>
-            </a:r>
-            <a:endParaRPr lang="en-GB" sz="1050" dirty="0"/>
-          </a:p>
-        </p:txBody>
-      </p:sp>
-      <p:pic>
-        <p:nvPicPr>
-          <p:cNvPr id="1005" name="Twin Builder" descr="Twin Builder"/>
-          <p:cNvPicPr>
-            <a:picLocks noChangeAspect="1"/>
-          </p:cNvPicPr>
-          <p:nvPr/>
-        </p:nvPicPr>
-        <p:blipFill>
-          <a:blip r:embed="rId7"/>
-          <a:stretch>
-            <a:fillRect/>
-          </a:stretch>
-        </p:blipFill>
-        <p:spPr>
-          <a:xfrm>
-            <a:off x="365760" y="3073527"/>
-            <a:ext cx="2606040" cy="1628775"/>
-          </a:xfrm>
-          <a:prstGeom prst="roundRect">
-            <a:avLst>
-              <a:gd name="adj" fmla="val 2807"/>
-            </a:avLst>
-          </a:prstGeom>
-          <a:ln w="9525">
-            <a:solidFill>
-              <a:srgbClr val="DADCE0"/>
-            </a:solidFill>
-          </a:ln>
-          <a:effectLst>
-            <a:outerShdw blurRad="76200" dist="19050" dir="5400000" algn="t" rotWithShape="0">
-              <a:srgbClr val="000000">
-                <a:alpha val="16000"/>
-              </a:srgbClr>
-            </a:outerShdw>
-          </a:effectLst>
-        </p:spPr>
-      </p:pic>
-      <p:sp>
-        <p:nvSpPr>
-          <p:cNvPr id="1006" name="Twin Builder caption"/>
-          <p:cNvSpPr txBox="1"/>
-          <p:nvPr/>
-        </p:nvSpPr>
-        <p:spPr>
-          <a:xfrm>
-            <a:off x="3081528" y="3073527"/>
-            <a:ext cx="1417320" cy="1628775"/>
-          </a:xfrm>
-          <a:prstGeom prst="rect">
-            <a:avLst/>
-          </a:prstGeom>
-          <a:noFill/>
-          <a:ln>
-            <a:noFill/>
-          </a:ln>
-        </p:spPr>
-        <p:txBody>
-          <a:bodyPr wrap="square" lIns="0" tIns="0" rIns="0" bIns="0" anchor="ctr" rtlCol="0">
-            <a:noAutofit/>
-          </a:bodyPr>
-          <a:lstStyle/>
-          <a:p>
-            <a:pPr marL="0" indent="0" algn="l">
-              <a:spcBef>
-                <a:spcPts val="0"/>
-              </a:spcBef>
-              <a:spcAft>
-                <a:spcPts val="300"/>
-              </a:spcAft>
-              <a:buNone/>
-            </a:pPr>
-            <a:r>
-              <a:rPr lang="en-GB" sz="1200" b="0" dirty="0">
-                <a:solidFill>
-                  <a:srgbClr val="202124"/>
-                </a:solidFill>
-                <a:latin typeface="Google Sans Flex SemiBold"/>
-                <a:ea typeface="Google Sans Flex SemiBold"/>
-                <a:cs typeface="Google Sans Flex SemiBold"/>
-                <a:sym typeface="Google Sans Flex SemiBold"/>
-              </a:rPr>
-              <a:t>Twin Builder</a:t>
-            </a:r>
-            <a:endParaRPr lang="en-GB" sz="1200" dirty="0"/>
-          </a:p>
-          <a:p>
-            <a:pPr marL="0" indent="0" algn="l">
-              <a:lnSpc>
-                <a:spcPct val="105000"/>
-              </a:lnSpc>
-              <a:spcBef>
-                <a:spcPts val="0"/>
-              </a:spcBef>
-              <a:spcAft>
-                <a:spcPts val="0"/>
-              </a:spcAft>
-              <a:buNone/>
-            </a:pPr>
-            <a:r>
-              <a:rPr lang="en-GB" sz="1050" b="0" dirty="0">
-                <a:solidFill>
-                  <a:srgbClr val="5F6368"/>
-                </a:solidFill>
-                <a:latin typeface="Google Sans Flex"/>
-                <a:ea typeface="Google Sans Flex"/>
-                <a:cs typeface="Google Sans Flex"/>
-                <a:sym typeface="Google Sans Flex"/>
-              </a:rPr>
-              <a:t>Review screen with stages, provenance counts and a live layout preview.</a:t>
-            </a:r>
-            <a:endParaRPr lang="en-GB" sz="1050" dirty="0"/>
-          </a:p>
-        </p:txBody>
-      </p:sp>
-      <p:pic>
-        <p:nvPicPr>
-          <p:cNvPr id="1007" name="Playground" descr="Playground"/>
-          <p:cNvPicPr>
-            <a:picLocks noChangeAspect="1"/>
-          </p:cNvPicPr>
-          <p:nvPr/>
-        </p:nvPicPr>
-        <p:blipFill>
-          <a:blip r:embed="rId8"/>
-          <a:stretch>
-            <a:fillRect/>
-          </a:stretch>
-        </p:blipFill>
-        <p:spPr>
-          <a:xfrm>
-            <a:off x="4645152" y="3073527"/>
-            <a:ext cx="2606040" cy="1628775"/>
-          </a:xfrm>
-          <a:prstGeom prst="roundRect">
-            <a:avLst>
-              <a:gd name="adj" fmla="val 2807"/>
-            </a:avLst>
-          </a:prstGeom>
-          <a:ln w="9525">
-            <a:solidFill>
-              <a:srgbClr val="DADCE0"/>
-            </a:solidFill>
-          </a:ln>
-          <a:effectLst>
-            <a:outerShdw blurRad="76200" dist="19050" dir="5400000" algn="t" rotWithShape="0">
-              <a:srgbClr val="000000">
-                <a:alpha val="16000"/>
-              </a:srgbClr>
-            </a:outerShdw>
-          </a:effectLst>
-        </p:spPr>
-      </p:pic>
-      <p:sp>
-        <p:nvSpPr>
-          <p:cNvPr id="1008" name="Playground caption"/>
-          <p:cNvSpPr txBox="1"/>
-          <p:nvPr/>
-        </p:nvSpPr>
-        <p:spPr>
-          <a:xfrm>
-            <a:off x="7360920" y="3073527"/>
-            <a:ext cx="1417320" cy="1628775"/>
-          </a:xfrm>
-          <a:prstGeom prst="rect">
-            <a:avLst/>
-          </a:prstGeom>
-          <a:noFill/>
-          <a:ln>
-            <a:noFill/>
-          </a:ln>
-        </p:spPr>
-        <p:txBody>
-          <a:bodyPr wrap="square" lIns="0" tIns="0" rIns="0" bIns="0" anchor="ctr" rtlCol="0">
-            <a:noAutofit/>
-          </a:bodyPr>
-          <a:lstStyle/>
-          <a:p>
-            <a:pPr marL="0" indent="0" algn="l">
-              <a:spcBef>
-                <a:spcPts val="0"/>
-              </a:spcBef>
-              <a:spcAft>
-                <a:spcPts val="300"/>
-              </a:spcAft>
-              <a:buNone/>
-            </a:pPr>
-            <a:r>
-              <a:rPr lang="en-GB" sz="1200" b="0" dirty="0">
-                <a:solidFill>
-                  <a:srgbClr val="202124"/>
-                </a:solidFill>
-                <a:latin typeface="Google Sans Flex SemiBold"/>
-                <a:ea typeface="Google Sans Flex SemiBold"/>
-                <a:cs typeface="Google Sans Flex SemiBold"/>
-                <a:sym typeface="Google Sans Flex SemiBold"/>
-              </a:rPr>
-              <a:t>Playground</a:t>
-            </a:r>
-            <a:endParaRPr lang="en-GB" sz="1200" dirty="0"/>
-          </a:p>
-          <a:p>
-            <a:pPr marL="0" indent="0" algn="l">
-              <a:lnSpc>
-                <a:spcPct val="105000"/>
-              </a:lnSpc>
-              <a:spcBef>
-                <a:spcPts val="0"/>
-              </a:spcBef>
-              <a:spcAft>
-                <a:spcPts val="0"/>
-              </a:spcAft>
-              <a:buNone/>
-            </a:pPr>
-            <a:r>
-              <a:rPr lang="en-GB" sz="1050" b="0" dirty="0">
-                <a:solidFill>
-                  <a:srgbClr val="5F6368"/>
-                </a:solidFill>
-                <a:latin typeface="Google Sans Flex"/>
-                <a:ea typeface="Google Sans Flex"/>
-                <a:cs typeface="Google Sans Flex"/>
-                <a:sym typeface="Google Sans Flex"/>
-              </a:rPr>
-              <a:t>Place machines and robots on the floor and set automation rules.</a:t>
-            </a:r>
-            <a:endParaRPr lang="en-GB" sz="1050" dirty="0"/>
-          </a:p>
-        </p:txBody>
-      </p:sp>
-    </p:spTree>
-  </p:cSld>
-  <p:clrMapOvr>
-    <a:masterClrMapping/>
-  </p:clrMapOvr>
-</p:sld>
-</file>
-
-<file path=ppt/slides/slide3.xml><?xml version="1.0" encoding="utf-8"?>
+<file path=ppt/slides/slide2.xml><?xml version="1.0" encoding="utf-8"?>
 <p:sld xmlns:a="http://schemas.openxmlformats.org/drawingml/2006/main" xmlns:r="http://schemas.openxmlformats.org/officeDocument/2006/relationships" xmlns:mc="http://schemas.openxmlformats.org/markup-compatibility/2006" xmlns:mv="urn:schemas-microsoft-com:mac:vml" xmlns:p="http://schemas.openxmlformats.org/presentationml/2006/main" xmlns:c="http://schemas.openxmlformats.org/drawingml/2006/chart" xmlns:dgm="http://schemas.openxmlformats.org/drawingml/2006/diagram" xmlns:o="urn:schemas-microsoft-com:office:office" xmlns:v="urn:schemas-microsoft-com:vml" xmlns:pvml="urn:schemas-microsoft-com:office:powerpoint" xmlns:com="http://schemas.openxmlformats.org/drawingml/2006/compatibility" xmlns:p14="http://schemas.microsoft.com/office/powerpoint/2010/main" xmlns:p15="http://schemas.microsoft.com/office/powerpoint/2012/main" xmlns:ahyp="http://schemas.microsoft.com/office/drawing/2018/hyperlinkcolor">
   <p:cSld>
     <p:spTree>
@@ -13189,7 +11923,7 @@
           <a:p>
             <a:pPr marL="0" indent="0" algn="l">
               <a:lnSpc>
-                <a:spcPct val="112000"/>
+                <a:spcPct val="120000"/>
               </a:lnSpc>
               <a:spcBef>
                 <a:spcPts val="0"/>
@@ -13198,416 +11932,17 @@
                 <a:spcPts val="0"/>
               </a:spcAft>
               <a:buNone/>
-            </a:pPr>
-            <a:r>
-              <a:rPr lang="en-GB" sz="1200" b="0" dirty="0">
+              <a:defRPr sz="1100">
                 <a:solidFill>
                   <a:srgbClr val="3C4043"/>
                 </a:solidFill>
                 <a:latin typeface="Google Sans Flex"/>
-                <a:ea typeface="Google Sans Flex"/>
-                <a:cs typeface="Google Sans Flex"/>
-                <a:sym typeface="Google Sans Flex"/>
-              </a:rPr>
-              <a:t>An agentic industrial digital twin on Google Cloud. It mirrors a factory as a live model, spots trouble early, simulates the alternatives and proposes a plan, which a person approves before anything changes.</a:t>
+              </a:defRPr>
+            </a:pPr>
+            <a:r>
+              <a:t>TwinForge AI is a Google Cloud-powered industrial digital twin that connects factory operations, AI agents, and deterministic simulation to help manufacturers predict, optimize, and act with confidence.</a:t>
             </a:r>
             <a:endParaRPr lang="en-GB" sz="1200" dirty="0"/>
-          </a:p>
-        </p:txBody>
-      </p:sp>
-      <p:sp>
-        <p:nvSpPr>
-          <p:cNvPr id="1004" name="See circle"/>
-          <p:cNvSpPr/>
-          <p:nvPr/>
-        </p:nvSpPr>
-        <p:spPr>
-          <a:xfrm>
-            <a:off x="365760" y="2724912"/>
-            <a:ext cx="347472" cy="347472"/>
-          </a:xfrm>
-          <a:prstGeom prst="ellipse">
-            <a:avLst/>
-          </a:prstGeom>
-          <a:solidFill>
-            <a:srgbClr val="1A73E8"/>
-          </a:solidFill>
-          <a:ln>
-            <a:noFill/>
-          </a:ln>
-        </p:spPr>
-        <p:txBody>
-          <a:bodyPr wrap="square" lIns="73152" tIns="73152" rIns="73152" bIns="73152" anchor="ctr" rtlCol="0">
-            <a:noAutofit/>
-          </a:bodyPr>
-          <a:lstStyle/>
-          <a:p>
-            <a:endParaRPr lang="en-GB"/>
-          </a:p>
-        </p:txBody>
-      </p:sp>
-      <p:pic>
-        <p:nvPicPr>
-          <p:cNvPr id="1005" name="See" descr=""/>
-          <p:cNvPicPr>
-            <a:picLocks noChangeAspect="1"/>
-          </p:cNvPicPr>
-          <p:nvPr/>
-        </p:nvPicPr>
-        <p:blipFill>
-          <a:blip r:embed="rId4"/>
-          <a:stretch>
-            <a:fillRect/>
-          </a:stretch>
-        </p:blipFill>
-        <p:spPr>
-          <a:xfrm>
-            <a:off x="442204" y="2801356"/>
-            <a:ext cx="194584" cy="194584"/>
-          </a:xfrm>
-          <a:prstGeom prst="rect">
-            <a:avLst/>
-          </a:prstGeom>
-        </p:spPr>
-      </p:pic>
-      <p:sp>
-        <p:nvSpPr>
-          <p:cNvPr id="1006" name="See text"/>
-          <p:cNvSpPr txBox="1"/>
-          <p:nvPr/>
-        </p:nvSpPr>
-        <p:spPr>
-          <a:xfrm>
-            <a:off x="841248" y="2697480"/>
-            <a:ext cx="4069080" cy="640080"/>
-          </a:xfrm>
-          <a:prstGeom prst="rect">
-            <a:avLst/>
-          </a:prstGeom>
-          <a:noFill/>
-          <a:ln>
-            <a:noFill/>
-          </a:ln>
-        </p:spPr>
-        <p:txBody>
-          <a:bodyPr wrap="square" lIns="0" tIns="0" rIns="0" bIns="0" anchor="t" rtlCol="0">
-            <a:noAutofit/>
-          </a:bodyPr>
-          <a:lstStyle/>
-          <a:p>
-            <a:pPr marL="0" indent="0" algn="l">
-              <a:spcBef>
-                <a:spcPts val="0"/>
-              </a:spcBef>
-              <a:spcAft>
-                <a:spcPts val="100"/>
-              </a:spcAft>
-              <a:buNone/>
-            </a:pPr>
-            <a:r>
-              <a:rPr lang="en-GB" sz="1200" b="0" dirty="0">
-                <a:solidFill>
-                  <a:srgbClr val="202124"/>
-                </a:solidFill>
-                <a:latin typeface="Google Sans Flex SemiBold"/>
-                <a:ea typeface="Google Sans Flex SemiBold"/>
-                <a:cs typeface="Google Sans Flex SemiBold"/>
-                <a:sym typeface="Google Sans Flex SemiBold"/>
-              </a:rPr>
-              <a:t>See</a:t>
-            </a:r>
-            <a:endParaRPr lang="en-GB" sz="1200" dirty="0"/>
-          </a:p>
-          <a:p>
-            <a:pPr marL="0" indent="0" algn="l">
-              <a:lnSpc>
-                <a:spcPct val="105000"/>
-              </a:lnSpc>
-              <a:spcBef>
-                <a:spcPts val="0"/>
-              </a:spcBef>
-              <a:spcAft>
-                <a:spcPts val="0"/>
-              </a:spcAft>
-              <a:buNone/>
-            </a:pPr>
-            <a:r>
-              <a:rPr lang="en-GB" sz="1100" b="0" dirty="0">
-                <a:solidFill>
-                  <a:srgbClr val="5F6368"/>
-                </a:solidFill>
-                <a:latin typeface="Google Sans Flex"/>
-                <a:ea typeface="Google Sans Flex"/>
-                <a:cs typeface="Google Sans Flex"/>
-                <a:sym typeface="Google Sans Flex"/>
-              </a:rPr>
-              <a:t>A live twin of lines, machines, materials, orders, cameras and mobile robots, in topology, isometric, floor-plan and 3D views.</a:t>
-            </a:r>
-            <a:endParaRPr lang="en-GB" sz="1100" dirty="0"/>
-          </a:p>
-        </p:txBody>
-      </p:sp>
-      <p:sp>
-        <p:nvSpPr>
-          <p:cNvPr id="1007" name="Understand circle"/>
-          <p:cNvSpPr/>
-          <p:nvPr/>
-        </p:nvSpPr>
-        <p:spPr>
-          <a:xfrm>
-            <a:off x="365760" y="3410712"/>
-            <a:ext cx="347472" cy="347472"/>
-          </a:xfrm>
-          <a:prstGeom prst="ellipse">
-            <a:avLst/>
-          </a:prstGeom>
-          <a:solidFill>
-            <a:srgbClr val="1A73E8"/>
-          </a:solidFill>
-          <a:ln>
-            <a:noFill/>
-          </a:ln>
-        </p:spPr>
-        <p:txBody>
-          <a:bodyPr wrap="square" lIns="73152" tIns="73152" rIns="73152" bIns="73152" anchor="ctr" rtlCol="0">
-            <a:noAutofit/>
-          </a:bodyPr>
-          <a:lstStyle/>
-          <a:p>
-            <a:endParaRPr lang="en-GB"/>
-          </a:p>
-        </p:txBody>
-      </p:sp>
-      <p:pic>
-        <p:nvPicPr>
-          <p:cNvPr id="1008" name="Understand" descr=""/>
-          <p:cNvPicPr>
-            <a:picLocks noChangeAspect="1"/>
-          </p:cNvPicPr>
-          <p:nvPr/>
-        </p:nvPicPr>
-        <p:blipFill>
-          <a:blip r:embed="rId5"/>
-          <a:stretch>
-            <a:fillRect/>
-          </a:stretch>
-        </p:blipFill>
-        <p:spPr>
-          <a:xfrm>
-            <a:off x="442204" y="3487156"/>
-            <a:ext cx="194584" cy="194584"/>
-          </a:xfrm>
-          <a:prstGeom prst="rect">
-            <a:avLst/>
-          </a:prstGeom>
-        </p:spPr>
-      </p:pic>
-      <p:sp>
-        <p:nvSpPr>
-          <p:cNvPr id="1009" name="Understand text"/>
-          <p:cNvSpPr txBox="1"/>
-          <p:nvPr/>
-        </p:nvSpPr>
-        <p:spPr>
-          <a:xfrm>
-            <a:off x="841248" y="3383280"/>
-            <a:ext cx="4069080" cy="640080"/>
-          </a:xfrm>
-          <a:prstGeom prst="rect">
-            <a:avLst/>
-          </a:prstGeom>
-          <a:noFill/>
-          <a:ln>
-            <a:noFill/>
-          </a:ln>
-        </p:spPr>
-        <p:txBody>
-          <a:bodyPr wrap="square" lIns="0" tIns="0" rIns="0" bIns="0" anchor="t" rtlCol="0">
-            <a:noAutofit/>
-          </a:bodyPr>
-          <a:lstStyle/>
-          <a:p>
-            <a:pPr marL="0" indent="0" algn="l">
-              <a:spcBef>
-                <a:spcPts val="0"/>
-              </a:spcBef>
-              <a:spcAft>
-                <a:spcPts val="100"/>
-              </a:spcAft>
-              <a:buNone/>
-            </a:pPr>
-            <a:r>
-              <a:rPr lang="en-GB" sz="1200" b="0" dirty="0">
-                <a:solidFill>
-                  <a:srgbClr val="202124"/>
-                </a:solidFill>
-                <a:latin typeface="Google Sans Flex SemiBold"/>
-                <a:ea typeface="Google Sans Flex SemiBold"/>
-                <a:cs typeface="Google Sans Flex SemiBold"/>
-                <a:sym typeface="Google Sans Flex SemiBold"/>
-              </a:rPr>
-              <a:t>Understand</a:t>
-            </a:r>
-            <a:endParaRPr lang="en-GB" sz="1200" dirty="0"/>
-          </a:p>
-          <a:p>
-            <a:pPr marL="0" indent="0" algn="l">
-              <a:lnSpc>
-                <a:spcPct val="105000"/>
-              </a:lnSpc>
-              <a:spcBef>
-                <a:spcPts val="0"/>
-              </a:spcBef>
-              <a:spcAft>
-                <a:spcPts val="0"/>
-              </a:spcAft>
-              <a:buNone/>
-            </a:pPr>
-            <a:r>
-              <a:rPr lang="en-GB" sz="1100" b="0" dirty="0">
-                <a:solidFill>
-                  <a:srgbClr val="5F6368"/>
-                </a:solidFill>
-                <a:latin typeface="Google Sans Flex"/>
-                <a:ea typeface="Google Sans Flex"/>
-                <a:cs typeface="Google Sans Flex"/>
-                <a:sym typeface="Google Sans Flex"/>
-              </a:rPr>
-              <a:t>Six specialist AI agents investigate incidents; a multi-agent copilot built with Google’s ADK answers with traceable figures.</a:t>
-            </a:r>
-            <a:endParaRPr lang="en-GB" sz="1100" dirty="0"/>
-          </a:p>
-        </p:txBody>
-      </p:sp>
-      <p:sp>
-        <p:nvSpPr>
-          <p:cNvPr id="1010" name="Decide circle"/>
-          <p:cNvSpPr/>
-          <p:nvPr/>
-        </p:nvSpPr>
-        <p:spPr>
-          <a:xfrm>
-            <a:off x="365760" y="4096512"/>
-            <a:ext cx="347472" cy="347472"/>
-          </a:xfrm>
-          <a:prstGeom prst="ellipse">
-            <a:avLst/>
-          </a:prstGeom>
-          <a:solidFill>
-            <a:srgbClr val="1A73E8"/>
-          </a:solidFill>
-          <a:ln>
-            <a:noFill/>
-          </a:ln>
-        </p:spPr>
-        <p:txBody>
-          <a:bodyPr wrap="square" lIns="73152" tIns="73152" rIns="73152" bIns="73152" anchor="ctr" rtlCol="0">
-            <a:noAutofit/>
-          </a:bodyPr>
-          <a:lstStyle/>
-          <a:p>
-            <a:endParaRPr lang="en-GB"/>
-          </a:p>
-        </p:txBody>
-      </p:sp>
-      <p:pic>
-        <p:nvPicPr>
-          <p:cNvPr id="1011" name="Decide" descr=""/>
-          <p:cNvPicPr>
-            <a:picLocks noChangeAspect="1"/>
-          </p:cNvPicPr>
-          <p:nvPr/>
-        </p:nvPicPr>
-        <p:blipFill>
-          <a:blip r:embed="rId6"/>
-          <a:stretch>
-            <a:fillRect/>
-          </a:stretch>
-        </p:blipFill>
-        <p:spPr>
-          <a:xfrm>
-            <a:off x="442204" y="4172956"/>
-            <a:ext cx="194584" cy="194584"/>
-          </a:xfrm>
-          <a:prstGeom prst="rect">
-            <a:avLst/>
-          </a:prstGeom>
-        </p:spPr>
-      </p:pic>
-      <p:sp>
-        <p:nvSpPr>
-          <p:cNvPr id="1012" name="Decide text"/>
-          <p:cNvSpPr txBox="1"/>
-          <p:nvPr/>
-        </p:nvSpPr>
-        <p:spPr>
-          <a:xfrm>
-            <a:off x="841248" y="4069080"/>
-            <a:ext cx="4069080" cy="640080"/>
-          </a:xfrm>
-          <a:prstGeom prst="rect">
-            <a:avLst/>
-          </a:prstGeom>
-          <a:noFill/>
-          <a:ln>
-            <a:noFill/>
-          </a:ln>
-        </p:spPr>
-        <p:txBody>
-          <a:bodyPr wrap="square" lIns="0" tIns="0" rIns="0" bIns="0" anchor="t" rtlCol="0">
-            <a:noAutofit/>
-          </a:bodyPr>
-          <a:lstStyle/>
-          <a:p>
-            <a:pPr marL="0" indent="0" algn="l">
-              <a:spcBef>
-                <a:spcPts val="0"/>
-              </a:spcBef>
-              <a:spcAft>
-                <a:spcPts val="100"/>
-              </a:spcAft>
-              <a:buNone/>
-            </a:pPr>
-            <a:r>
-              <a:rPr lang="en-GB" sz="1200" b="0" dirty="0">
-                <a:solidFill>
-                  <a:srgbClr val="202124"/>
-                </a:solidFill>
-                <a:latin typeface="Google Sans Flex SemiBold"/>
-                <a:ea typeface="Google Sans Flex SemiBold"/>
-                <a:cs typeface="Google Sans Flex SemiBold"/>
-                <a:sym typeface="Google Sans Flex SemiBold"/>
-              </a:rPr>
-              <a:t>Decide</a:t>
-            </a:r>
-            <a:endParaRPr lang="en-GB" sz="1200" dirty="0"/>
-          </a:p>
-          <a:p>
-            <a:pPr marL="0" indent="0" algn="l">
-              <a:lnSpc>
-                <a:spcPct val="105000"/>
-              </a:lnSpc>
-              <a:spcBef>
-                <a:spcPts val="0"/>
-              </a:spcBef>
-              <a:spcAft>
-                <a:spcPts val="0"/>
-              </a:spcAft>
-              <a:buNone/>
-            </a:pPr>
-            <a:r>
-              <a:rPr lang="en-GB" sz="1100" b="0" dirty="0">
-                <a:solidFill>
-                  <a:srgbClr val="5F6368"/>
-                </a:solidFill>
-                <a:latin typeface="Google Sans Flex"/>
-                <a:ea typeface="Google Sans Flex"/>
-                <a:cs typeface="Google Sans Flex"/>
-                <a:sym typeface="Google Sans Flex"/>
-              </a:rPr>
-              <a:t>A deterministic plant engine simulates the options; a person approves, the twin executes, and every step is audited.</a:t>
-            </a:r>
-            <a:endParaRPr lang="en-GB" sz="1100" dirty="0"/>
           </a:p>
         </p:txBody>
       </p:sp>
@@ -13657,8 +11992,8 @@
         </p:nvSpPr>
         <p:spPr>
           <a:xfrm>
-            <a:off x="5166360" y="3639312"/>
-            <a:ext cx="3611880" cy="1115568"/>
+            <a:off x="5166360" y="3500000"/>
+            <a:ext cx="3611880" cy="1350000"/>
           </a:xfrm>
           <a:prstGeom prst="roundRect">
             <a:avLst>
@@ -13673,7 +12008,7 @@
           </a:ln>
         </p:spPr>
         <p:txBody>
-          <a:bodyPr wrap="square" lIns="164592" tIns="164592" rIns="164592" bIns="164592" anchor="ctr" rtlCol="0">
+          <a:bodyPr wrap="square" lIns="152400" tIns="127000" rIns="152400" bIns="127000" anchor="ctr" rtlCol="0">
             <a:noAutofit/>
           </a:bodyPr>
           <a:lstStyle/>
@@ -13683,50 +12018,189 @@
                 <a:spcPts val="0"/>
               </a:spcBef>
               <a:spcAft>
-                <a:spcPts val="300"/>
-              </a:spcAft>
-              <a:buNone/>
-            </a:pPr>
-            <a:r>
-              <a:rPr lang="en-GB" sz="950" b="0" dirty="0">
+                <a:spcPts val="400"/>
+              </a:spcAft>
+              <a:buNone/>
+              <a:defRPr sz="1000" b="1">
                 <a:solidFill>
                   <a:srgbClr val="1A73E8"/>
                 </a:solidFill>
-                <a:latin typeface="Google Sans Flex SemiBold"/>
-                <a:ea typeface="Google Sans Flex SemiBold"/>
-                <a:cs typeface="Google Sans Flex SemiBold"/>
-                <a:sym typeface="Google Sans Flex SemiBold"/>
-              </a:rPr>
-              <a:t>OUR PRINCIPLE</a:t>
+                <a:latin typeface="Google Sans Flex"/>
+              </a:defRPr>
+            </a:pPr>
+            <a:r>
+              <a:t>SEE. UNDERSTAND. SIMULATE. ACT.</a:t>
             </a:r>
             <a:endParaRPr lang="en-GB" sz="950" dirty="0"/>
           </a:p>
           <a:p>
-            <a:pPr marL="0" indent="0" algn="l">
+            <a:pPr>
               <a:lnSpc>
-                <a:spcPct val="110000"/>
+                <a:spcPct val="115000"/>
               </a:lnSpc>
-              <a:spcBef>
-                <a:spcPts val="0"/>
-              </a:spcBef>
-              <a:spcAft>
-                <a:spcPts val="0"/>
-              </a:spcAft>
-              <a:buNone/>
-            </a:pPr>
-            <a:r>
-              <a:rPr lang="en-GB" sz="1200" b="0" dirty="0">
+              <a:spcAft>
+                <a:spcPts val="600"/>
+              </a:spcAft>
+              <a:defRPr sz="950">
                 <a:solidFill>
                   <a:srgbClr val="202124"/>
                 </a:solidFill>
-                <a:latin typeface="Google Sans Flex Medium"/>
-                <a:ea typeface="Google Sans Flex Medium"/>
-                <a:cs typeface="Google Sans Flex Medium"/>
-                <a:sym typeface="Google Sans Flex Medium"/>
+                <a:latin typeface="Google Sans Flex"/>
+              </a:defRPr>
+            </a:pPr>
+            <a:r>
+              <a:t>Explore a live digital twin, investigate incidents with six specialist AI agents, simulate alternative scenarios, and execute approved actions only after human authorization.</a:t>
+            </a:r>
+          </a:p>
+          <a:p>
+            <a:r>
+              <a:rPr sz="800" i="1">
+                <a:solidFill>
+                  <a:srgbClr val="5F6368"/>
+                </a:solidFill>
+                <a:latin typeface="Google Sans Flex"/>
               </a:rPr>
-              <a:t>Language models explain, extract and orchestrate. Numbers come from code. Decisions come from people.</a:t>
+              <a:t>OUR PRINCIPLE: Language models explain, extract and orchestrate. Numbers come from code. Decisions come from people.</a:t>
             </a:r>
-            <a:endParaRPr lang="en-GB" sz="1200" dirty="0"/>
+          </a:p>
+        </p:txBody>
+      </p:sp>
+      <p:sp>
+        <p:nvSpPr>
+          <p:cNvPr id="1015" name="Capabilities"/>
+          <p:cNvSpPr txBox="1"/>
+          <p:nvPr/>
+        </p:nvSpPr>
+        <p:spPr>
+          <a:xfrm>
+            <a:off x="365760" y="2580000"/>
+            <a:ext cx="4572000" cy="2200000"/>
+          </a:xfrm>
+          <a:prstGeom prst="rect">
+            <a:avLst/>
+          </a:prstGeom>
+          <a:noFill/>
+        </p:spPr>
+        <p:txBody>
+          <a:bodyPr wrap="square" lIns="0" rIns="0" tIns="0" bIns="0">
+            <a:spAutoFit/>
+          </a:bodyPr>
+          <a:lstStyle/>
+          <a:p>
+            <a:pPr>
+              <a:spcAft>
+                <a:spcPts val="800"/>
+              </a:spcAft>
+              <a:defRPr sz="1150" b="1">
+                <a:solidFill>
+                  <a:srgbClr val="1A73E8"/>
+                </a:solidFill>
+                <a:latin typeface="Google Sans Flex"/>
+              </a:defRPr>
+            </a:pPr>
+            <a:r>
+              <a:t>Four intelligent capabilities.</a:t>
+            </a:r>
+          </a:p>
+          <a:p>
+            <a:pPr>
+              <a:spcAft>
+                <a:spcPts val="700"/>
+              </a:spcAft>
+            </a:pPr>
+            <a:r>
+              <a:rPr sz="1000" b="1">
+                <a:solidFill>
+                  <a:srgbClr val="202124"/>
+                </a:solidFill>
+                <a:latin typeface="Google Sans Flex"/>
+              </a:rPr>
+              <a:t>•  Predictive Maintenance — </a:t>
+            </a:r>
+            <a:r>
+              <a:rPr sz="1000" b="0">
+                <a:solidFill>
+                  <a:srgbClr val="5F6368"/>
+                </a:solidFill>
+                <a:latin typeface="Google Sans Flex"/>
+              </a:rPr>
+              <a:t>Anticipate equipment failures before they disrupt production.</a:t>
+            </a:r>
+          </a:p>
+          <a:p>
+            <a:pPr>
+              <a:spcAft>
+                <a:spcPts val="700"/>
+              </a:spcAft>
+            </a:pPr>
+            <a:r>
+              <a:rPr sz="1000" b="1">
+                <a:solidFill>
+                  <a:srgbClr val="202124"/>
+                </a:solidFill>
+                <a:latin typeface="Google Sans Flex"/>
+              </a:rPr>
+              <a:t>•  Demand Forecasting — </a:t>
+            </a:r>
+            <a:r>
+              <a:rPr sz="1000" b="0">
+                <a:solidFill>
+                  <a:srgbClr val="5F6368"/>
+                </a:solidFill>
+                <a:latin typeface="Google Sans Flex"/>
+              </a:rPr>
+              <a:t>Predict demand and optimize production plans.</a:t>
+            </a:r>
+          </a:p>
+          <a:p>
+            <a:pPr>
+              <a:spcAft>
+                <a:spcPts val="700"/>
+              </a:spcAft>
+            </a:pPr>
+            <a:r>
+              <a:rPr sz="1000" b="1">
+                <a:solidFill>
+                  <a:srgbClr val="202124"/>
+                </a:solidFill>
+                <a:latin typeface="Google Sans Flex"/>
+              </a:rPr>
+              <a:t>•  Supply Chain Intelligence — </a:t>
+            </a:r>
+            <a:r>
+              <a:rPr sz="1000" b="0">
+                <a:solidFill>
+                  <a:srgbClr val="5F6368"/>
+                </a:solidFill>
+                <a:latin typeface="Google Sans Flex"/>
+              </a:rPr>
+              <a:t>Identify disruptions and optimize materials, inventory, and deliveries.</a:t>
+            </a:r>
+          </a:p>
+          <a:p>
+            <a:pPr>
+              <a:spcAft>
+                <a:spcPts val="700"/>
+              </a:spcAft>
+            </a:pPr>
+            <a:r>
+              <a:rPr sz="1000" b="1">
+                <a:solidFill>
+                  <a:srgbClr val="202124"/>
+                </a:solidFill>
+                <a:latin typeface="Google Sans Flex"/>
+              </a:rPr>
+              <a:t>•  Visual Quality Inspection — </a:t>
+            </a:r>
+            <a:r>
+              <a:rPr sz="1000" b="0">
+                <a:solidFill>
+                  <a:srgbClr val="5F6368"/>
+                </a:solidFill>
+                <a:latin typeface="Google Sans Flex"/>
+              </a:rPr>
+              <a:t>Detect defects, improve first-pass yield, and reduce quality losses.</a:t>
+            </a:r>
           </a:p>
         </p:txBody>
       </p:sp>
@@ -13738,7 +12212,7 @@
 </p:sld>
 </file>
 
-<file path=ppt/slides/slide4.xml><?xml version="1.0" encoding="utf-8"?>
+<file path=ppt/slides/slide3.xml><?xml version="1.0" encoding="utf-8"?>
 <p:sld xmlns:a="http://schemas.openxmlformats.org/drawingml/2006/main" xmlns:r="http://schemas.openxmlformats.org/officeDocument/2006/relationships" xmlns:mc="http://schemas.openxmlformats.org/markup-compatibility/2006" xmlns:mv="urn:schemas-microsoft-com:mac:vml" xmlns:p="http://schemas.openxmlformats.org/presentationml/2006/main" xmlns:c="http://schemas.openxmlformats.org/drawingml/2006/chart" xmlns:dgm="http://schemas.openxmlformats.org/drawingml/2006/diagram" xmlns:o="urn:schemas-microsoft-com:office:office" xmlns:v="urn:schemas-microsoft-com:vml" xmlns:pvml="urn:schemas-microsoft-com:office:powerpoint" xmlns:com="http://schemas.openxmlformats.org/drawingml/2006/compatibility" xmlns:p14="http://schemas.microsoft.com/office/powerpoint/2010/main" xmlns:p15="http://schemas.microsoft.com/office/powerpoint/2012/main" xmlns:ahyp="http://schemas.microsoft.com/office/drawing/2018/hyperlinkcolor">
   <p:cSld>
     <p:spTree>
@@ -14700,7 +13174,7 @@
 </p:sld>
 </file>
 
-<file path=ppt/slides/slide5.xml><?xml version="1.0" encoding="utf-8"?>
+<file path=ppt/slides/slide4.xml><?xml version="1.0" encoding="utf-8"?>
 <p:sld xmlns:a="http://schemas.openxmlformats.org/drawingml/2006/main" xmlns:r="http://schemas.openxmlformats.org/officeDocument/2006/relationships" xmlns:mc="http://schemas.openxmlformats.org/markup-compatibility/2006" xmlns:mv="urn:schemas-microsoft-com:mac:vml" xmlns:p="http://schemas.openxmlformats.org/presentationml/2006/main" xmlns:c="http://schemas.openxmlformats.org/drawingml/2006/chart" xmlns:dgm="http://schemas.openxmlformats.org/drawingml/2006/diagram" xmlns:o="urn:schemas-microsoft-com:office:office" xmlns:v="urn:schemas-microsoft-com:vml" xmlns:pvml="urn:schemas-microsoft-com:office:powerpoint" xmlns:com="http://schemas.openxmlformats.org/drawingml/2006/compatibility" xmlns:p14="http://schemas.microsoft.com/office/powerpoint/2010/main" xmlns:p15="http://schemas.microsoft.com/office/powerpoint/2012/main" xmlns:ahyp="http://schemas.microsoft.com/office/drawing/2018/hyperlinkcolor">
   <p:cSld>
     <p:spTree>
@@ -16610,7 +15084,7 @@
 </p:sld>
 </file>
 
-<file path=ppt/slides/slide6.xml><?xml version="1.0" encoding="utf-8"?>
+<file path=ppt/slides/slide5.xml><?xml version="1.0" encoding="utf-8"?>
 <p:sld xmlns:a="http://schemas.openxmlformats.org/drawingml/2006/main" xmlns:r="http://schemas.openxmlformats.org/officeDocument/2006/relationships" xmlns:mc="http://schemas.openxmlformats.org/markup-compatibility/2006" xmlns:mv="urn:schemas-microsoft-com:mac:vml" xmlns:p="http://schemas.openxmlformats.org/presentationml/2006/main" xmlns:c="http://schemas.openxmlformats.org/drawingml/2006/chart" xmlns:dgm="http://schemas.openxmlformats.org/drawingml/2006/diagram" xmlns:o="urn:schemas-microsoft-com:office:office" xmlns:v="urn:schemas-microsoft-com:vml" xmlns:pvml="urn:schemas-microsoft-com:office:powerpoint" xmlns:com="http://schemas.openxmlformats.org/drawingml/2006/compatibility" xmlns:p14="http://schemas.microsoft.com/office/powerpoint/2010/main" xmlns:p15="http://schemas.microsoft.com/office/powerpoint/2012/main" xmlns:ahyp="http://schemas.microsoft.com/office/drawing/2018/hyperlinkcolor">
   <p:cSld>
     <p:spTree>
@@ -17024,7 +15498,7 @@
 </p:sld>
 </file>
 
-<file path=ppt/slides/slide8.xml><?xml version="1.0" encoding="utf-8"?>
+<file path=ppt/slides/slide6.xml><?xml version="1.0" encoding="utf-8"?>
 <p:sld xmlns:a="http://schemas.openxmlformats.org/drawingml/2006/main" xmlns:r="http://schemas.openxmlformats.org/officeDocument/2006/relationships" xmlns:mc="http://schemas.openxmlformats.org/markup-compatibility/2006" xmlns:mv="urn:schemas-microsoft-com:mac:vml" xmlns:p="http://schemas.openxmlformats.org/presentationml/2006/main" xmlns:c="http://schemas.openxmlformats.org/drawingml/2006/chart" xmlns:dgm="http://schemas.openxmlformats.org/drawingml/2006/diagram" xmlns:o="urn:schemas-microsoft-com:office:office" xmlns:v="urn:schemas-microsoft-com:vml" xmlns:pvml="urn:schemas-microsoft-com:office:powerpoint" xmlns:com="http://schemas.openxmlformats.org/drawingml/2006/compatibility" xmlns:p14="http://schemas.microsoft.com/office/powerpoint/2010/main" xmlns:p15="http://schemas.microsoft.com/office/powerpoint/2012/main" xmlns:ahyp="http://schemas.microsoft.com/office/drawing/2018/hyperlinkcolor">
   <p:cSld>
     <p:spTree>
@@ -17502,7 +15976,7 @@
 </p:sld>
 </file>
 
-<file path=ppt/slides/slide9.xml><?xml version="1.0" encoding="utf-8"?>
+<file path=ppt/slides/slide7.xml><?xml version="1.0" encoding="utf-8"?>
 <p:sld xmlns:a="http://schemas.openxmlformats.org/drawingml/2006/main" xmlns:r="http://schemas.openxmlformats.org/officeDocument/2006/relationships" xmlns:mc="http://schemas.openxmlformats.org/markup-compatibility/2006" xmlns:mv="urn:schemas-microsoft-com:mac:vml" xmlns:p="http://schemas.openxmlformats.org/presentationml/2006/main" xmlns:c="http://schemas.openxmlformats.org/drawingml/2006/chart" xmlns:dgm="http://schemas.openxmlformats.org/drawingml/2006/diagram" xmlns:o="urn:schemas-microsoft-com:office:office" xmlns:v="urn:schemas-microsoft-com:vml" xmlns:pvml="urn:schemas-microsoft-com:office:powerpoint" xmlns:com="http://schemas.openxmlformats.org/drawingml/2006/compatibility" xmlns:p14="http://schemas.microsoft.com/office/powerpoint/2010/main" xmlns:p15="http://schemas.microsoft.com/office/powerpoint/2012/main" xmlns:ahyp="http://schemas.microsoft.com/office/drawing/2018/hyperlinkcolor">
   <p:cSld>
     <p:spTree>
@@ -21805,6 +20279,1272 @@
               <a:t>Testing</a:t>
             </a:r>
             <a:endParaRPr lang="en-GB" sz="1100" dirty="0"/>
+          </a:p>
+        </p:txBody>
+      </p:sp>
+    </p:spTree>
+  </p:cSld>
+  <p:clrMapOvr>
+    <a:masterClrMapping/>
+  </p:clrMapOvr>
+</p:sld>
+</file>
+
+<file path=ppt/slides/slide8.xml><?xml version="1.0" encoding="utf-8"?>
+<p:sld xmlns:a="http://schemas.openxmlformats.org/drawingml/2006/main" xmlns:r="http://schemas.openxmlformats.org/officeDocument/2006/relationships" xmlns:mc="http://schemas.openxmlformats.org/markup-compatibility/2006" xmlns:mv="urn:schemas-microsoft-com:mac:vml" xmlns:p="http://schemas.openxmlformats.org/presentationml/2006/main" xmlns:c="http://schemas.openxmlformats.org/drawingml/2006/chart" xmlns:dgm="http://schemas.openxmlformats.org/drawingml/2006/diagram" xmlns:o="urn:schemas-microsoft-com:office:office" xmlns:v="urn:schemas-microsoft-com:vml" xmlns:pvml="urn:schemas-microsoft-com:office:powerpoint" xmlns:com="http://schemas.openxmlformats.org/drawingml/2006/compatibility" xmlns:p14="http://schemas.microsoft.com/office/powerpoint/2010/main" xmlns:p15="http://schemas.microsoft.com/office/powerpoint/2012/main" xmlns:ahyp="http://schemas.microsoft.com/office/drawing/2018/hyperlinkcolor">
+  <p:cSld>
+    <p:spTree>
+      <p:nvGrpSpPr>
+        <p:cNvPr id="131" name="Shape 131"/>
+        <p:cNvGrpSpPr/>
+        <p:nvPr/>
+      </p:nvGrpSpPr>
+      <p:grpSpPr>
+        <a:xfrm>
+          <a:off x="0" y="0"/>
+          <a:ext cx="0" cy="0"/>
+          <a:chOff x="0" y="0"/>
+          <a:chExt cx="0" cy="0"/>
+        </a:xfrm>
+      </p:grpSpPr>
+      <p:pic>
+        <p:nvPicPr>
+          <p:cNvPr id="132" name="Google Shape;132;p23" title="Frame 144.png"/>
+          <p:cNvPicPr preferRelativeResize="0"/>
+          <p:nvPr/>
+        </p:nvPicPr>
+        <p:blipFill rotWithShape="1">
+          <a:blip r:embed="rId3">
+            <a:alphaModFix/>
+          </a:blip>
+          <a:srcRect b="98001" l="0" r="0" t="0"/>
+          <a:stretch/>
+        </p:blipFill>
+        <p:spPr>
+          <a:xfrm>
+            <a:off x="0" y="5093562"/>
+            <a:ext cx="9144000" cy="54275"/>
+          </a:xfrm>
+          <a:prstGeom prst="rect">
+            <a:avLst/>
+          </a:prstGeom>
+          <a:noFill/>
+          <a:ln>
+            <a:noFill/>
+          </a:ln>
+        </p:spPr>
+      </p:pic>
+      <p:pic>
+        <p:nvPicPr>
+          <p:cNvPr id="133" name="Google Shape;133;p23" title="Group 427319979.png"/>
+          <p:cNvPicPr preferRelativeResize="0"/>
+          <p:nvPr/>
+        </p:nvPicPr>
+        <p:blipFill>
+          <a:blip r:embed="rId4">
+            <a:alphaModFix/>
+          </a:blip>
+          <a:stretch>
+            <a:fillRect/>
+          </a:stretch>
+        </p:blipFill>
+        <p:spPr>
+          <a:xfrm>
+            <a:off x="0" y="1"/>
+            <a:ext cx="9144000" cy="507359"/>
+          </a:xfrm>
+          <a:prstGeom prst="rect">
+            <a:avLst/>
+          </a:prstGeom>
+          <a:noFill/>
+          <a:ln>
+            <a:noFill/>
+          </a:ln>
+        </p:spPr>
+      </p:pic>
+      <p:sp>
+        <p:nvSpPr>
+          <p:cNvPr id="134" name="Google Shape;134;p23"/>
+          <p:cNvSpPr/>
+          <p:nvPr/>
+        </p:nvSpPr>
+        <p:spPr>
+          <a:xfrm>
+            <a:off x="-29250" y="5071875"/>
+            <a:ext cx="9173400" cy="97800"/>
+          </a:xfrm>
+          <a:prstGeom prst="rect">
+            <a:avLst/>
+          </a:prstGeom>
+          <a:solidFill>
+            <a:schemeClr val="dk1"/>
+          </a:solidFill>
+          <a:ln>
+            <a:noFill/>
+          </a:ln>
+        </p:spPr>
+        <p:txBody>
+          <a:bodyPr anchorCtr="0" anchor="ctr" bIns="91425" lIns="91425" spcFirstLastPara="1" rIns="91425" wrap="square" tIns="91425">
+            <a:noAutofit/>
+          </a:bodyPr>
+          <a:lstStyle/>
+          <a:p>
+            <a:pPr indent="0" lvl="0" marL="0" rtl="0" algn="ctr">
+              <a:spcBef>
+                <a:spcPts val="0"/>
+              </a:spcBef>
+              <a:spcAft>
+                <a:spcPts val="0"/>
+              </a:spcAft>
+              <a:buNone/>
+            </a:pPr>
+            <a:r>
+              <a:t/>
+            </a:r>
+            <a:endParaRPr/>
+          </a:p>
+        </p:txBody>
+      </p:sp>
+      <p:sp>
+        <p:nvSpPr>
+          <p:cNvPr id="135" name="Google Shape;135;p23"/>
+          <p:cNvSpPr txBox="1"/>
+          <p:nvPr/>
+        </p:nvSpPr>
+        <p:spPr>
+          <a:xfrm>
+            <a:off x="265350" y="663825"/>
+            <a:ext cx="8943000" cy="461900"/>
+          </a:xfrm>
+          <a:prstGeom prst="rect">
+            <a:avLst/>
+          </a:prstGeom>
+          <a:noFill/>
+          <a:ln>
+            <a:noFill/>
+          </a:ln>
+        </p:spPr>
+        <p:txBody>
+          <a:bodyPr anchorCtr="0" anchor="t" bIns="91425" lIns="91425" spcFirstLastPara="1" rIns="91425" wrap="square" tIns="91425">
+            <a:noAutofit/>
+          </a:bodyPr>
+          <a:lstStyle/>
+          <a:p>
+            <a:pPr marL="0" indent="0" algn="l">
+              <a:spcBef>
+                <a:spcPts val="0"/>
+              </a:spcBef>
+              <a:spcAft>
+                <a:spcPts val="0"/>
+              </a:spcAft>
+              <a:buNone/>
+            </a:pPr>
+            <a:r>
+              <a:rPr lang="en-GB" sz="1600" b="0" dirty="0">
+                <a:solidFill>
+                  <a:srgbClr val="000000"/>
+                </a:solidFill>
+                <a:latin typeface="Google Sans Flex Medium"/>
+                <a:ea typeface="Google Sans Flex Medium"/>
+                <a:cs typeface="Google Sans Flex Medium"/>
+                <a:sym typeface="Google Sans Flex Medium"/>
+              </a:rPr>
+              <a:t>Snapshots of the prototype (1/2)</a:t>
+            </a:r>
+            <a:endParaRPr lang="en-GB" sz="1600" dirty="0"/>
+          </a:p>
+        </p:txBody>
+      </p:sp>
+      <p:pic>
+        <p:nvPicPr>
+          <p:cNvPr id="1001" name="Command Center" descr="Command Center"/>
+          <p:cNvPicPr>
+            <a:picLocks noChangeAspect="1"/>
+          </p:cNvPicPr>
+          <p:nvPr/>
+        </p:nvPicPr>
+        <p:blipFill>
+          <a:blip r:embed="rId5"/>
+          <a:stretch>
+            <a:fillRect/>
+          </a:stretch>
+        </p:blipFill>
+        <p:spPr>
+          <a:xfrm>
+            <a:off x="365760" y="1188720"/>
+            <a:ext cx="2606040" cy="1628775"/>
+          </a:xfrm>
+          <a:prstGeom prst="roundRect">
+            <a:avLst>
+              <a:gd name="adj" fmla="val 2807"/>
+            </a:avLst>
+          </a:prstGeom>
+          <a:ln w="9525">
+            <a:solidFill>
+              <a:srgbClr val="DADCE0"/>
+            </a:solidFill>
+          </a:ln>
+          <a:effectLst>
+            <a:outerShdw blurRad="76200" dist="19050" dir="5400000" algn="t" rotWithShape="0">
+              <a:srgbClr val="000000">
+                <a:alpha val="16000"/>
+              </a:srgbClr>
+            </a:outerShdw>
+          </a:effectLst>
+        </p:spPr>
+      </p:pic>
+      <p:sp>
+        <p:nvSpPr>
+          <p:cNvPr id="1002" name="Command Center caption"/>
+          <p:cNvSpPr txBox="1"/>
+          <p:nvPr/>
+        </p:nvSpPr>
+        <p:spPr>
+          <a:xfrm>
+            <a:off x="3081528" y="1188720"/>
+            <a:ext cx="1417320" cy="1628775"/>
+          </a:xfrm>
+          <a:prstGeom prst="rect">
+            <a:avLst/>
+          </a:prstGeom>
+          <a:noFill/>
+          <a:ln>
+            <a:noFill/>
+          </a:ln>
+        </p:spPr>
+        <p:txBody>
+          <a:bodyPr wrap="square" lIns="0" tIns="0" rIns="0" bIns="0" anchor="ctr" rtlCol="0">
+            <a:noAutofit/>
+          </a:bodyPr>
+          <a:lstStyle/>
+          <a:p>
+            <a:pPr marL="0" indent="0" algn="l">
+              <a:spcBef>
+                <a:spcPts val="0"/>
+              </a:spcBef>
+              <a:spcAft>
+                <a:spcPts val="300"/>
+              </a:spcAft>
+              <a:buNone/>
+            </a:pPr>
+            <a:r>
+              <a:rPr lang="en-GB" sz="1200" b="0" dirty="0">
+                <a:solidFill>
+                  <a:srgbClr val="202124"/>
+                </a:solidFill>
+                <a:latin typeface="Google Sans Flex SemiBold"/>
+                <a:ea typeface="Google Sans Flex SemiBold"/>
+                <a:cs typeface="Google Sans Flex SemiBold"/>
+                <a:sym typeface="Google Sans Flex SemiBold"/>
+              </a:rPr>
+              <a:t>Command Center</a:t>
+            </a:r>
+            <a:endParaRPr lang="en-GB" sz="1200" dirty="0"/>
+          </a:p>
+          <a:p>
+            <a:pPr marL="0" indent="0" algn="l">
+              <a:lnSpc>
+                <a:spcPct val="105000"/>
+              </a:lnSpc>
+              <a:spcBef>
+                <a:spcPts val="0"/>
+              </a:spcBef>
+              <a:spcAft>
+                <a:spcPts val="0"/>
+              </a:spcAft>
+              <a:buNone/>
+            </a:pPr>
+            <a:r>
+              <a:rPr lang="en-GB" sz="1050" b="0" dirty="0">
+                <a:solidFill>
+                  <a:srgbClr val="5F6368"/>
+                </a:solidFill>
+                <a:latin typeface="Google Sans Flex"/>
+                <a:ea typeface="Google Sans Flex"/>
+                <a:cs typeface="Google Sans Flex"/>
+                <a:sym typeface="Google Sans Flex"/>
+              </a:rPr>
+              <a:t>The whole plant on one screen during the crisis, with the guided demo panel.</a:t>
+            </a:r>
+            <a:endParaRPr lang="en-GB" sz="1050" dirty="0"/>
+          </a:p>
+        </p:txBody>
+      </p:sp>
+      <p:pic>
+        <p:nvPicPr>
+          <p:cNvPr id="1003" name="AI Operations" descr="AI Operations"/>
+          <p:cNvPicPr>
+            <a:picLocks noChangeAspect="1"/>
+          </p:cNvPicPr>
+          <p:nvPr/>
+        </p:nvPicPr>
+        <p:blipFill>
+          <a:blip r:embed="rId6"/>
+          <a:stretch>
+            <a:fillRect/>
+          </a:stretch>
+        </p:blipFill>
+        <p:spPr>
+          <a:xfrm>
+            <a:off x="4645152" y="1188720"/>
+            <a:ext cx="2606040" cy="1628775"/>
+          </a:xfrm>
+          <a:prstGeom prst="roundRect">
+            <a:avLst>
+              <a:gd name="adj" fmla="val 2807"/>
+            </a:avLst>
+          </a:prstGeom>
+          <a:ln w="9525">
+            <a:solidFill>
+              <a:srgbClr val="DADCE0"/>
+            </a:solidFill>
+          </a:ln>
+          <a:effectLst>
+            <a:outerShdw blurRad="76200" dist="19050" dir="5400000" algn="t" rotWithShape="0">
+              <a:srgbClr val="000000">
+                <a:alpha val="16000"/>
+              </a:srgbClr>
+            </a:outerShdw>
+          </a:effectLst>
+        </p:spPr>
+      </p:pic>
+      <p:sp>
+        <p:nvSpPr>
+          <p:cNvPr id="1004" name="AI Operations caption"/>
+          <p:cNvSpPr txBox="1"/>
+          <p:nvPr/>
+        </p:nvSpPr>
+        <p:spPr>
+          <a:xfrm>
+            <a:off x="7360920" y="1188720"/>
+            <a:ext cx="1417320" cy="1628775"/>
+          </a:xfrm>
+          <a:prstGeom prst="rect">
+            <a:avLst/>
+          </a:prstGeom>
+          <a:noFill/>
+          <a:ln>
+            <a:noFill/>
+          </a:ln>
+        </p:spPr>
+        <p:txBody>
+          <a:bodyPr wrap="square" lIns="0" tIns="0" rIns="0" bIns="0" anchor="ctr" rtlCol="0">
+            <a:noAutofit/>
+          </a:bodyPr>
+          <a:lstStyle/>
+          <a:p>
+            <a:pPr marL="0" indent="0" algn="l">
+              <a:spcBef>
+                <a:spcPts val="0"/>
+              </a:spcBef>
+              <a:spcAft>
+                <a:spcPts val="300"/>
+              </a:spcAft>
+              <a:buNone/>
+            </a:pPr>
+            <a:r>
+              <a:rPr lang="en-GB" sz="1200" b="0" dirty="0">
+                <a:solidFill>
+                  <a:srgbClr val="202124"/>
+                </a:solidFill>
+                <a:latin typeface="Google Sans Flex SemiBold"/>
+                <a:ea typeface="Google Sans Flex SemiBold"/>
+                <a:cs typeface="Google Sans Flex SemiBold"/>
+                <a:sym typeface="Google Sans Flex SemiBold"/>
+              </a:rPr>
+              <a:t>AI Operations</a:t>
+            </a:r>
+            <a:endParaRPr lang="en-GB" sz="1200" dirty="0"/>
+          </a:p>
+          <a:p>
+            <a:pPr marL="0" indent="0" algn="l">
+              <a:lnSpc>
+                <a:spcPct val="105000"/>
+              </a:lnSpc>
+              <a:spcBef>
+                <a:spcPts val="0"/>
+              </a:spcBef>
+              <a:spcAft>
+                <a:spcPts val="0"/>
+              </a:spcAft>
+              <a:buNone/>
+            </a:pPr>
+            <a:r>
+              <a:rPr lang="en-GB" sz="1050" b="0" dirty="0">
+                <a:solidFill>
+                  <a:srgbClr val="5F6368"/>
+                </a:solidFill>
+                <a:latin typeface="Google Sans Flex"/>
+                <a:ea typeface="Google Sans Flex"/>
+                <a:cs typeface="Google Sans Flex"/>
+                <a:sym typeface="Google Sans Flex"/>
+              </a:rPr>
+              <a:t>Six agents stream findings; a trip is predicted about 16 hours ahead.</a:t>
+            </a:r>
+            <a:endParaRPr lang="en-GB" sz="1050" dirty="0"/>
+          </a:p>
+        </p:txBody>
+      </p:sp>
+      <p:pic>
+        <p:nvPicPr>
+          <p:cNvPr id="1005" name="What-If Simulator" descr="What-If Simulator"/>
+          <p:cNvPicPr>
+            <a:picLocks noChangeAspect="1"/>
+          </p:cNvPicPr>
+          <p:nvPr/>
+        </p:nvPicPr>
+        <p:blipFill>
+          <a:blip r:embed="rId7"/>
+          <a:stretch>
+            <a:fillRect/>
+          </a:stretch>
+        </p:blipFill>
+        <p:spPr>
+          <a:xfrm>
+            <a:off x="365760" y="3073527"/>
+            <a:ext cx="2606040" cy="1628775"/>
+          </a:xfrm>
+          <a:prstGeom prst="roundRect">
+            <a:avLst>
+              <a:gd name="adj" fmla="val 2807"/>
+            </a:avLst>
+          </a:prstGeom>
+          <a:ln w="9525">
+            <a:solidFill>
+              <a:srgbClr val="DADCE0"/>
+            </a:solidFill>
+          </a:ln>
+          <a:effectLst>
+            <a:outerShdw blurRad="76200" dist="19050" dir="5400000" algn="t" rotWithShape="0">
+              <a:srgbClr val="000000">
+                <a:alpha val="16000"/>
+              </a:srgbClr>
+            </a:outerShdw>
+          </a:effectLst>
+        </p:spPr>
+      </p:pic>
+      <p:sp>
+        <p:nvSpPr>
+          <p:cNvPr id="1006" name="What-If Simulator caption"/>
+          <p:cNvSpPr txBox="1"/>
+          <p:nvPr/>
+        </p:nvSpPr>
+        <p:spPr>
+          <a:xfrm>
+            <a:off x="3081528" y="3073527"/>
+            <a:ext cx="1417320" cy="1628775"/>
+          </a:xfrm>
+          <a:prstGeom prst="rect">
+            <a:avLst/>
+          </a:prstGeom>
+          <a:noFill/>
+          <a:ln>
+            <a:noFill/>
+          </a:ln>
+        </p:spPr>
+        <p:txBody>
+          <a:bodyPr wrap="square" lIns="0" tIns="0" rIns="0" bIns="0" anchor="ctr" rtlCol="0">
+            <a:noAutofit/>
+          </a:bodyPr>
+          <a:lstStyle/>
+          <a:p>
+            <a:pPr marL="0" indent="0" algn="l">
+              <a:spcBef>
+                <a:spcPts val="0"/>
+              </a:spcBef>
+              <a:spcAft>
+                <a:spcPts val="300"/>
+              </a:spcAft>
+              <a:buNone/>
+            </a:pPr>
+            <a:r>
+              <a:rPr lang="en-GB" sz="1200" b="0" dirty="0">
+                <a:solidFill>
+                  <a:srgbClr val="202124"/>
+                </a:solidFill>
+                <a:latin typeface="Google Sans Flex SemiBold"/>
+                <a:ea typeface="Google Sans Flex SemiBold"/>
+                <a:cs typeface="Google Sans Flex SemiBold"/>
+                <a:sym typeface="Google Sans Flex SemiBold"/>
+              </a:rPr>
+              <a:t>What-If Simulator</a:t>
+            </a:r>
+            <a:endParaRPr lang="en-GB" sz="1200" dirty="0"/>
+          </a:p>
+          <a:p>
+            <a:pPr marL="0" indent="0" algn="l">
+              <a:lnSpc>
+                <a:spcPct val="105000"/>
+              </a:lnSpc>
+              <a:spcBef>
+                <a:spcPts val="0"/>
+              </a:spcBef>
+              <a:spcAft>
+                <a:spcPts val="0"/>
+              </a:spcAft>
+              <a:buNone/>
+            </a:pPr>
+            <a:r>
+              <a:rPr lang="en-GB" sz="1050" b="0" dirty="0">
+                <a:solidFill>
+                  <a:srgbClr val="5F6368"/>
+                </a:solidFill>
+                <a:latin typeface="Google Sans Flex"/>
+                <a:ea typeface="Google Sans Flex"/>
+                <a:cs typeface="Google Sans Flex"/>
+                <a:sym typeface="Google Sans Flex"/>
+              </a:rPr>
+              <a:t>Four plans compared; reroute to Line B + maintain scores 82.2 with no late units.</a:t>
+            </a:r>
+            <a:endParaRPr lang="en-GB" sz="1050" dirty="0"/>
+          </a:p>
+        </p:txBody>
+      </p:sp>
+      <p:pic>
+        <p:nvPicPr>
+          <p:cNvPr id="1007" name="Digital Twin in 3D" descr="Digital Twin in 3D"/>
+          <p:cNvPicPr>
+            <a:picLocks noChangeAspect="1"/>
+          </p:cNvPicPr>
+          <p:nvPr/>
+        </p:nvPicPr>
+        <p:blipFill>
+          <a:blip r:embed="rId8"/>
+          <a:stretch>
+            <a:fillRect/>
+          </a:stretch>
+        </p:blipFill>
+        <p:spPr>
+          <a:xfrm>
+            <a:off x="4645152" y="3073527"/>
+            <a:ext cx="2606040" cy="1628775"/>
+          </a:xfrm>
+          <a:prstGeom prst="roundRect">
+            <a:avLst>
+              <a:gd name="adj" fmla="val 2807"/>
+            </a:avLst>
+          </a:prstGeom>
+          <a:ln w="9525">
+            <a:solidFill>
+              <a:srgbClr val="DADCE0"/>
+            </a:solidFill>
+          </a:ln>
+          <a:effectLst>
+            <a:outerShdw blurRad="76200" dist="19050" dir="5400000" algn="t" rotWithShape="0">
+              <a:srgbClr val="000000">
+                <a:alpha val="16000"/>
+              </a:srgbClr>
+            </a:outerShdw>
+          </a:effectLst>
+        </p:spPr>
+      </p:pic>
+      <p:sp>
+        <p:nvSpPr>
+          <p:cNvPr id="1008" name="Digital Twin in 3D caption"/>
+          <p:cNvSpPr txBox="1"/>
+          <p:nvPr/>
+        </p:nvSpPr>
+        <p:spPr>
+          <a:xfrm>
+            <a:off x="7360920" y="3073527"/>
+            <a:ext cx="1417320" cy="1628775"/>
+          </a:xfrm>
+          <a:prstGeom prst="rect">
+            <a:avLst/>
+          </a:prstGeom>
+          <a:noFill/>
+          <a:ln>
+            <a:noFill/>
+          </a:ln>
+        </p:spPr>
+        <p:txBody>
+          <a:bodyPr wrap="square" lIns="0" tIns="0" rIns="0" bIns="0" anchor="ctr" rtlCol="0">
+            <a:noAutofit/>
+          </a:bodyPr>
+          <a:lstStyle/>
+          <a:p>
+            <a:pPr marL="0" indent="0" algn="l">
+              <a:spcBef>
+                <a:spcPts val="0"/>
+              </a:spcBef>
+              <a:spcAft>
+                <a:spcPts val="300"/>
+              </a:spcAft>
+              <a:buNone/>
+            </a:pPr>
+            <a:r>
+              <a:rPr lang="en-GB" sz="1200" b="0" dirty="0">
+                <a:solidFill>
+                  <a:srgbClr val="202124"/>
+                </a:solidFill>
+                <a:latin typeface="Google Sans Flex SemiBold"/>
+                <a:ea typeface="Google Sans Flex SemiBold"/>
+                <a:cs typeface="Google Sans Flex SemiBold"/>
+                <a:sym typeface="Google Sans Flex SemiBold"/>
+              </a:rPr>
+              <a:t>Digital Twin in 3D</a:t>
+            </a:r>
+            <a:endParaRPr lang="en-GB" sz="1200" dirty="0"/>
+          </a:p>
+          <a:p>
+            <a:pPr marL="0" indent="0" algn="l">
+              <a:lnSpc>
+                <a:spcPct val="105000"/>
+              </a:lnSpc>
+              <a:spcBef>
+                <a:spcPts val="0"/>
+              </a:spcBef>
+              <a:spcAft>
+                <a:spcPts val="0"/>
+              </a:spcAft>
+              <a:buNone/>
+            </a:pPr>
+            <a:r>
+              <a:rPr lang="en-GB" sz="1050" b="0" dirty="0">
+                <a:solidFill>
+                  <a:srgbClr val="5F6368"/>
+                </a:solidFill>
+                <a:latin typeface="Google Sans Flex"/>
+                <a:ea typeface="Google Sans Flex"/>
+                <a:cs typeface="Google Sans Flex"/>
+                <a:sym typeface="Google Sans Flex"/>
+              </a:rPr>
+              <a:t>Orbit the live plant; robots animate and the recommended path is highlighted.</a:t>
+            </a:r>
+            <a:endParaRPr lang="en-GB" sz="1050" dirty="0"/>
+          </a:p>
+        </p:txBody>
+      </p:sp>
+    </p:spTree>
+  </p:cSld>
+  <p:clrMapOvr>
+    <a:masterClrMapping/>
+  </p:clrMapOvr>
+</p:sld>
+</file>
+
+<file path=ppt/slides/slide9.xml><?xml version="1.0" encoding="utf-8"?>
+<p:sld xmlns:a="http://schemas.openxmlformats.org/drawingml/2006/main" xmlns:r="http://schemas.openxmlformats.org/officeDocument/2006/relationships" xmlns:mc="http://schemas.openxmlformats.org/markup-compatibility/2006" xmlns:mv="urn:schemas-microsoft-com:mac:vml" xmlns:p="http://schemas.openxmlformats.org/presentationml/2006/main" xmlns:c="http://schemas.openxmlformats.org/drawingml/2006/chart" xmlns:dgm="http://schemas.openxmlformats.org/drawingml/2006/diagram" xmlns:o="urn:schemas-microsoft-com:office:office" xmlns:v="urn:schemas-microsoft-com:vml" xmlns:pvml="urn:schemas-microsoft-com:office:powerpoint" xmlns:com="http://schemas.openxmlformats.org/drawingml/2006/compatibility" xmlns:p14="http://schemas.microsoft.com/office/powerpoint/2010/main" xmlns:p15="http://schemas.microsoft.com/office/powerpoint/2012/main" xmlns:ahyp="http://schemas.microsoft.com/office/drawing/2018/hyperlinkcolor">
+  <p:cSld>
+    <p:spTree>
+      <p:nvGrpSpPr>
+        <p:cNvPr id="131" name="Shape 131"/>
+        <p:cNvGrpSpPr/>
+        <p:nvPr/>
+      </p:nvGrpSpPr>
+      <p:grpSpPr>
+        <a:xfrm>
+          <a:off x="0" y="0"/>
+          <a:ext cx="0" cy="0"/>
+          <a:chOff x="0" y="0"/>
+          <a:chExt cx="0" cy="0"/>
+        </a:xfrm>
+      </p:grpSpPr>
+      <p:pic>
+        <p:nvPicPr>
+          <p:cNvPr id="132" name="Google Shape;132;p23" title="Frame 144.png"/>
+          <p:cNvPicPr preferRelativeResize="0"/>
+          <p:nvPr/>
+        </p:nvPicPr>
+        <p:blipFill rotWithShape="1">
+          <a:blip r:embed="rId3">
+            <a:alphaModFix/>
+          </a:blip>
+          <a:srcRect b="98001" l="0" r="0" t="0"/>
+          <a:stretch/>
+        </p:blipFill>
+        <p:spPr>
+          <a:xfrm>
+            <a:off x="0" y="5093562"/>
+            <a:ext cx="9144000" cy="54275"/>
+          </a:xfrm>
+          <a:prstGeom prst="rect">
+            <a:avLst/>
+          </a:prstGeom>
+          <a:noFill/>
+          <a:ln>
+            <a:noFill/>
+          </a:ln>
+        </p:spPr>
+      </p:pic>
+      <p:pic>
+        <p:nvPicPr>
+          <p:cNvPr id="133" name="Google Shape;133;p23" title="Group 427319979.png"/>
+          <p:cNvPicPr preferRelativeResize="0"/>
+          <p:nvPr/>
+        </p:nvPicPr>
+        <p:blipFill>
+          <a:blip r:embed="rId4">
+            <a:alphaModFix/>
+          </a:blip>
+          <a:stretch>
+            <a:fillRect/>
+          </a:stretch>
+        </p:blipFill>
+        <p:spPr>
+          <a:xfrm>
+            <a:off x="0" y="1"/>
+            <a:ext cx="9144000" cy="507359"/>
+          </a:xfrm>
+          <a:prstGeom prst="rect">
+            <a:avLst/>
+          </a:prstGeom>
+          <a:noFill/>
+          <a:ln>
+            <a:noFill/>
+          </a:ln>
+        </p:spPr>
+      </p:pic>
+      <p:sp>
+        <p:nvSpPr>
+          <p:cNvPr id="134" name="Google Shape;134;p23"/>
+          <p:cNvSpPr/>
+          <p:nvPr/>
+        </p:nvSpPr>
+        <p:spPr>
+          <a:xfrm>
+            <a:off x="-29250" y="5071875"/>
+            <a:ext cx="9173400" cy="97800"/>
+          </a:xfrm>
+          <a:prstGeom prst="rect">
+            <a:avLst/>
+          </a:prstGeom>
+          <a:solidFill>
+            <a:schemeClr val="dk1"/>
+          </a:solidFill>
+          <a:ln>
+            <a:noFill/>
+          </a:ln>
+        </p:spPr>
+        <p:txBody>
+          <a:bodyPr anchorCtr="0" anchor="ctr" bIns="91425" lIns="91425" spcFirstLastPara="1" rIns="91425" wrap="square" tIns="91425">
+            <a:noAutofit/>
+          </a:bodyPr>
+          <a:lstStyle/>
+          <a:p>
+            <a:pPr indent="0" lvl="0" marL="0" rtl="0" algn="ctr">
+              <a:spcBef>
+                <a:spcPts val="0"/>
+              </a:spcBef>
+              <a:spcAft>
+                <a:spcPts val="0"/>
+              </a:spcAft>
+              <a:buNone/>
+            </a:pPr>
+            <a:r>
+              <a:t/>
+            </a:r>
+            <a:endParaRPr/>
+          </a:p>
+        </p:txBody>
+      </p:sp>
+      <p:sp>
+        <p:nvSpPr>
+          <p:cNvPr id="135" name="Google Shape;135;p23"/>
+          <p:cNvSpPr txBox="1"/>
+          <p:nvPr/>
+        </p:nvSpPr>
+        <p:spPr>
+          <a:xfrm>
+            <a:off x="265350" y="663825"/>
+            <a:ext cx="8943000" cy="461900"/>
+          </a:xfrm>
+          <a:prstGeom prst="rect">
+            <a:avLst/>
+          </a:prstGeom>
+          <a:noFill/>
+          <a:ln>
+            <a:noFill/>
+          </a:ln>
+        </p:spPr>
+        <p:txBody>
+          <a:bodyPr anchorCtr="0" anchor="t" bIns="91425" lIns="91425" spcFirstLastPara="1" rIns="91425" wrap="square" tIns="91425">
+            <a:noAutofit/>
+          </a:bodyPr>
+          <a:lstStyle/>
+          <a:p>
+            <a:pPr marL="0" indent="0" algn="l">
+              <a:spcBef>
+                <a:spcPts val="0"/>
+              </a:spcBef>
+              <a:spcAft>
+                <a:spcPts val="0"/>
+              </a:spcAft>
+              <a:buNone/>
+            </a:pPr>
+            <a:r>
+              <a:rPr lang="en-GB" sz="1600" b="0" dirty="0">
+                <a:solidFill>
+                  <a:srgbClr val="000000"/>
+                </a:solidFill>
+                <a:latin typeface="Google Sans Flex Medium"/>
+                <a:ea typeface="Google Sans Flex Medium"/>
+                <a:cs typeface="Google Sans Flex Medium"/>
+                <a:sym typeface="Google Sans Flex Medium"/>
+              </a:rPr>
+              <a:t>Snapshots of the prototype (2/2)</a:t>
+            </a:r>
+            <a:endParaRPr lang="en-GB" sz="1600" dirty="0"/>
+          </a:p>
+        </p:txBody>
+      </p:sp>
+      <p:pic>
+        <p:nvPicPr>
+          <p:cNvPr id="1001" name="Approvals" descr="Approvals"/>
+          <p:cNvPicPr>
+            <a:picLocks noChangeAspect="1"/>
+          </p:cNvPicPr>
+          <p:nvPr/>
+        </p:nvPicPr>
+        <p:blipFill>
+          <a:blip r:embed="rId5"/>
+          <a:stretch>
+            <a:fillRect/>
+          </a:stretch>
+        </p:blipFill>
+        <p:spPr>
+          <a:xfrm>
+            <a:off x="365760" y="1188720"/>
+            <a:ext cx="2606040" cy="1628775"/>
+          </a:xfrm>
+          <a:prstGeom prst="roundRect">
+            <a:avLst>
+              <a:gd name="adj" fmla="val 2807"/>
+            </a:avLst>
+          </a:prstGeom>
+          <a:ln w="9525">
+            <a:solidFill>
+              <a:srgbClr val="DADCE0"/>
+            </a:solidFill>
+          </a:ln>
+          <a:effectLst>
+            <a:outerShdw blurRad="76200" dist="19050" dir="5400000" algn="t" rotWithShape="0">
+              <a:srgbClr val="000000">
+                <a:alpha val="16000"/>
+              </a:srgbClr>
+            </a:outerShdw>
+          </a:effectLst>
+        </p:spPr>
+      </p:pic>
+      <p:sp>
+        <p:nvSpPr>
+          <p:cNvPr id="1002" name="Approvals caption"/>
+          <p:cNvSpPr txBox="1"/>
+          <p:nvPr/>
+        </p:nvSpPr>
+        <p:spPr>
+          <a:xfrm>
+            <a:off x="3081528" y="1188720"/>
+            <a:ext cx="1417320" cy="1628775"/>
+          </a:xfrm>
+          <a:prstGeom prst="rect">
+            <a:avLst/>
+          </a:prstGeom>
+          <a:noFill/>
+          <a:ln>
+            <a:noFill/>
+          </a:ln>
+        </p:spPr>
+        <p:txBody>
+          <a:bodyPr wrap="square" lIns="0" tIns="0" rIns="0" bIns="0" anchor="ctr" rtlCol="0">
+            <a:noAutofit/>
+          </a:bodyPr>
+          <a:lstStyle/>
+          <a:p>
+            <a:pPr marL="0" indent="0" algn="l">
+              <a:spcBef>
+                <a:spcPts val="0"/>
+              </a:spcBef>
+              <a:spcAft>
+                <a:spcPts val="300"/>
+              </a:spcAft>
+              <a:buNone/>
+            </a:pPr>
+            <a:r>
+              <a:rPr lang="en-GB" sz="1200" b="0" dirty="0">
+                <a:solidFill>
+                  <a:srgbClr val="202124"/>
+                </a:solidFill>
+                <a:latin typeface="Google Sans Flex SemiBold"/>
+                <a:ea typeface="Google Sans Flex SemiBold"/>
+                <a:cs typeface="Google Sans Flex SemiBold"/>
+                <a:sym typeface="Google Sans Flex SemiBold"/>
+              </a:rPr>
+              <a:t>Approvals</a:t>
+            </a:r>
+            <a:endParaRPr lang="en-GB" sz="1200" dirty="0"/>
+          </a:p>
+          <a:p>
+            <a:pPr marL="0" indent="0" algn="l">
+              <a:lnSpc>
+                <a:spcPct val="105000"/>
+              </a:lnSpc>
+              <a:spcBef>
+                <a:spcPts val="0"/>
+              </a:spcBef>
+              <a:spcAft>
+                <a:spcPts val="0"/>
+              </a:spcAft>
+              <a:buNone/>
+            </a:pPr>
+            <a:r>
+              <a:rPr lang="en-GB" sz="1050" b="0" dirty="0">
+                <a:solidFill>
+                  <a:srgbClr val="5F6368"/>
+                </a:solidFill>
+                <a:latin typeface="Google Sans Flex"/>
+                <a:ea typeface="Google Sans Flex"/>
+                <a:cs typeface="Google Sans Flex"/>
+                <a:sym typeface="Google Sans Flex"/>
+              </a:rPr>
+              <a:t>The approved plan ran: Line B took over and the failing robot is healthy again.</a:t>
+            </a:r>
+            <a:endParaRPr lang="en-GB" sz="1050" dirty="0"/>
+          </a:p>
+        </p:txBody>
+      </p:sp>
+      <p:pic>
+        <p:nvPicPr>
+          <p:cNvPr id="1003" name="Visual Quality" descr="Visual Quality"/>
+          <p:cNvPicPr>
+            <a:picLocks noChangeAspect="1"/>
+          </p:cNvPicPr>
+          <p:nvPr/>
+        </p:nvPicPr>
+        <p:blipFill>
+          <a:blip r:embed="rId6"/>
+          <a:stretch>
+            <a:fillRect/>
+          </a:stretch>
+        </p:blipFill>
+        <p:spPr>
+          <a:xfrm>
+            <a:off x="4645152" y="1188720"/>
+            <a:ext cx="2606040" cy="1628775"/>
+          </a:xfrm>
+          <a:prstGeom prst="roundRect">
+            <a:avLst>
+              <a:gd name="adj" fmla="val 2807"/>
+            </a:avLst>
+          </a:prstGeom>
+          <a:ln w="9525">
+            <a:solidFill>
+              <a:srgbClr val="DADCE0"/>
+            </a:solidFill>
+          </a:ln>
+          <a:effectLst>
+            <a:outerShdw blurRad="76200" dist="19050" dir="5400000" algn="t" rotWithShape="0">
+              <a:srgbClr val="000000">
+                <a:alpha val="16000"/>
+              </a:srgbClr>
+            </a:outerShdw>
+          </a:effectLst>
+        </p:spPr>
+      </p:pic>
+      <p:sp>
+        <p:nvSpPr>
+          <p:cNvPr id="1004" name="Visual Quality caption"/>
+          <p:cNvSpPr txBox="1"/>
+          <p:nvPr/>
+        </p:nvSpPr>
+        <p:spPr>
+          <a:xfrm>
+            <a:off x="7360920" y="1188720"/>
+            <a:ext cx="1417320" cy="1628775"/>
+          </a:xfrm>
+          <a:prstGeom prst="rect">
+            <a:avLst/>
+          </a:prstGeom>
+          <a:noFill/>
+          <a:ln>
+            <a:noFill/>
+          </a:ln>
+        </p:spPr>
+        <p:txBody>
+          <a:bodyPr wrap="square" lIns="0" tIns="0" rIns="0" bIns="0" anchor="ctr" rtlCol="0">
+            <a:noAutofit/>
+          </a:bodyPr>
+          <a:lstStyle/>
+          <a:p>
+            <a:pPr marL="0" indent="0" algn="l">
+              <a:spcBef>
+                <a:spcPts val="0"/>
+              </a:spcBef>
+              <a:spcAft>
+                <a:spcPts val="300"/>
+              </a:spcAft>
+              <a:buNone/>
+            </a:pPr>
+            <a:r>
+              <a:rPr lang="en-GB" sz="1200" b="0" dirty="0">
+                <a:solidFill>
+                  <a:srgbClr val="202124"/>
+                </a:solidFill>
+                <a:latin typeface="Google Sans Flex SemiBold"/>
+                <a:ea typeface="Google Sans Flex SemiBold"/>
+                <a:cs typeface="Google Sans Flex SemiBold"/>
+                <a:sym typeface="Google Sans Flex SemiBold"/>
+              </a:rPr>
+              <a:t>Visual Quality</a:t>
+            </a:r>
+            <a:endParaRPr lang="en-GB" sz="1200" dirty="0"/>
+          </a:p>
+          <a:p>
+            <a:pPr marL="0" indent="0" algn="l">
+              <a:lnSpc>
+                <a:spcPct val="105000"/>
+              </a:lnSpc>
+              <a:spcBef>
+                <a:spcPts val="0"/>
+              </a:spcBef>
+              <a:spcAft>
+                <a:spcPts val="0"/>
+              </a:spcAft>
+              <a:buNone/>
+            </a:pPr>
+            <a:r>
+              <a:rPr lang="en-GB" sz="1050" b="0" dirty="0">
+                <a:solidFill>
+                  <a:srgbClr val="5F6368"/>
+                </a:solidFill>
+                <a:latin typeface="Google Sans Flex"/>
+                <a:ea typeface="Google Sans Flex"/>
+                <a:cs typeface="Google Sans Flex"/>
+                <a:sym typeface="Google Sans Flex"/>
+              </a:rPr>
+              <a:t>FPY, DPMO and defect Pareto; robot vibration tracks Line A rejects (r = 0.89).</a:t>
+            </a:r>
+            <a:endParaRPr lang="en-GB" sz="1050" dirty="0"/>
+          </a:p>
+        </p:txBody>
+      </p:sp>
+      <p:pic>
+        <p:nvPicPr>
+          <p:cNvPr id="1005" name="Twin Builder" descr="Twin Builder"/>
+          <p:cNvPicPr>
+            <a:picLocks noChangeAspect="1"/>
+          </p:cNvPicPr>
+          <p:nvPr/>
+        </p:nvPicPr>
+        <p:blipFill>
+          <a:blip r:embed="rId7"/>
+          <a:stretch>
+            <a:fillRect/>
+          </a:stretch>
+        </p:blipFill>
+        <p:spPr>
+          <a:xfrm>
+            <a:off x="365760" y="3073527"/>
+            <a:ext cx="2606040" cy="1628775"/>
+          </a:xfrm>
+          <a:prstGeom prst="roundRect">
+            <a:avLst>
+              <a:gd name="adj" fmla="val 2807"/>
+            </a:avLst>
+          </a:prstGeom>
+          <a:ln w="9525">
+            <a:solidFill>
+              <a:srgbClr val="DADCE0"/>
+            </a:solidFill>
+          </a:ln>
+          <a:effectLst>
+            <a:outerShdw blurRad="76200" dist="19050" dir="5400000" algn="t" rotWithShape="0">
+              <a:srgbClr val="000000">
+                <a:alpha val="16000"/>
+              </a:srgbClr>
+            </a:outerShdw>
+          </a:effectLst>
+        </p:spPr>
+      </p:pic>
+      <p:sp>
+        <p:nvSpPr>
+          <p:cNvPr id="1006" name="Twin Builder caption"/>
+          <p:cNvSpPr txBox="1"/>
+          <p:nvPr/>
+        </p:nvSpPr>
+        <p:spPr>
+          <a:xfrm>
+            <a:off x="3081528" y="3073527"/>
+            <a:ext cx="1417320" cy="1628775"/>
+          </a:xfrm>
+          <a:prstGeom prst="rect">
+            <a:avLst/>
+          </a:prstGeom>
+          <a:noFill/>
+          <a:ln>
+            <a:noFill/>
+          </a:ln>
+        </p:spPr>
+        <p:txBody>
+          <a:bodyPr wrap="square" lIns="0" tIns="0" rIns="0" bIns="0" anchor="ctr" rtlCol="0">
+            <a:noAutofit/>
+          </a:bodyPr>
+          <a:lstStyle/>
+          <a:p>
+            <a:pPr marL="0" indent="0" algn="l">
+              <a:spcBef>
+                <a:spcPts val="0"/>
+              </a:spcBef>
+              <a:spcAft>
+                <a:spcPts val="300"/>
+              </a:spcAft>
+              <a:buNone/>
+            </a:pPr>
+            <a:r>
+              <a:rPr lang="en-GB" sz="1200" b="0" dirty="0">
+                <a:solidFill>
+                  <a:srgbClr val="202124"/>
+                </a:solidFill>
+                <a:latin typeface="Google Sans Flex SemiBold"/>
+                <a:ea typeface="Google Sans Flex SemiBold"/>
+                <a:cs typeface="Google Sans Flex SemiBold"/>
+                <a:sym typeface="Google Sans Flex SemiBold"/>
+              </a:rPr>
+              <a:t>Twin Builder</a:t>
+            </a:r>
+            <a:endParaRPr lang="en-GB" sz="1200" dirty="0"/>
+          </a:p>
+          <a:p>
+            <a:pPr marL="0" indent="0" algn="l">
+              <a:lnSpc>
+                <a:spcPct val="105000"/>
+              </a:lnSpc>
+              <a:spcBef>
+                <a:spcPts val="0"/>
+              </a:spcBef>
+              <a:spcAft>
+                <a:spcPts val="0"/>
+              </a:spcAft>
+              <a:buNone/>
+            </a:pPr>
+            <a:r>
+              <a:rPr lang="en-GB" sz="1050" b="0" dirty="0">
+                <a:solidFill>
+                  <a:srgbClr val="5F6368"/>
+                </a:solidFill>
+                <a:latin typeface="Google Sans Flex"/>
+                <a:ea typeface="Google Sans Flex"/>
+                <a:cs typeface="Google Sans Flex"/>
+                <a:sym typeface="Google Sans Flex"/>
+              </a:rPr>
+              <a:t>Review screen with stages, provenance counts and a live layout preview.</a:t>
+            </a:r>
+            <a:endParaRPr lang="en-GB" sz="1050" dirty="0"/>
+          </a:p>
+        </p:txBody>
+      </p:sp>
+      <p:pic>
+        <p:nvPicPr>
+          <p:cNvPr id="1007" name="Playground" descr="Playground"/>
+          <p:cNvPicPr>
+            <a:picLocks noChangeAspect="1"/>
+          </p:cNvPicPr>
+          <p:nvPr/>
+        </p:nvPicPr>
+        <p:blipFill>
+          <a:blip r:embed="rId8"/>
+          <a:stretch>
+            <a:fillRect/>
+          </a:stretch>
+        </p:blipFill>
+        <p:spPr>
+          <a:xfrm>
+            <a:off x="4645152" y="3073527"/>
+            <a:ext cx="2606040" cy="1628775"/>
+          </a:xfrm>
+          <a:prstGeom prst="roundRect">
+            <a:avLst>
+              <a:gd name="adj" fmla="val 2807"/>
+            </a:avLst>
+          </a:prstGeom>
+          <a:ln w="9525">
+            <a:solidFill>
+              <a:srgbClr val="DADCE0"/>
+            </a:solidFill>
+          </a:ln>
+          <a:effectLst>
+            <a:outerShdw blurRad="76200" dist="19050" dir="5400000" algn="t" rotWithShape="0">
+              <a:srgbClr val="000000">
+                <a:alpha val="16000"/>
+              </a:srgbClr>
+            </a:outerShdw>
+          </a:effectLst>
+        </p:spPr>
+      </p:pic>
+      <p:sp>
+        <p:nvSpPr>
+          <p:cNvPr id="1008" name="Playground caption"/>
+          <p:cNvSpPr txBox="1"/>
+          <p:nvPr/>
+        </p:nvSpPr>
+        <p:spPr>
+          <a:xfrm>
+            <a:off x="7360920" y="3073527"/>
+            <a:ext cx="1417320" cy="1628775"/>
+          </a:xfrm>
+          <a:prstGeom prst="rect">
+            <a:avLst/>
+          </a:prstGeom>
+          <a:noFill/>
+          <a:ln>
+            <a:noFill/>
+          </a:ln>
+        </p:spPr>
+        <p:txBody>
+          <a:bodyPr wrap="square" lIns="0" tIns="0" rIns="0" bIns="0" anchor="ctr" rtlCol="0">
+            <a:noAutofit/>
+          </a:bodyPr>
+          <a:lstStyle/>
+          <a:p>
+            <a:pPr marL="0" indent="0" algn="l">
+              <a:spcBef>
+                <a:spcPts val="0"/>
+              </a:spcBef>
+              <a:spcAft>
+                <a:spcPts val="300"/>
+              </a:spcAft>
+              <a:buNone/>
+            </a:pPr>
+            <a:r>
+              <a:rPr lang="en-GB" sz="1200" b="0" dirty="0">
+                <a:solidFill>
+                  <a:srgbClr val="202124"/>
+                </a:solidFill>
+                <a:latin typeface="Google Sans Flex SemiBold"/>
+                <a:ea typeface="Google Sans Flex SemiBold"/>
+                <a:cs typeface="Google Sans Flex SemiBold"/>
+                <a:sym typeface="Google Sans Flex SemiBold"/>
+              </a:rPr>
+              <a:t>Playground</a:t>
+            </a:r>
+            <a:endParaRPr lang="en-GB" sz="1200" dirty="0"/>
+          </a:p>
+          <a:p>
+            <a:pPr marL="0" indent="0" algn="l">
+              <a:lnSpc>
+                <a:spcPct val="105000"/>
+              </a:lnSpc>
+              <a:spcBef>
+                <a:spcPts val="0"/>
+              </a:spcBef>
+              <a:spcAft>
+                <a:spcPts val="0"/>
+              </a:spcAft>
+              <a:buNone/>
+            </a:pPr>
+            <a:r>
+              <a:rPr lang="en-GB" sz="1050" b="0" dirty="0">
+                <a:solidFill>
+                  <a:srgbClr val="5F6368"/>
+                </a:solidFill>
+                <a:latin typeface="Google Sans Flex"/>
+                <a:ea typeface="Google Sans Flex"/>
+                <a:cs typeface="Google Sans Flex"/>
+                <a:sym typeface="Google Sans Flex"/>
+              </a:rPr>
+              <a:t>Place machines and robots on the floor and set automation rules.</a:t>
+            </a:r>
+            <a:endParaRPr lang="en-GB" sz="1050" dirty="0"/>
           </a:p>
         </p:txBody>
       </p:sp>

</xml_diff>

<commit_message>
docs: update core principle across presentation deck and architecture documentation
</commit_message>
<xml_diff>
--- a/docs/TwinForge_AI_Builder_Cup.pptx
+++ b/docs/TwinForge_AI_Builder_Cup.pptx
@@ -11992,8 +11992,8 @@
         </p:nvSpPr>
         <p:spPr>
           <a:xfrm>
-            <a:off x="5166360" y="3500000"/>
-            <a:ext cx="3611880" cy="1350000"/>
+            <a:off x="5166360" y="3480000"/>
+            <a:ext cx="3611880" cy="1420000"/>
           </a:xfrm>
           <a:prstGeom prst="roundRect">
             <a:avLst>
@@ -12008,7 +12008,7 @@
           </a:ln>
         </p:spPr>
         <p:txBody>
-          <a:bodyPr wrap="square" lIns="152400" tIns="127000" rIns="152400" bIns="127000" anchor="ctr" rtlCol="0">
+          <a:bodyPr wrap="square" lIns="152400" tIns="101600" rIns="152400" bIns="101600" anchor="ctr" rtlCol="0">
             <a:noAutofit/>
           </a:bodyPr>
           <a:lstStyle/>
@@ -12018,7 +12018,7 @@
                 <a:spcPts val="0"/>
               </a:spcBef>
               <a:spcAft>
-                <a:spcPts val="400"/>
+                <a:spcPts val="300"/>
               </a:spcAft>
               <a:buNone/>
               <a:defRPr sz="1000" b="1">
@@ -12041,7 +12041,7 @@
               <a:spcAft>
                 <a:spcPts val="600"/>
               </a:spcAft>
-              <a:defRPr sz="950">
+              <a:defRPr sz="900">
                 <a:solidFill>
                   <a:srgbClr val="202124"/>
                 </a:solidFill>
@@ -12054,13 +12054,22 @@
           </a:p>
           <a:p>
             <a:r>
-              <a:rPr sz="800" i="1">
+              <a:rPr sz="800" b="1">
                 <a:solidFill>
-                  <a:srgbClr val="5F6368"/>
+                  <a:srgbClr val="1A73E8"/>
                 </a:solidFill>
                 <a:latin typeface="Google Sans Flex"/>
               </a:rPr>
-              <a:t>OUR PRINCIPLE: Language models explain, extract and orchestrate. Numbers come from code. Decisions come from people.</a:t>
+              <a:t>OUR PRINCIPLE: </a:t>
+            </a:r>
+            <a:r>
+              <a:rPr sz="800" i="1">
+                <a:solidFill>
+                  <a:srgbClr val="3C4043"/>
+                </a:solidFill>
+                <a:latin typeface="Google Sans Flex"/>
+              </a:rPr>
+              <a:t>Language models explain, extract and orchestrate. Numbers come from configured rules. Suggestions come from the ontology. Decisions come from people.</a:t>
             </a:r>
           </a:p>
         </p:txBody>
@@ -13087,16 +13096,13 @@
               <a:buChar char="•"/>
             </a:pPr>
             <a:r>
-              <a:rPr lang="en-GB" sz="1150" b="0" dirty="0">
+              <a:rPr sz="1150">
                 <a:solidFill>
                   <a:srgbClr val="3C4043"/>
                 </a:solidFill>
                 <a:latin typeface="Google Sans Flex"/>
-                <a:ea typeface="Google Sans Flex"/>
-                <a:cs typeface="Google Sans Flex"/>
-                <a:sym typeface="Google Sans Flex"/>
               </a:rPr>
-              <a:t>Models explain, code computes, people decide: every figure the AI states is checked against computed results.</a:t>
+              <a:t>Models explain, configured rules compute, ontology suggests, people decide: every figure the AI states is checked against configured rules.</a:t>
             </a:r>
             <a:endParaRPr lang="en-GB" sz="1150" dirty="0"/>
           </a:p>

</xml_diff>

<commit_message>
docs: move Action framework below capabilities on Slide 2 and make Principle card prominent and larger
</commit_message>
<xml_diff>
--- a/docs/TwinForge_AI_Builder_Cup.pptx
+++ b/docs/TwinForge_AI_Builder_Cup.pptx
@@ -11904,8 +11904,8 @@
         </p:nvSpPr>
         <p:spPr>
           <a:xfrm>
-            <a:off x="365760" y="1801368"/>
-            <a:ext cx="4572000" cy="777240"/>
+            <a:off x="365760" y="1750000"/>
+            <a:ext cx="4572000" cy="580000"/>
           </a:xfrm>
           <a:prstGeom prst="rect">
             <a:avLst/>
@@ -11932,7 +11932,7 @@
                 <a:spcPts val="0"/>
               </a:spcAft>
               <a:buNone/>
-              <a:defRPr sz="1100">
+              <a:defRPr sz="1050">
                 <a:solidFill>
                   <a:srgbClr val="3C4043"/>
                 </a:solidFill>
@@ -11992,8 +11992,8 @@
         </p:nvSpPr>
         <p:spPr>
           <a:xfrm>
-            <a:off x="5166360" y="3480000"/>
-            <a:ext cx="3611880" cy="1420000"/>
+            <a:off x="5166360" y="3520000"/>
+            <a:ext cx="3611880" cy="1350000"/>
           </a:xfrm>
           <a:prstGeom prst="roundRect">
             <a:avLst>
@@ -12003,12 +12003,14 @@
           <a:solidFill>
             <a:srgbClr val="E8F0FE"/>
           </a:solidFill>
-          <a:ln>
-            <a:noFill/>
-          </a:ln>
-        </p:spPr>
-        <p:txBody>
-          <a:bodyPr wrap="square" lIns="152400" tIns="101600" rIns="152400" bIns="101600" anchor="ctr" rtlCol="0">
+          <a:ln w="12700">
+            <a:solidFill>
+              <a:srgbClr val="D2E3FC"/>
+            </a:solidFill>
+          </a:ln>
+        </p:spPr>
+        <p:txBody>
+          <a:bodyPr wrap="square" lIns="203200" tIns="177800" rIns="203200" bIns="177800" anchor="ctr" rtlCol="0">
             <a:noAutofit/>
           </a:bodyPr>
           <a:lstStyle/>
@@ -12018,10 +12020,10 @@
                 <a:spcPts val="0"/>
               </a:spcBef>
               <a:spcAft>
-                <a:spcPts val="300"/>
-              </a:spcAft>
-              <a:buNone/>
-              <a:defRPr sz="1000" b="1">
+                <a:spcPts val="800"/>
+              </a:spcAft>
+              <a:buNone/>
+              <a:defRPr sz="1150" b="1">
                 <a:solidFill>
                   <a:srgbClr val="1A73E8"/>
                 </a:solidFill>
@@ -12029,47 +12031,72 @@
               </a:defRPr>
             </a:pPr>
             <a:r>
-              <a:t>SEE. UNDERSTAND. SIMULATE. ACT.</a:t>
+              <a:t>OUR PRINCIPLE</a:t>
             </a:r>
             <a:endParaRPr lang="en-GB" sz="950" dirty="0"/>
           </a:p>
           <a:p>
             <a:pPr>
-              <a:lnSpc>
-                <a:spcPct val="115000"/>
-              </a:lnSpc>
-              <a:spcAft>
-                <a:spcPts val="600"/>
-              </a:spcAft>
-              <a:defRPr sz="900">
+              <a:spcAft>
+                <a:spcPts val="300"/>
+              </a:spcAft>
+            </a:pPr>
+            <a:r>
+              <a:rPr sz="1050" b="0">
                 <a:solidFill>
                   <a:srgbClr val="202124"/>
                 </a:solidFill>
                 <a:latin typeface="Google Sans Flex"/>
-              </a:defRPr>
+              </a:rPr>
+              <a:t>Language models explain, extract and orchestrate.</a:t>
+            </a:r>
+          </a:p>
+          <a:p>
+            <a:pPr>
+              <a:spcAft>
+                <a:spcPts val="300"/>
+              </a:spcAft>
             </a:pPr>
             <a:r>
-              <a:t>Explore a live digital twin, investigate incidents with six specialist AI agents, simulate alternative scenarios, and execute approved actions only after human authorization.</a:t>
+              <a:rPr sz="1050" b="0">
+                <a:solidFill>
+                  <a:srgbClr val="202124"/>
+                </a:solidFill>
+                <a:latin typeface="Google Sans Flex"/>
+              </a:rPr>
+              <a:t>Numbers come from configured rules.</a:t>
             </a:r>
           </a:p>
           <a:p>
+            <a:pPr>
+              <a:spcAft>
+                <a:spcPts val="300"/>
+              </a:spcAft>
+            </a:pPr>
             <a:r>
-              <a:rPr sz="800" b="1">
+              <a:rPr sz="1050" b="0">
+                <a:solidFill>
+                  <a:srgbClr val="202124"/>
+                </a:solidFill>
+                <a:latin typeface="Google Sans Flex"/>
+              </a:rPr>
+              <a:t>Suggestions come from the ontology.</a:t>
+            </a:r>
+          </a:p>
+          <a:p>
+            <a:pPr>
+              <a:spcAft>
+                <a:spcPts val="300"/>
+              </a:spcAft>
+            </a:pPr>
+            <a:r>
+              <a:rPr sz="1050" b="1">
                 <a:solidFill>
                   <a:srgbClr val="1A73E8"/>
                 </a:solidFill>
                 <a:latin typeface="Google Sans Flex"/>
               </a:rPr>
-              <a:t>OUR PRINCIPLE: </a:t>
-            </a:r>
-            <a:r>
-              <a:rPr sz="800" i="1">
-                <a:solidFill>
-                  <a:srgbClr val="3C4043"/>
-                </a:solidFill>
-                <a:latin typeface="Google Sans Flex"/>
-              </a:rPr>
-              <a:t>Language models explain, extract and orchestrate. Numbers come from configured rules. Suggestions come from the ontology. Decisions come from people.</a:t>
+              <a:t>Decisions come from people.</a:t>
             </a:r>
           </a:p>
         </p:txBody>
@@ -12082,8 +12109,8 @@
         </p:nvSpPr>
         <p:spPr>
           <a:xfrm>
-            <a:off x="365760" y="2580000"/>
-            <a:ext cx="4572000" cy="2200000"/>
+            <a:off x="365760" y="2380000"/>
+            <a:ext cx="4572000" cy="2500000"/>
           </a:xfrm>
           <a:prstGeom prst="rect">
             <a:avLst/>
@@ -12098,9 +12125,9 @@
           <a:p>
             <a:pPr>
               <a:spcAft>
-                <a:spcPts val="800"/>
-              </a:spcAft>
-              <a:defRPr sz="1150" b="1">
+                <a:spcPts val="500"/>
+              </a:spcAft>
+              <a:defRPr sz="1100" b="1">
                 <a:solidFill>
                   <a:srgbClr val="1A73E8"/>
                 </a:solidFill>
@@ -12114,11 +12141,11 @@
           <a:p>
             <a:pPr>
               <a:spcAft>
-                <a:spcPts val="700"/>
+                <a:spcPts val="400"/>
               </a:spcAft>
             </a:pPr>
             <a:r>
-              <a:rPr sz="1000" b="1">
+              <a:rPr sz="950" b="1">
                 <a:solidFill>
                   <a:srgbClr val="202124"/>
                 </a:solidFill>
@@ -12127,7 +12154,7 @@
               <a:t>•  Predictive Maintenance — </a:t>
             </a:r>
             <a:r>
-              <a:rPr sz="1000" b="0">
+              <a:rPr sz="950" b="0">
                 <a:solidFill>
                   <a:srgbClr val="5F6368"/>
                 </a:solidFill>
@@ -12139,11 +12166,11 @@
           <a:p>
             <a:pPr>
               <a:spcAft>
-                <a:spcPts val="700"/>
+                <a:spcPts val="400"/>
               </a:spcAft>
             </a:pPr>
             <a:r>
-              <a:rPr sz="1000" b="1">
+              <a:rPr sz="950" b="1">
                 <a:solidFill>
                   <a:srgbClr val="202124"/>
                 </a:solidFill>
@@ -12152,7 +12179,7 @@
               <a:t>•  Demand Forecasting — </a:t>
             </a:r>
             <a:r>
-              <a:rPr sz="1000" b="0">
+              <a:rPr sz="950" b="0">
                 <a:solidFill>
                   <a:srgbClr val="5F6368"/>
                 </a:solidFill>
@@ -12164,11 +12191,11 @@
           <a:p>
             <a:pPr>
               <a:spcAft>
-                <a:spcPts val="700"/>
+                <a:spcPts val="400"/>
               </a:spcAft>
             </a:pPr>
             <a:r>
-              <a:rPr sz="1000" b="1">
+              <a:rPr sz="950" b="1">
                 <a:solidFill>
                   <a:srgbClr val="202124"/>
                 </a:solidFill>
@@ -12177,7 +12204,7 @@
               <a:t>•  Supply Chain Intelligence — </a:t>
             </a:r>
             <a:r>
-              <a:rPr sz="1000" b="0">
+              <a:rPr sz="950" b="0">
                 <a:solidFill>
                   <a:srgbClr val="5F6368"/>
                 </a:solidFill>
@@ -12189,11 +12216,11 @@
           <a:p>
             <a:pPr>
               <a:spcAft>
-                <a:spcPts val="700"/>
+                <a:spcPts val="400"/>
               </a:spcAft>
             </a:pPr>
             <a:r>
-              <a:rPr sz="1000" b="1">
+              <a:rPr sz="950" b="1">
                 <a:solidFill>
                   <a:srgbClr val="202124"/>
                 </a:solidFill>
@@ -12202,13 +12229,48 @@
               <a:t>•  Visual Quality Inspection — </a:t>
             </a:r>
             <a:r>
-              <a:rPr sz="1000" b="0">
+              <a:rPr sz="950" b="0">
                 <a:solidFill>
                   <a:srgbClr val="5F6368"/>
                 </a:solidFill>
                 <a:latin typeface="Google Sans Flex"/>
               </a:rPr>
               <a:t>Detect defects, improve first-pass yield, and reduce quality losses.</a:t>
+            </a:r>
+          </a:p>
+          <a:p>
+            <a:pPr>
+              <a:spcBef>
+                <a:spcPts val="800"/>
+              </a:spcBef>
+              <a:spcAft>
+                <a:spcPts val="300"/>
+              </a:spcAft>
+            </a:pPr>
+            <a:r>
+              <a:rPr sz="1100" b="1">
+                <a:solidFill>
+                  <a:srgbClr val="1A73E8"/>
+                </a:solidFill>
+                <a:latin typeface="Google Sans Flex"/>
+              </a:rPr>
+              <a:t>See. Understand. Simulate. Act.</a:t>
+            </a:r>
+          </a:p>
+          <a:p>
+            <a:pPr>
+              <a:lnSpc>
+                <a:spcPct val="115000"/>
+              </a:lnSpc>
+            </a:pPr>
+            <a:r>
+              <a:rPr sz="950">
+                <a:solidFill>
+                  <a:srgbClr val="3C4043"/>
+                </a:solidFill>
+                <a:latin typeface="Google Sans Flex"/>
+              </a:rPr>
+              <a:t>Explore a live digital twin, investigate incidents with six specialist AI agents, simulate alternative scenarios, and execute approved actions only after human authorization.</a:t>
             </a:r>
           </a:p>
         </p:txBody>

</xml_diff>

<commit_message>
docs: update Feature 2 (AI Operations) on Slide 4 with the 4 core capabilities
</commit_message>
<xml_diff>
--- a/docs/TwinForge_AI_Builder_Cup.pptx
+++ b/docs/TwinForge_AI_Builder_Cup.pptx
@@ -13748,8 +13748,8 @@
         </p:nvSpPr>
         <p:spPr>
           <a:xfrm>
-            <a:off x="3378708" y="1664208"/>
-            <a:ext cx="2395728" cy="566928"/>
+            <a:off x="3378708" y="1610000"/>
+            <a:ext cx="2395728" cy="620000"/>
           </a:xfrm>
           <a:prstGeom prst="rect">
             <a:avLst/>
@@ -13767,7 +13767,7 @@
           <a:p>
             <a:pPr marL="0" indent="0" algn="l">
               <a:lnSpc>
-                <a:spcPct val="105000"/>
+                <a:spcPct val="112000"/>
               </a:lnSpc>
               <a:spcBef>
                 <a:spcPts val="0"/>
@@ -13776,18 +13776,15 @@
                 <a:spcPts val="0"/>
               </a:spcAft>
               <a:buNone/>
-            </a:pPr>
-            <a:r>
-              <a:rPr lang="en-GB" sz="1050" b="0" dirty="0">
+              <a:defRPr sz="819">
                 <a:solidFill>
                   <a:srgbClr val="5F6368"/>
                 </a:solidFill>
                 <a:latin typeface="Google Sans Flex"/>
-                <a:ea typeface="Google Sans Flex"/>
-                <a:cs typeface="Google Sans Flex"/>
-                <a:sym typeface="Google Sans Flex"/>
-              </a:rPr>
-              <a:t>Six specialist agents stream findings with evidence, from observe to recommend.</a:t>
+              </a:defRPr>
+            </a:pPr>
+            <a:r>
+              <a:t>Predictive Maintenance to anticipate equipment failures, Demand Forecasting to optimize production planning, Supply Chain Intelligence to identify disruptions, and Visual Quality Inspection to detect defects and improve quality.</a:t>
             </a:r>
             <a:endParaRPr lang="en-GB" sz="1050" dirty="0"/>
           </a:p>

</xml_diff>

<commit_message>
docs: adjust Feature 2 description and font size to match other cards on Slide 4
</commit_message>
<xml_diff>
--- a/docs/TwinForge_AI_Builder_Cup.pptx
+++ b/docs/TwinForge_AI_Builder_Cup.pptx
@@ -13748,8 +13748,8 @@
         </p:nvSpPr>
         <p:spPr>
           <a:xfrm>
-            <a:off x="3378708" y="1610000"/>
-            <a:ext cx="2395728" cy="620000"/>
+            <a:off x="3378708" y="1590000"/>
+            <a:ext cx="2395728" cy="640000"/>
           </a:xfrm>
           <a:prstGeom prst="rect">
             <a:avLst/>
@@ -13767,7 +13767,7 @@
           <a:p>
             <a:pPr marL="0" indent="0" algn="l">
               <a:lnSpc>
-                <a:spcPct val="112000"/>
+                <a:spcPct val="115000"/>
               </a:lnSpc>
               <a:spcBef>
                 <a:spcPts val="0"/>
@@ -13784,7 +13784,13 @@
               </a:defRPr>
             </a:pPr>
             <a:r>
-              <a:t>Predictive Maintenance to anticipate equipment failures, Demand Forecasting to optimize production planning, Supply Chain Intelligence to identify disruptions, and Visual Quality Inspection to detect defects and improve quality.</a:t>
+              <a:rPr sz="950">
+                <a:solidFill>
+                  <a:srgbClr val="5F6368"/>
+                </a:solidFill>
+                <a:latin typeface="Google Sans Flex"/>
+              </a:rPr>
+              <a:t>Predictive Maintenance to anticipate equipment failures, Demand Forecasting to optimize production planning, and Supply Chain Intelligence to identify disruptions.</a:t>
             </a:r>
             <a:endParaRPr lang="en-GB" sz="1050" dirty="0"/>
           </a:p>

</xml_diff>

<commit_message>
docs: add Slide 7 with 4 individual feature architecture diagrams
</commit_message>
<xml_diff>
--- a/docs/TwinForge_AI_Builder_Cup.pptx
+++ b/docs/TwinForge_AI_Builder_Cup.pptx
@@ -14,6 +14,7 @@
     <p:sldId id="260" r:id="rId10"/>
     <p:sldId id="261" r:id="rId11"/>
     <p:sldId id="263" r:id="rId13"/>
+    <p:sldId id="273" r:id="rId20"/>
     <p:sldId id="264" r:id="rId14"/>
     <p:sldId id="266" r:id="rId16"/>
     <p:sldId id="272" r:id="rId28"/>
@@ -11658,6 +11659,247 @@
 </p:sld>
 </file>
 
+<file path=ppt/slides/slide14.xml><?xml version="1.0" encoding="utf-8"?>
+<p:sld xmlns:a="http://schemas.openxmlformats.org/drawingml/2006/main" xmlns:p="http://schemas.openxmlformats.org/presentationml/2006/main" xmlns:r="http://schemas.openxmlformats.org/officeDocument/2006/relationships">
+  <p:cSld>
+    <p:spTree>
+      <p:nvGrpSpPr>
+        <p:cNvPr id="1" name=""/>
+        <p:cNvGrpSpPr/>
+        <p:nvPr/>
+      </p:nvGrpSpPr>
+      <p:grpSpPr/>
+      <p:pic>
+        <p:nvPicPr>
+          <p:cNvPr id="2" name="Picture 1" descr="image.png"/>
+          <p:cNvPicPr>
+            <a:picLocks noChangeAspect="1"/>
+          </p:cNvPicPr>
+          <p:nvPr/>
+        </p:nvPicPr>
+        <p:blipFill>
+          <a:blip r:embed="rId2"/>
+          <a:stretch>
+            <a:fillRect/>
+          </a:stretch>
+        </p:blipFill>
+        <p:spPr>
+          <a:xfrm>
+            <a:off x="0" y="1"/>
+            <a:ext cx="9144000" cy="507359"/>
+          </a:xfrm>
+          <a:prstGeom prst="rect">
+            <a:avLst/>
+          </a:prstGeom>
+        </p:spPr>
+      </p:pic>
+      <p:pic>
+        <p:nvPicPr>
+          <p:cNvPr id="3" name="Picture 2" descr="image.png"/>
+          <p:cNvPicPr>
+            <a:picLocks noChangeAspect="1"/>
+          </p:cNvPicPr>
+          <p:nvPr/>
+        </p:nvPicPr>
+        <p:blipFill>
+          <a:blip r:embed="rId3"/>
+          <a:stretch>
+            <a:fillRect/>
+          </a:stretch>
+        </p:blipFill>
+        <p:spPr>
+          <a:xfrm>
+            <a:off x="0" y="5093562"/>
+            <a:ext cx="9144000" cy="54275"/>
+          </a:xfrm>
+          <a:prstGeom prst="rect">
+            <a:avLst/>
+          </a:prstGeom>
+        </p:spPr>
+      </p:pic>
+      <p:sp>
+        <p:nvSpPr>
+          <p:cNvPr id="110" name="Google Shape;110;p20"/>
+          <p:cNvSpPr/>
+          <p:nvPr/>
+        </p:nvSpPr>
+        <p:spPr>
+          <a:xfrm>
+            <a:off x="-29250" y="5071875"/>
+            <a:ext cx="9173400" cy="97800"/>
+          </a:xfrm>
+          <a:prstGeom prst="rect">
+            <a:avLst/>
+          </a:prstGeom>
+          <a:solidFill>
+            <a:schemeClr val="dk1"/>
+          </a:solidFill>
+          <a:ln>
+            <a:noFill/>
+          </a:ln>
+        </p:spPr>
+        <p:txBody>
+          <a:bodyPr anchorCtr="0" anchor="ctr" bIns="91425" lIns="91425" spcFirstLastPara="1" rIns="91425" wrap="square" tIns="91425">
+            <a:noAutofit/>
+          </a:bodyPr>
+          <a:lstStyle/>
+          <a:p>
+            <a:pPr indent="0" lvl="0" marL="0" rtl="0" algn="ctr">
+              <a:spcBef>
+                <a:spcPts val="0"/>
+              </a:spcBef>
+              <a:spcAft>
+                <a:spcPts val="0"/>
+              </a:spcAft>
+              <a:buNone/>
+            </a:pPr>
+            <a:r>
+              <a:t/>
+            </a:r>
+            <a:endParaRPr/>
+          </a:p>
+        </p:txBody>
+      </p:sp>
+      <p:sp>
+        <p:nvSpPr>
+          <p:cNvPr id="111" name="TextBox 110"/>
+          <p:cNvSpPr txBox="1"/>
+          <p:nvPr/>
+        </p:nvSpPr>
+        <p:spPr>
+          <a:xfrm>
+            <a:off x="265350" y="663825"/>
+            <a:ext cx="8943000" cy="461900"/>
+          </a:xfrm>
+          <a:prstGeom prst="rect">
+            <a:avLst/>
+          </a:prstGeom>
+          <a:noFill/>
+        </p:spPr>
+        <p:txBody>
+          <a:bodyPr wrap="none">
+            <a:spAutoFit/>
+          </a:bodyPr>
+          <a:lstStyle/>
+          <a:p>
+            <a:pPr>
+              <a:defRPr sz="1600">
+                <a:solidFill>
+                  <a:srgbClr val="000000"/>
+                </a:solidFill>
+                <a:latin typeface="Google Sans Flex"/>
+              </a:defRPr>
+            </a:pPr>
+            <a:r>
+              <a:t>Architecture diagrams of individual features</a:t>
+            </a:r>
+          </a:p>
+        </p:txBody>
+      </p:sp>
+      <p:pic>
+        <p:nvPicPr>
+          <p:cNvPr id="112" name="Picture 111" descr="predictive_maintenance_architecture.jpg"/>
+          <p:cNvPicPr>
+            <a:picLocks noChangeAspect="1"/>
+          </p:cNvPicPr>
+          <p:nvPr/>
+        </p:nvPicPr>
+        <p:blipFill>
+          <a:blip r:embed="rId4"/>
+          <a:stretch>
+            <a:fillRect/>
+          </a:stretch>
+        </p:blipFill>
+        <p:spPr>
+          <a:xfrm>
+            <a:off x="1629303" y="1140000"/>
+            <a:ext cx="2762697" cy="1840000"/>
+          </a:xfrm>
+          <a:prstGeom prst="rect">
+            <a:avLst/>
+          </a:prstGeom>
+        </p:spPr>
+      </p:pic>
+      <p:pic>
+        <p:nvPicPr>
+          <p:cNvPr id="113" name="Picture 112" descr="demand_forecasting_architecture.jpg"/>
+          <p:cNvPicPr>
+            <a:picLocks noChangeAspect="1"/>
+          </p:cNvPicPr>
+          <p:nvPr/>
+        </p:nvPicPr>
+        <p:blipFill>
+          <a:blip r:embed="rId5"/>
+          <a:stretch>
+            <a:fillRect/>
+          </a:stretch>
+        </p:blipFill>
+        <p:spPr>
+          <a:xfrm>
+            <a:off x="4752000" y="1140000"/>
+            <a:ext cx="2762697" cy="1840000"/>
+          </a:xfrm>
+          <a:prstGeom prst="rect">
+            <a:avLst/>
+          </a:prstGeom>
+        </p:spPr>
+      </p:pic>
+      <p:pic>
+        <p:nvPicPr>
+          <p:cNvPr id="114" name="Picture 113" descr="supply_chain_intelligence_architecture.jpg"/>
+          <p:cNvPicPr>
+            <a:picLocks noChangeAspect="1"/>
+          </p:cNvPicPr>
+          <p:nvPr/>
+        </p:nvPicPr>
+        <p:blipFill>
+          <a:blip r:embed="rId6"/>
+          <a:stretch>
+            <a:fillRect/>
+          </a:stretch>
+        </p:blipFill>
+        <p:spPr>
+          <a:xfrm>
+            <a:off x="1629303" y="3080000"/>
+            <a:ext cx="2762697" cy="1840000"/>
+          </a:xfrm>
+          <a:prstGeom prst="rect">
+            <a:avLst/>
+          </a:prstGeom>
+        </p:spPr>
+      </p:pic>
+      <p:pic>
+        <p:nvPicPr>
+          <p:cNvPr id="115" name="Picture 114" descr="visual_quality_inspection_architecture.jpg"/>
+          <p:cNvPicPr>
+            <a:picLocks noChangeAspect="1"/>
+          </p:cNvPicPr>
+          <p:nvPr/>
+        </p:nvPicPr>
+        <p:blipFill>
+          <a:blip r:embed="rId7"/>
+          <a:stretch>
+            <a:fillRect/>
+          </a:stretch>
+        </p:blipFill>
+        <p:spPr>
+          <a:xfrm>
+            <a:off x="4752000" y="3080000"/>
+            <a:ext cx="2762697" cy="1840000"/>
+          </a:xfrm>
+          <a:prstGeom prst="rect">
+            <a:avLst/>
+          </a:prstGeom>
+        </p:spPr>
+      </p:pic>
+    </p:spTree>
+  </p:cSld>
+  <p:clrMapOvr>
+    <a:masterClrMapping/>
+  </p:clrMapOvr>
+</p:sld>
+</file>
+
 <file path=ppt/slides/slide2.xml><?xml version="1.0" encoding="utf-8"?>
 <p:sld xmlns:a="http://schemas.openxmlformats.org/drawingml/2006/main" xmlns:r="http://schemas.openxmlformats.org/officeDocument/2006/relationships" xmlns:mc="http://schemas.openxmlformats.org/markup-compatibility/2006" xmlns:mv="urn:schemas-microsoft-com:mac:vml" xmlns:p="http://schemas.openxmlformats.org/presentationml/2006/main" xmlns:c="http://schemas.openxmlformats.org/drawingml/2006/chart" xmlns:dgm="http://schemas.openxmlformats.org/drawingml/2006/diagram" xmlns:o="urn:schemas-microsoft-com:office:office" xmlns:v="urn:schemas-microsoft-com:vml" xmlns:pvml="urn:schemas-microsoft-com:office:powerpoint" xmlns:com="http://schemas.openxmlformats.org/drawingml/2006/compatibility" xmlns:p14="http://schemas.microsoft.com/office/powerpoint/2010/main" xmlns:p15="http://schemas.microsoft.com/office/powerpoint/2012/main" xmlns:ahyp="http://schemas.microsoft.com/office/drawing/2018/hyperlinkcolor">
   <p:cSld>

</xml_diff>

<commit_message>
docs: split feature architecture diagrams across 2 slides side-by-side for improved legibility
</commit_message>
<xml_diff>
--- a/docs/TwinForge_AI_Builder_Cup.pptx
+++ b/docs/TwinForge_AI_Builder_Cup.pptx
@@ -15,6 +15,7 @@
     <p:sldId id="261" r:id="rId11"/>
     <p:sldId id="263" r:id="rId13"/>
     <p:sldId id="273" r:id="rId20"/>
+    <p:sldId id="274" r:id="rId15"/>
     <p:sldId id="264" r:id="rId14"/>
     <p:sldId id="266" r:id="rId16"/>
     <p:sldId id="272" r:id="rId28"/>
@@ -6846,6 +6847,639 @@
 </file>
 
 <file path=ppt/slides/slide10.xml><?xml version="1.0" encoding="utf-8"?>
+<p:sld xmlns:a="http://schemas.openxmlformats.org/drawingml/2006/main" xmlns:r="http://schemas.openxmlformats.org/officeDocument/2006/relationships" xmlns:mc="http://schemas.openxmlformats.org/markup-compatibility/2006" xmlns:mv="urn:schemas-microsoft-com:mac:vml" xmlns:p="http://schemas.openxmlformats.org/presentationml/2006/main" xmlns:c="http://schemas.openxmlformats.org/drawingml/2006/chart" xmlns:dgm="http://schemas.openxmlformats.org/drawingml/2006/diagram" xmlns:o="urn:schemas-microsoft-com:office:office" xmlns:v="urn:schemas-microsoft-com:vml" xmlns:pvml="urn:schemas-microsoft-com:office:powerpoint" xmlns:com="http://schemas.openxmlformats.org/drawingml/2006/compatibility" xmlns:p14="http://schemas.microsoft.com/office/powerpoint/2010/main" xmlns:p15="http://schemas.microsoft.com/office/powerpoint/2012/main" xmlns:ahyp="http://schemas.microsoft.com/office/drawing/2018/hyperlinkcolor">
+  <p:cSld>
+    <p:spTree>
+      <p:nvGrpSpPr>
+        <p:cNvPr id="131" name="Shape 131"/>
+        <p:cNvGrpSpPr/>
+        <p:nvPr/>
+      </p:nvGrpSpPr>
+      <p:grpSpPr>
+        <a:xfrm>
+          <a:off x="0" y="0"/>
+          <a:ext cx="0" cy="0"/>
+          <a:chOff x="0" y="0"/>
+          <a:chExt cx="0" cy="0"/>
+        </a:xfrm>
+      </p:grpSpPr>
+      <p:pic>
+        <p:nvPicPr>
+          <p:cNvPr id="132" name="Google Shape;132;p23" title="Frame 144.png"/>
+          <p:cNvPicPr preferRelativeResize="0"/>
+          <p:nvPr/>
+        </p:nvPicPr>
+        <p:blipFill rotWithShape="1">
+          <a:blip r:embed="rId3">
+            <a:alphaModFix/>
+          </a:blip>
+          <a:srcRect b="98001" l="0" r="0" t="0"/>
+          <a:stretch/>
+        </p:blipFill>
+        <p:spPr>
+          <a:xfrm>
+            <a:off x="0" y="5093562"/>
+            <a:ext cx="9144000" cy="54275"/>
+          </a:xfrm>
+          <a:prstGeom prst="rect">
+            <a:avLst/>
+          </a:prstGeom>
+          <a:noFill/>
+          <a:ln>
+            <a:noFill/>
+          </a:ln>
+        </p:spPr>
+      </p:pic>
+      <p:pic>
+        <p:nvPicPr>
+          <p:cNvPr id="133" name="Google Shape;133;p23" title="Group 427319979.png"/>
+          <p:cNvPicPr preferRelativeResize="0"/>
+          <p:nvPr/>
+        </p:nvPicPr>
+        <p:blipFill>
+          <a:blip r:embed="rId4">
+            <a:alphaModFix/>
+          </a:blip>
+          <a:stretch>
+            <a:fillRect/>
+          </a:stretch>
+        </p:blipFill>
+        <p:spPr>
+          <a:xfrm>
+            <a:off x="0" y="1"/>
+            <a:ext cx="9144000" cy="507359"/>
+          </a:xfrm>
+          <a:prstGeom prst="rect">
+            <a:avLst/>
+          </a:prstGeom>
+          <a:noFill/>
+          <a:ln>
+            <a:noFill/>
+          </a:ln>
+        </p:spPr>
+      </p:pic>
+      <p:sp>
+        <p:nvSpPr>
+          <p:cNvPr id="134" name="Google Shape;134;p23"/>
+          <p:cNvSpPr/>
+          <p:nvPr/>
+        </p:nvSpPr>
+        <p:spPr>
+          <a:xfrm>
+            <a:off x="-29250" y="5071875"/>
+            <a:ext cx="9173400" cy="97800"/>
+          </a:xfrm>
+          <a:prstGeom prst="rect">
+            <a:avLst/>
+          </a:prstGeom>
+          <a:solidFill>
+            <a:schemeClr val="dk1"/>
+          </a:solidFill>
+          <a:ln>
+            <a:noFill/>
+          </a:ln>
+        </p:spPr>
+        <p:txBody>
+          <a:bodyPr anchorCtr="0" anchor="ctr" bIns="91425" lIns="91425" spcFirstLastPara="1" rIns="91425" wrap="square" tIns="91425">
+            <a:noAutofit/>
+          </a:bodyPr>
+          <a:lstStyle/>
+          <a:p>
+            <a:pPr indent="0" lvl="0" marL="0" rtl="0" algn="ctr">
+              <a:spcBef>
+                <a:spcPts val="0"/>
+              </a:spcBef>
+              <a:spcAft>
+                <a:spcPts val="0"/>
+              </a:spcAft>
+              <a:buNone/>
+            </a:pPr>
+            <a:r>
+              <a:t/>
+            </a:r>
+            <a:endParaRPr/>
+          </a:p>
+        </p:txBody>
+      </p:sp>
+      <p:sp>
+        <p:nvSpPr>
+          <p:cNvPr id="135" name="Google Shape;135;p23"/>
+          <p:cNvSpPr txBox="1"/>
+          <p:nvPr/>
+        </p:nvSpPr>
+        <p:spPr>
+          <a:xfrm>
+            <a:off x="265350" y="663825"/>
+            <a:ext cx="8943000" cy="461900"/>
+          </a:xfrm>
+          <a:prstGeom prst="rect">
+            <a:avLst/>
+          </a:prstGeom>
+          <a:noFill/>
+          <a:ln>
+            <a:noFill/>
+          </a:ln>
+        </p:spPr>
+        <p:txBody>
+          <a:bodyPr anchorCtr="0" anchor="t" bIns="91425" lIns="91425" spcFirstLastPara="1" rIns="91425" wrap="square" tIns="91425">
+            <a:noAutofit/>
+          </a:bodyPr>
+          <a:lstStyle/>
+          <a:p>
+            <a:pPr marL="0" indent="0" algn="l">
+              <a:spcBef>
+                <a:spcPts val="0"/>
+              </a:spcBef>
+              <a:spcAft>
+                <a:spcPts val="0"/>
+              </a:spcAft>
+              <a:buNone/>
+            </a:pPr>
+            <a:r>
+              <a:rPr lang="en-GB" sz="1600" b="0" dirty="0">
+                <a:solidFill>
+                  <a:srgbClr val="000000"/>
+                </a:solidFill>
+                <a:latin typeface="Google Sans Flex Medium"/>
+                <a:ea typeface="Google Sans Flex Medium"/>
+                <a:cs typeface="Google Sans Flex Medium"/>
+                <a:sym typeface="Google Sans Flex Medium"/>
+              </a:rPr>
+              <a:t>Snapshots of the prototype (2/2)</a:t>
+            </a:r>
+            <a:endParaRPr lang="en-GB" sz="1600" dirty="0"/>
+          </a:p>
+        </p:txBody>
+      </p:sp>
+      <p:pic>
+        <p:nvPicPr>
+          <p:cNvPr id="1001" name="Approvals" descr="Approvals"/>
+          <p:cNvPicPr>
+            <a:picLocks noChangeAspect="1"/>
+          </p:cNvPicPr>
+          <p:nvPr/>
+        </p:nvPicPr>
+        <p:blipFill>
+          <a:blip r:embed="rId5"/>
+          <a:stretch>
+            <a:fillRect/>
+          </a:stretch>
+        </p:blipFill>
+        <p:spPr>
+          <a:xfrm>
+            <a:off x="365760" y="1188720"/>
+            <a:ext cx="2606040" cy="1628775"/>
+          </a:xfrm>
+          <a:prstGeom prst="roundRect">
+            <a:avLst>
+              <a:gd name="adj" fmla="val 2807"/>
+            </a:avLst>
+          </a:prstGeom>
+          <a:ln w="9525">
+            <a:solidFill>
+              <a:srgbClr val="DADCE0"/>
+            </a:solidFill>
+          </a:ln>
+          <a:effectLst>
+            <a:outerShdw blurRad="76200" dist="19050" dir="5400000" algn="t" rotWithShape="0">
+              <a:srgbClr val="000000">
+                <a:alpha val="16000"/>
+              </a:srgbClr>
+            </a:outerShdw>
+          </a:effectLst>
+        </p:spPr>
+      </p:pic>
+      <p:sp>
+        <p:nvSpPr>
+          <p:cNvPr id="1002" name="Approvals caption"/>
+          <p:cNvSpPr txBox="1"/>
+          <p:nvPr/>
+        </p:nvSpPr>
+        <p:spPr>
+          <a:xfrm>
+            <a:off x="3081528" y="1188720"/>
+            <a:ext cx="1417320" cy="1628775"/>
+          </a:xfrm>
+          <a:prstGeom prst="rect">
+            <a:avLst/>
+          </a:prstGeom>
+          <a:noFill/>
+          <a:ln>
+            <a:noFill/>
+          </a:ln>
+        </p:spPr>
+        <p:txBody>
+          <a:bodyPr wrap="square" lIns="0" tIns="0" rIns="0" bIns="0" anchor="ctr" rtlCol="0">
+            <a:noAutofit/>
+          </a:bodyPr>
+          <a:lstStyle/>
+          <a:p>
+            <a:pPr marL="0" indent="0" algn="l">
+              <a:spcBef>
+                <a:spcPts val="0"/>
+              </a:spcBef>
+              <a:spcAft>
+                <a:spcPts val="300"/>
+              </a:spcAft>
+              <a:buNone/>
+            </a:pPr>
+            <a:r>
+              <a:rPr lang="en-GB" sz="1200" b="0" dirty="0">
+                <a:solidFill>
+                  <a:srgbClr val="202124"/>
+                </a:solidFill>
+                <a:latin typeface="Google Sans Flex SemiBold"/>
+                <a:ea typeface="Google Sans Flex SemiBold"/>
+                <a:cs typeface="Google Sans Flex SemiBold"/>
+                <a:sym typeface="Google Sans Flex SemiBold"/>
+              </a:rPr>
+              <a:t>Approvals</a:t>
+            </a:r>
+            <a:endParaRPr lang="en-GB" sz="1200" dirty="0"/>
+          </a:p>
+          <a:p>
+            <a:pPr marL="0" indent="0" algn="l">
+              <a:lnSpc>
+                <a:spcPct val="105000"/>
+              </a:lnSpc>
+              <a:spcBef>
+                <a:spcPts val="0"/>
+              </a:spcBef>
+              <a:spcAft>
+                <a:spcPts val="0"/>
+              </a:spcAft>
+              <a:buNone/>
+            </a:pPr>
+            <a:r>
+              <a:rPr lang="en-GB" sz="1050" b="0" dirty="0">
+                <a:solidFill>
+                  <a:srgbClr val="5F6368"/>
+                </a:solidFill>
+                <a:latin typeface="Google Sans Flex"/>
+                <a:ea typeface="Google Sans Flex"/>
+                <a:cs typeface="Google Sans Flex"/>
+                <a:sym typeface="Google Sans Flex"/>
+              </a:rPr>
+              <a:t>The approved plan ran: Line B took over and the failing robot is healthy again.</a:t>
+            </a:r>
+            <a:endParaRPr lang="en-GB" sz="1050" dirty="0"/>
+          </a:p>
+        </p:txBody>
+      </p:sp>
+      <p:pic>
+        <p:nvPicPr>
+          <p:cNvPr id="1003" name="Visual Quality" descr="Visual Quality"/>
+          <p:cNvPicPr>
+            <a:picLocks noChangeAspect="1"/>
+          </p:cNvPicPr>
+          <p:nvPr/>
+        </p:nvPicPr>
+        <p:blipFill>
+          <a:blip r:embed="rId6"/>
+          <a:stretch>
+            <a:fillRect/>
+          </a:stretch>
+        </p:blipFill>
+        <p:spPr>
+          <a:xfrm>
+            <a:off x="4645152" y="1188720"/>
+            <a:ext cx="2606040" cy="1628775"/>
+          </a:xfrm>
+          <a:prstGeom prst="roundRect">
+            <a:avLst>
+              <a:gd name="adj" fmla="val 2807"/>
+            </a:avLst>
+          </a:prstGeom>
+          <a:ln w="9525">
+            <a:solidFill>
+              <a:srgbClr val="DADCE0"/>
+            </a:solidFill>
+          </a:ln>
+          <a:effectLst>
+            <a:outerShdw blurRad="76200" dist="19050" dir="5400000" algn="t" rotWithShape="0">
+              <a:srgbClr val="000000">
+                <a:alpha val="16000"/>
+              </a:srgbClr>
+            </a:outerShdw>
+          </a:effectLst>
+        </p:spPr>
+      </p:pic>
+      <p:sp>
+        <p:nvSpPr>
+          <p:cNvPr id="1004" name="Visual Quality caption"/>
+          <p:cNvSpPr txBox="1"/>
+          <p:nvPr/>
+        </p:nvSpPr>
+        <p:spPr>
+          <a:xfrm>
+            <a:off x="7360920" y="1188720"/>
+            <a:ext cx="1417320" cy="1628775"/>
+          </a:xfrm>
+          <a:prstGeom prst="rect">
+            <a:avLst/>
+          </a:prstGeom>
+          <a:noFill/>
+          <a:ln>
+            <a:noFill/>
+          </a:ln>
+        </p:spPr>
+        <p:txBody>
+          <a:bodyPr wrap="square" lIns="0" tIns="0" rIns="0" bIns="0" anchor="ctr" rtlCol="0">
+            <a:noAutofit/>
+          </a:bodyPr>
+          <a:lstStyle/>
+          <a:p>
+            <a:pPr marL="0" indent="0" algn="l">
+              <a:spcBef>
+                <a:spcPts val="0"/>
+              </a:spcBef>
+              <a:spcAft>
+                <a:spcPts val="300"/>
+              </a:spcAft>
+              <a:buNone/>
+            </a:pPr>
+            <a:r>
+              <a:rPr lang="en-GB" sz="1200" b="0" dirty="0">
+                <a:solidFill>
+                  <a:srgbClr val="202124"/>
+                </a:solidFill>
+                <a:latin typeface="Google Sans Flex SemiBold"/>
+                <a:ea typeface="Google Sans Flex SemiBold"/>
+                <a:cs typeface="Google Sans Flex SemiBold"/>
+                <a:sym typeface="Google Sans Flex SemiBold"/>
+              </a:rPr>
+              <a:t>Visual Quality</a:t>
+            </a:r>
+            <a:endParaRPr lang="en-GB" sz="1200" dirty="0"/>
+          </a:p>
+          <a:p>
+            <a:pPr marL="0" indent="0" algn="l">
+              <a:lnSpc>
+                <a:spcPct val="105000"/>
+              </a:lnSpc>
+              <a:spcBef>
+                <a:spcPts val="0"/>
+              </a:spcBef>
+              <a:spcAft>
+                <a:spcPts val="0"/>
+              </a:spcAft>
+              <a:buNone/>
+            </a:pPr>
+            <a:r>
+              <a:rPr lang="en-GB" sz="1050" b="0" dirty="0">
+                <a:solidFill>
+                  <a:srgbClr val="5F6368"/>
+                </a:solidFill>
+                <a:latin typeface="Google Sans Flex"/>
+                <a:ea typeface="Google Sans Flex"/>
+                <a:cs typeface="Google Sans Flex"/>
+                <a:sym typeface="Google Sans Flex"/>
+              </a:rPr>
+              <a:t>FPY, DPMO and defect Pareto; robot vibration tracks Line A rejects (r = 0.89).</a:t>
+            </a:r>
+            <a:endParaRPr lang="en-GB" sz="1050" dirty="0"/>
+          </a:p>
+        </p:txBody>
+      </p:sp>
+      <p:pic>
+        <p:nvPicPr>
+          <p:cNvPr id="1005" name="Twin Builder" descr="Twin Builder"/>
+          <p:cNvPicPr>
+            <a:picLocks noChangeAspect="1"/>
+          </p:cNvPicPr>
+          <p:nvPr/>
+        </p:nvPicPr>
+        <p:blipFill>
+          <a:blip r:embed="rId7"/>
+          <a:stretch>
+            <a:fillRect/>
+          </a:stretch>
+        </p:blipFill>
+        <p:spPr>
+          <a:xfrm>
+            <a:off x="365760" y="3073527"/>
+            <a:ext cx="2606040" cy="1628775"/>
+          </a:xfrm>
+          <a:prstGeom prst="roundRect">
+            <a:avLst>
+              <a:gd name="adj" fmla="val 2807"/>
+            </a:avLst>
+          </a:prstGeom>
+          <a:ln w="9525">
+            <a:solidFill>
+              <a:srgbClr val="DADCE0"/>
+            </a:solidFill>
+          </a:ln>
+          <a:effectLst>
+            <a:outerShdw blurRad="76200" dist="19050" dir="5400000" algn="t" rotWithShape="0">
+              <a:srgbClr val="000000">
+                <a:alpha val="16000"/>
+              </a:srgbClr>
+            </a:outerShdw>
+          </a:effectLst>
+        </p:spPr>
+      </p:pic>
+      <p:sp>
+        <p:nvSpPr>
+          <p:cNvPr id="1006" name="Twin Builder caption"/>
+          <p:cNvSpPr txBox="1"/>
+          <p:nvPr/>
+        </p:nvSpPr>
+        <p:spPr>
+          <a:xfrm>
+            <a:off x="3081528" y="3073527"/>
+            <a:ext cx="1417320" cy="1628775"/>
+          </a:xfrm>
+          <a:prstGeom prst="rect">
+            <a:avLst/>
+          </a:prstGeom>
+          <a:noFill/>
+          <a:ln>
+            <a:noFill/>
+          </a:ln>
+        </p:spPr>
+        <p:txBody>
+          <a:bodyPr wrap="square" lIns="0" tIns="0" rIns="0" bIns="0" anchor="ctr" rtlCol="0">
+            <a:noAutofit/>
+          </a:bodyPr>
+          <a:lstStyle/>
+          <a:p>
+            <a:pPr marL="0" indent="0" algn="l">
+              <a:spcBef>
+                <a:spcPts val="0"/>
+              </a:spcBef>
+              <a:spcAft>
+                <a:spcPts val="300"/>
+              </a:spcAft>
+              <a:buNone/>
+            </a:pPr>
+            <a:r>
+              <a:rPr lang="en-GB" sz="1200" b="0" dirty="0">
+                <a:solidFill>
+                  <a:srgbClr val="202124"/>
+                </a:solidFill>
+                <a:latin typeface="Google Sans Flex SemiBold"/>
+                <a:ea typeface="Google Sans Flex SemiBold"/>
+                <a:cs typeface="Google Sans Flex SemiBold"/>
+                <a:sym typeface="Google Sans Flex SemiBold"/>
+              </a:rPr>
+              <a:t>Twin Builder</a:t>
+            </a:r>
+            <a:endParaRPr lang="en-GB" sz="1200" dirty="0"/>
+          </a:p>
+          <a:p>
+            <a:pPr marL="0" indent="0" algn="l">
+              <a:lnSpc>
+                <a:spcPct val="105000"/>
+              </a:lnSpc>
+              <a:spcBef>
+                <a:spcPts val="0"/>
+              </a:spcBef>
+              <a:spcAft>
+                <a:spcPts val="0"/>
+              </a:spcAft>
+              <a:buNone/>
+            </a:pPr>
+            <a:r>
+              <a:rPr lang="en-GB" sz="1050" b="0" dirty="0">
+                <a:solidFill>
+                  <a:srgbClr val="5F6368"/>
+                </a:solidFill>
+                <a:latin typeface="Google Sans Flex"/>
+                <a:ea typeface="Google Sans Flex"/>
+                <a:cs typeface="Google Sans Flex"/>
+                <a:sym typeface="Google Sans Flex"/>
+              </a:rPr>
+              <a:t>Review screen with stages, provenance counts and a live layout preview.</a:t>
+            </a:r>
+            <a:endParaRPr lang="en-GB" sz="1050" dirty="0"/>
+          </a:p>
+        </p:txBody>
+      </p:sp>
+      <p:pic>
+        <p:nvPicPr>
+          <p:cNvPr id="1007" name="Playground" descr="Playground"/>
+          <p:cNvPicPr>
+            <a:picLocks noChangeAspect="1"/>
+          </p:cNvPicPr>
+          <p:nvPr/>
+        </p:nvPicPr>
+        <p:blipFill>
+          <a:blip r:embed="rId8"/>
+          <a:stretch>
+            <a:fillRect/>
+          </a:stretch>
+        </p:blipFill>
+        <p:spPr>
+          <a:xfrm>
+            <a:off x="4645152" y="3073527"/>
+            <a:ext cx="2606040" cy="1628775"/>
+          </a:xfrm>
+          <a:prstGeom prst="roundRect">
+            <a:avLst>
+              <a:gd name="adj" fmla="val 2807"/>
+            </a:avLst>
+          </a:prstGeom>
+          <a:ln w="9525">
+            <a:solidFill>
+              <a:srgbClr val="DADCE0"/>
+            </a:solidFill>
+          </a:ln>
+          <a:effectLst>
+            <a:outerShdw blurRad="76200" dist="19050" dir="5400000" algn="t" rotWithShape="0">
+              <a:srgbClr val="000000">
+                <a:alpha val="16000"/>
+              </a:srgbClr>
+            </a:outerShdw>
+          </a:effectLst>
+        </p:spPr>
+      </p:pic>
+      <p:sp>
+        <p:nvSpPr>
+          <p:cNvPr id="1008" name="Playground caption"/>
+          <p:cNvSpPr txBox="1"/>
+          <p:nvPr/>
+        </p:nvSpPr>
+        <p:spPr>
+          <a:xfrm>
+            <a:off x="7360920" y="3073527"/>
+            <a:ext cx="1417320" cy="1628775"/>
+          </a:xfrm>
+          <a:prstGeom prst="rect">
+            <a:avLst/>
+          </a:prstGeom>
+          <a:noFill/>
+          <a:ln>
+            <a:noFill/>
+          </a:ln>
+        </p:spPr>
+        <p:txBody>
+          <a:bodyPr wrap="square" lIns="0" tIns="0" rIns="0" bIns="0" anchor="ctr" rtlCol="0">
+            <a:noAutofit/>
+          </a:bodyPr>
+          <a:lstStyle/>
+          <a:p>
+            <a:pPr marL="0" indent="0" algn="l">
+              <a:spcBef>
+                <a:spcPts val="0"/>
+              </a:spcBef>
+              <a:spcAft>
+                <a:spcPts val="300"/>
+              </a:spcAft>
+              <a:buNone/>
+            </a:pPr>
+            <a:r>
+              <a:rPr lang="en-GB" sz="1200" b="0" dirty="0">
+                <a:solidFill>
+                  <a:srgbClr val="202124"/>
+                </a:solidFill>
+                <a:latin typeface="Google Sans Flex SemiBold"/>
+                <a:ea typeface="Google Sans Flex SemiBold"/>
+                <a:cs typeface="Google Sans Flex SemiBold"/>
+                <a:sym typeface="Google Sans Flex SemiBold"/>
+              </a:rPr>
+              <a:t>Playground</a:t>
+            </a:r>
+            <a:endParaRPr lang="en-GB" sz="1200" dirty="0"/>
+          </a:p>
+          <a:p>
+            <a:pPr marL="0" indent="0" algn="l">
+              <a:lnSpc>
+                <a:spcPct val="105000"/>
+              </a:lnSpc>
+              <a:spcBef>
+                <a:spcPts val="0"/>
+              </a:spcBef>
+              <a:spcAft>
+                <a:spcPts val="0"/>
+              </a:spcAft>
+              <a:buNone/>
+            </a:pPr>
+            <a:r>
+              <a:rPr lang="en-GB" sz="1050" b="0" dirty="0">
+                <a:solidFill>
+                  <a:srgbClr val="5F6368"/>
+                </a:solidFill>
+                <a:latin typeface="Google Sans Flex"/>
+                <a:ea typeface="Google Sans Flex"/>
+                <a:cs typeface="Google Sans Flex"/>
+                <a:sym typeface="Google Sans Flex"/>
+              </a:rPr>
+              <a:t>Place machines and robots on the floor and set automation rules.</a:t>
+            </a:r>
+            <a:endParaRPr lang="en-GB" sz="1050" dirty="0"/>
+          </a:p>
+        </p:txBody>
+      </p:sp>
+    </p:spTree>
+  </p:cSld>
+  <p:clrMapOvr>
+    <a:masterClrMapping/>
+  </p:clrMapOvr>
+</p:sld>
+</file>
+
+<file path=ppt/slides/slide11.xml><?xml version="1.0" encoding="utf-8"?>
 <p:sld xmlns:a="http://schemas.openxmlformats.org/drawingml/2006/main" xmlns:r="http://schemas.openxmlformats.org/officeDocument/2006/relationships" xmlns:mc="http://schemas.openxmlformats.org/markup-compatibility/2006" xmlns:mv="urn:schemas-microsoft-com:mac:vml" xmlns:p="http://schemas.openxmlformats.org/presentationml/2006/main" xmlns:c="http://schemas.openxmlformats.org/drawingml/2006/chart" xmlns:dgm="http://schemas.openxmlformats.org/drawingml/2006/diagram" xmlns:o="urn:schemas-microsoft-com:office:office" xmlns:v="urn:schemas-microsoft-com:vml" xmlns:pvml="urn:schemas-microsoft-com:office:powerpoint" xmlns:com="http://schemas.openxmlformats.org/drawingml/2006/compatibility" xmlns:p14="http://schemas.microsoft.com/office/powerpoint/2010/main" xmlns:p15="http://schemas.microsoft.com/office/powerpoint/2012/main" xmlns:ahyp="http://schemas.microsoft.com/office/drawing/2018/hyperlinkcolor">
   <p:cSld>
     <p:spTree>
@@ -9530,7 +10164,7 @@
 </p:sld>
 </file>
 
-<file path=ppt/slides/slide11.xml><?xml version="1.0" encoding="utf-8"?>
+<file path=ppt/slides/slide12.xml><?xml version="1.0" encoding="utf-8"?>
 <p:sld xmlns:a="http://schemas.openxmlformats.org/drawingml/2006/main" xmlns:r="http://schemas.openxmlformats.org/officeDocument/2006/relationships" xmlns:mc="http://schemas.openxmlformats.org/markup-compatibility/2006" xmlns:mv="urn:schemas-microsoft-com:mac:vml" xmlns:p="http://schemas.openxmlformats.org/presentationml/2006/main" xmlns:c="http://schemas.openxmlformats.org/drawingml/2006/chart" xmlns:dgm="http://schemas.openxmlformats.org/drawingml/2006/diagram" xmlns:o="urn:schemas-microsoft-com:office:office" xmlns:v="urn:schemas-microsoft-com:vml" xmlns:pvml="urn:schemas-microsoft-com:office:powerpoint" xmlns:com="http://schemas.openxmlformats.org/drawingml/2006/compatibility" xmlns:p14="http://schemas.microsoft.com/office/powerpoint/2010/main" xmlns:p15="http://schemas.microsoft.com/office/powerpoint/2012/main" xmlns:ahyp="http://schemas.microsoft.com/office/drawing/2018/hyperlinkcolor">
   <p:cSld>
     <p:spTree>
@@ -10837,7 +11471,7 @@
 </p:sld>
 </file>
 
-<file path=ppt/slides/slide12.xml><?xml version="1.0" encoding="utf-8"?>
+<file path=ppt/slides/slide13.xml><?xml version="1.0" encoding="utf-8"?>
 <p:sld xmlns:a="http://schemas.openxmlformats.org/drawingml/2006/main" xmlns:r="http://schemas.openxmlformats.org/officeDocument/2006/relationships" xmlns:mc="http://schemas.openxmlformats.org/markup-compatibility/2006" xmlns:mv="urn:schemas-microsoft-com:mac:vml" xmlns:p="http://schemas.openxmlformats.org/presentationml/2006/main" xmlns:c="http://schemas.openxmlformats.org/drawingml/2006/chart" xmlns:dgm="http://schemas.openxmlformats.org/drawingml/2006/diagram" xmlns:o="urn:schemas-microsoft-com:office:office" xmlns:v="urn:schemas-microsoft-com:vml" xmlns:pvml="urn:schemas-microsoft-com:office:powerpoint" xmlns:com="http://schemas.openxmlformats.org/drawingml/2006/compatibility" xmlns:p14="http://schemas.microsoft.com/office/powerpoint/2010/main" xmlns:p15="http://schemas.microsoft.com/office/powerpoint/2012/main" xmlns:ahyp="http://schemas.microsoft.com/office/drawing/2018/hyperlinkcolor">
   <p:cSld>
     <p:spTree>
@@ -11579,7 +12213,7 @@
 </p:sld>
 </file>
 
-<file path=ppt/slides/slide13.xml><?xml version="1.0" encoding="utf-8"?>
+<file path=ppt/slides/slide14.xml><?xml version="1.0" encoding="utf-8"?>
 <p:sld xmlns:a="http://schemas.openxmlformats.org/drawingml/2006/main" xmlns:r="http://schemas.openxmlformats.org/officeDocument/2006/relationships" xmlns:mc="http://schemas.openxmlformats.org/markup-compatibility/2006" xmlns:mv="urn:schemas-microsoft-com:mac:vml" xmlns:p="http://schemas.openxmlformats.org/presentationml/2006/main" xmlns:c="http://schemas.openxmlformats.org/drawingml/2006/chart" xmlns:dgm="http://schemas.openxmlformats.org/drawingml/2006/diagram" xmlns:o="urn:schemas-microsoft-com:office:office" xmlns:v="urn:schemas-microsoft-com:vml" xmlns:pvml="urn:schemas-microsoft-com:office:powerpoint" xmlns:com="http://schemas.openxmlformats.org/drawingml/2006/compatibility" xmlns:p14="http://schemas.microsoft.com/office/powerpoint/2010/main" xmlns:p15="http://schemas.microsoft.com/office/powerpoint/2012/main" xmlns:ahyp="http://schemas.microsoft.com/office/drawing/2018/hyperlinkcolor">
   <p:cSld>
     <p:spTree>
@@ -11659,7 +12293,7 @@
 </p:sld>
 </file>
 
-<file path=ppt/slides/slide14.xml><?xml version="1.0" encoding="utf-8"?>
+<file path=ppt/slides/slide15.xml><?xml version="1.0" encoding="utf-8"?>
 <p:sld xmlns:a="http://schemas.openxmlformats.org/drawingml/2006/main" xmlns:p="http://schemas.openxmlformats.org/presentationml/2006/main" xmlns:r="http://schemas.openxmlformats.org/officeDocument/2006/relationships">
   <p:cSld>
     <p:spTree>
@@ -11791,14 +12425,14 @@
               </a:defRPr>
             </a:pPr>
             <a:r>
-              <a:t>Architecture diagrams of individual features</a:t>
+              <a:t>Architecture diagrams of individual features (2/2)</a:t>
             </a:r>
           </a:p>
         </p:txBody>
       </p:sp>
       <p:pic>
         <p:nvPicPr>
-          <p:cNvPr id="112" name="Picture 111" descr="predictive_maintenance_architecture.jpg"/>
+          <p:cNvPr id="112" name="Picture 111" descr="image.jpg"/>
           <p:cNvPicPr>
             <a:picLocks noChangeAspect="1"/>
           </p:cNvPicPr>
@@ -11812,8 +12446,8 @@
         </p:blipFill>
         <p:spPr>
           <a:xfrm>
-            <a:off x="1629303" y="1140000"/>
-            <a:ext cx="2762697" cy="1840000"/>
+            <a:off x="200000" y="1420000"/>
+            <a:ext cx="4282000" cy="2851879"/>
           </a:xfrm>
           <a:prstGeom prst="rect">
             <a:avLst/>
@@ -11822,7 +12456,7 @@
       </p:pic>
       <p:pic>
         <p:nvPicPr>
-          <p:cNvPr id="113" name="Picture 112" descr="demand_forecasting_architecture.jpg"/>
+          <p:cNvPr id="113" name="Picture 112" descr="image.jpg"/>
           <p:cNvPicPr>
             <a:picLocks noChangeAspect="1"/>
           </p:cNvPicPr>
@@ -11836,56 +12470,8 @@
         </p:blipFill>
         <p:spPr>
           <a:xfrm>
-            <a:off x="4752000" y="1140000"/>
-            <a:ext cx="2762697" cy="1840000"/>
-          </a:xfrm>
-          <a:prstGeom prst="rect">
-            <a:avLst/>
-          </a:prstGeom>
-        </p:spPr>
-      </p:pic>
-      <p:pic>
-        <p:nvPicPr>
-          <p:cNvPr id="114" name="Picture 113" descr="supply_chain_intelligence_architecture.jpg"/>
-          <p:cNvPicPr>
-            <a:picLocks noChangeAspect="1"/>
-          </p:cNvPicPr>
-          <p:nvPr/>
-        </p:nvPicPr>
-        <p:blipFill>
-          <a:blip r:embed="rId6"/>
-          <a:stretch>
-            <a:fillRect/>
-          </a:stretch>
-        </p:blipFill>
-        <p:spPr>
-          <a:xfrm>
-            <a:off x="1629303" y="3080000"/>
-            <a:ext cx="2762697" cy="1840000"/>
-          </a:xfrm>
-          <a:prstGeom prst="rect">
-            <a:avLst/>
-          </a:prstGeom>
-        </p:spPr>
-      </p:pic>
-      <p:pic>
-        <p:nvPicPr>
-          <p:cNvPr id="115" name="Picture 114" descr="visual_quality_inspection_architecture.jpg"/>
-          <p:cNvPicPr>
-            <a:picLocks noChangeAspect="1"/>
-          </p:cNvPicPr>
-          <p:nvPr/>
-        </p:nvPicPr>
-        <p:blipFill>
-          <a:blip r:embed="rId7"/>
-          <a:stretch>
-            <a:fillRect/>
-          </a:stretch>
-        </p:blipFill>
-        <p:spPr>
-          <a:xfrm>
-            <a:off x="4752000" y="3080000"/>
-            <a:ext cx="2762697" cy="1840000"/>
+            <a:off x="4662000" y="1420000"/>
+            <a:ext cx="4282000" cy="2851879"/>
           </a:xfrm>
           <a:prstGeom prst="rect">
             <a:avLst/>
@@ -16290,6 +16876,199 @@
 </file>
 
 <file path=ppt/slides/slide7.xml><?xml version="1.0" encoding="utf-8"?>
+<p:sld xmlns:a="http://schemas.openxmlformats.org/drawingml/2006/main" xmlns:p="http://schemas.openxmlformats.org/presentationml/2006/main" xmlns:r="http://schemas.openxmlformats.org/officeDocument/2006/relationships">
+  <p:cSld>
+    <p:spTree>
+      <p:nvGrpSpPr>
+        <p:cNvPr id="1" name=""/>
+        <p:cNvGrpSpPr/>
+        <p:nvPr/>
+      </p:nvGrpSpPr>
+      <p:grpSpPr/>
+      <p:pic>
+        <p:nvPicPr>
+          <p:cNvPr id="2" name="Picture 1" descr="image.png"/>
+          <p:cNvPicPr>
+            <a:picLocks noChangeAspect="1"/>
+          </p:cNvPicPr>
+          <p:nvPr/>
+        </p:nvPicPr>
+        <p:blipFill>
+          <a:blip r:embed="rId2"/>
+          <a:stretch>
+            <a:fillRect/>
+          </a:stretch>
+        </p:blipFill>
+        <p:spPr>
+          <a:xfrm>
+            <a:off x="0" y="1"/>
+            <a:ext cx="9144000" cy="507359"/>
+          </a:xfrm>
+          <a:prstGeom prst="rect">
+            <a:avLst/>
+          </a:prstGeom>
+        </p:spPr>
+      </p:pic>
+      <p:pic>
+        <p:nvPicPr>
+          <p:cNvPr id="3" name="Picture 2" descr="image.png"/>
+          <p:cNvPicPr>
+            <a:picLocks noChangeAspect="1"/>
+          </p:cNvPicPr>
+          <p:nvPr/>
+        </p:nvPicPr>
+        <p:blipFill>
+          <a:blip r:embed="rId3"/>
+          <a:stretch>
+            <a:fillRect/>
+          </a:stretch>
+        </p:blipFill>
+        <p:spPr>
+          <a:xfrm>
+            <a:off x="0" y="5093562"/>
+            <a:ext cx="9144000" cy="54275"/>
+          </a:xfrm>
+          <a:prstGeom prst="rect">
+            <a:avLst/>
+          </a:prstGeom>
+        </p:spPr>
+      </p:pic>
+      <p:sp>
+        <p:nvSpPr>
+          <p:cNvPr id="110" name="Google Shape;110;p20"/>
+          <p:cNvSpPr/>
+          <p:nvPr/>
+        </p:nvSpPr>
+        <p:spPr>
+          <a:xfrm>
+            <a:off x="-29250" y="5071875"/>
+            <a:ext cx="9173400" cy="97800"/>
+          </a:xfrm>
+          <a:prstGeom prst="rect">
+            <a:avLst/>
+          </a:prstGeom>
+          <a:solidFill>
+            <a:schemeClr val="dk1"/>
+          </a:solidFill>
+          <a:ln>
+            <a:noFill/>
+          </a:ln>
+        </p:spPr>
+        <p:txBody>
+          <a:bodyPr anchorCtr="0" anchor="ctr" bIns="91425" lIns="91425" spcFirstLastPara="1" rIns="91425" wrap="square" tIns="91425">
+            <a:noAutofit/>
+          </a:bodyPr>
+          <a:lstStyle/>
+          <a:p>
+            <a:pPr indent="0" lvl="0" marL="0" rtl="0" algn="ctr">
+              <a:spcBef>
+                <a:spcPts val="0"/>
+              </a:spcBef>
+              <a:spcAft>
+                <a:spcPts val="0"/>
+              </a:spcAft>
+              <a:buNone/>
+            </a:pPr>
+            <a:r>
+              <a:t/>
+            </a:r>
+            <a:endParaRPr/>
+          </a:p>
+        </p:txBody>
+      </p:sp>
+      <p:sp>
+        <p:nvSpPr>
+          <p:cNvPr id="111" name="TextBox 110"/>
+          <p:cNvSpPr txBox="1"/>
+          <p:nvPr/>
+        </p:nvSpPr>
+        <p:spPr>
+          <a:xfrm>
+            <a:off x="265350" y="663825"/>
+            <a:ext cx="8943000" cy="461900"/>
+          </a:xfrm>
+          <a:prstGeom prst="rect">
+            <a:avLst/>
+          </a:prstGeom>
+          <a:noFill/>
+        </p:spPr>
+        <p:txBody>
+          <a:bodyPr wrap="none">
+            <a:spAutoFit/>
+          </a:bodyPr>
+          <a:lstStyle/>
+          <a:p>
+            <a:pPr>
+              <a:defRPr sz="1600">
+                <a:solidFill>
+                  <a:srgbClr val="000000"/>
+                </a:solidFill>
+                <a:latin typeface="Google Sans Flex"/>
+              </a:defRPr>
+            </a:pPr>
+            <a:r>
+              <a:t>Architecture diagrams of individual features (1/2)</a:t>
+            </a:r>
+          </a:p>
+        </p:txBody>
+      </p:sp>
+      <p:pic>
+        <p:nvPicPr>
+          <p:cNvPr id="112" name="Picture 111" descr="image.jpg"/>
+          <p:cNvPicPr>
+            <a:picLocks noChangeAspect="1"/>
+          </p:cNvPicPr>
+          <p:nvPr/>
+        </p:nvPicPr>
+        <p:blipFill>
+          <a:blip r:embed="rId4"/>
+          <a:stretch>
+            <a:fillRect/>
+          </a:stretch>
+        </p:blipFill>
+        <p:spPr>
+          <a:xfrm>
+            <a:off x="200000" y="1420000"/>
+            <a:ext cx="4282000" cy="2851879"/>
+          </a:xfrm>
+          <a:prstGeom prst="rect">
+            <a:avLst/>
+          </a:prstGeom>
+        </p:spPr>
+      </p:pic>
+      <p:pic>
+        <p:nvPicPr>
+          <p:cNvPr id="113" name="Picture 112" descr="image.jpg"/>
+          <p:cNvPicPr>
+            <a:picLocks noChangeAspect="1"/>
+          </p:cNvPicPr>
+          <p:nvPr/>
+        </p:nvPicPr>
+        <p:blipFill>
+          <a:blip r:embed="rId5"/>
+          <a:stretch>
+            <a:fillRect/>
+          </a:stretch>
+        </p:blipFill>
+        <p:spPr>
+          <a:xfrm>
+            <a:off x="4662000" y="1420000"/>
+            <a:ext cx="4282000" cy="2851879"/>
+          </a:xfrm>
+          <a:prstGeom prst="rect">
+            <a:avLst/>
+          </a:prstGeom>
+        </p:spPr>
+      </p:pic>
+    </p:spTree>
+  </p:cSld>
+  <p:clrMapOvr>
+    <a:masterClrMapping/>
+  </p:clrMapOvr>
+</p:sld>
+</file>
+
+<file path=ppt/slides/slide8.xml><?xml version="1.0" encoding="utf-8"?>
 <p:sld xmlns:a="http://schemas.openxmlformats.org/drawingml/2006/main" xmlns:r="http://schemas.openxmlformats.org/officeDocument/2006/relationships" xmlns:mc="http://schemas.openxmlformats.org/markup-compatibility/2006" xmlns:mv="urn:schemas-microsoft-com:mac:vml" xmlns:p="http://schemas.openxmlformats.org/presentationml/2006/main" xmlns:c="http://schemas.openxmlformats.org/drawingml/2006/chart" xmlns:dgm="http://schemas.openxmlformats.org/drawingml/2006/diagram" xmlns:o="urn:schemas-microsoft-com:office:office" xmlns:v="urn:schemas-microsoft-com:vml" xmlns:pvml="urn:schemas-microsoft-com:office:powerpoint" xmlns:com="http://schemas.openxmlformats.org/drawingml/2006/compatibility" xmlns:p14="http://schemas.microsoft.com/office/powerpoint/2010/main" xmlns:p15="http://schemas.microsoft.com/office/powerpoint/2012/main" xmlns:ahyp="http://schemas.microsoft.com/office/drawing/2018/hyperlinkcolor">
   <p:cSld>
     <p:spTree>
@@ -20592,639 +21371,6 @@
               <a:t>Testing</a:t>
             </a:r>
             <a:endParaRPr lang="en-GB" sz="1100" dirty="0"/>
-          </a:p>
-        </p:txBody>
-      </p:sp>
-    </p:spTree>
-  </p:cSld>
-  <p:clrMapOvr>
-    <a:masterClrMapping/>
-  </p:clrMapOvr>
-</p:sld>
-</file>
-
-<file path=ppt/slides/slide8.xml><?xml version="1.0" encoding="utf-8"?>
-<p:sld xmlns:a="http://schemas.openxmlformats.org/drawingml/2006/main" xmlns:r="http://schemas.openxmlformats.org/officeDocument/2006/relationships" xmlns:mc="http://schemas.openxmlformats.org/markup-compatibility/2006" xmlns:mv="urn:schemas-microsoft-com:mac:vml" xmlns:p="http://schemas.openxmlformats.org/presentationml/2006/main" xmlns:c="http://schemas.openxmlformats.org/drawingml/2006/chart" xmlns:dgm="http://schemas.openxmlformats.org/drawingml/2006/diagram" xmlns:o="urn:schemas-microsoft-com:office:office" xmlns:v="urn:schemas-microsoft-com:vml" xmlns:pvml="urn:schemas-microsoft-com:office:powerpoint" xmlns:com="http://schemas.openxmlformats.org/drawingml/2006/compatibility" xmlns:p14="http://schemas.microsoft.com/office/powerpoint/2010/main" xmlns:p15="http://schemas.microsoft.com/office/powerpoint/2012/main" xmlns:ahyp="http://schemas.microsoft.com/office/drawing/2018/hyperlinkcolor">
-  <p:cSld>
-    <p:spTree>
-      <p:nvGrpSpPr>
-        <p:cNvPr id="131" name="Shape 131"/>
-        <p:cNvGrpSpPr/>
-        <p:nvPr/>
-      </p:nvGrpSpPr>
-      <p:grpSpPr>
-        <a:xfrm>
-          <a:off x="0" y="0"/>
-          <a:ext cx="0" cy="0"/>
-          <a:chOff x="0" y="0"/>
-          <a:chExt cx="0" cy="0"/>
-        </a:xfrm>
-      </p:grpSpPr>
-      <p:pic>
-        <p:nvPicPr>
-          <p:cNvPr id="132" name="Google Shape;132;p23" title="Frame 144.png"/>
-          <p:cNvPicPr preferRelativeResize="0"/>
-          <p:nvPr/>
-        </p:nvPicPr>
-        <p:blipFill rotWithShape="1">
-          <a:blip r:embed="rId3">
-            <a:alphaModFix/>
-          </a:blip>
-          <a:srcRect b="98001" l="0" r="0" t="0"/>
-          <a:stretch/>
-        </p:blipFill>
-        <p:spPr>
-          <a:xfrm>
-            <a:off x="0" y="5093562"/>
-            <a:ext cx="9144000" cy="54275"/>
-          </a:xfrm>
-          <a:prstGeom prst="rect">
-            <a:avLst/>
-          </a:prstGeom>
-          <a:noFill/>
-          <a:ln>
-            <a:noFill/>
-          </a:ln>
-        </p:spPr>
-      </p:pic>
-      <p:pic>
-        <p:nvPicPr>
-          <p:cNvPr id="133" name="Google Shape;133;p23" title="Group 427319979.png"/>
-          <p:cNvPicPr preferRelativeResize="0"/>
-          <p:nvPr/>
-        </p:nvPicPr>
-        <p:blipFill>
-          <a:blip r:embed="rId4">
-            <a:alphaModFix/>
-          </a:blip>
-          <a:stretch>
-            <a:fillRect/>
-          </a:stretch>
-        </p:blipFill>
-        <p:spPr>
-          <a:xfrm>
-            <a:off x="0" y="1"/>
-            <a:ext cx="9144000" cy="507359"/>
-          </a:xfrm>
-          <a:prstGeom prst="rect">
-            <a:avLst/>
-          </a:prstGeom>
-          <a:noFill/>
-          <a:ln>
-            <a:noFill/>
-          </a:ln>
-        </p:spPr>
-      </p:pic>
-      <p:sp>
-        <p:nvSpPr>
-          <p:cNvPr id="134" name="Google Shape;134;p23"/>
-          <p:cNvSpPr/>
-          <p:nvPr/>
-        </p:nvSpPr>
-        <p:spPr>
-          <a:xfrm>
-            <a:off x="-29250" y="5071875"/>
-            <a:ext cx="9173400" cy="97800"/>
-          </a:xfrm>
-          <a:prstGeom prst="rect">
-            <a:avLst/>
-          </a:prstGeom>
-          <a:solidFill>
-            <a:schemeClr val="dk1"/>
-          </a:solidFill>
-          <a:ln>
-            <a:noFill/>
-          </a:ln>
-        </p:spPr>
-        <p:txBody>
-          <a:bodyPr anchorCtr="0" anchor="ctr" bIns="91425" lIns="91425" spcFirstLastPara="1" rIns="91425" wrap="square" tIns="91425">
-            <a:noAutofit/>
-          </a:bodyPr>
-          <a:lstStyle/>
-          <a:p>
-            <a:pPr indent="0" lvl="0" marL="0" rtl="0" algn="ctr">
-              <a:spcBef>
-                <a:spcPts val="0"/>
-              </a:spcBef>
-              <a:spcAft>
-                <a:spcPts val="0"/>
-              </a:spcAft>
-              <a:buNone/>
-            </a:pPr>
-            <a:r>
-              <a:t/>
-            </a:r>
-            <a:endParaRPr/>
-          </a:p>
-        </p:txBody>
-      </p:sp>
-      <p:sp>
-        <p:nvSpPr>
-          <p:cNvPr id="135" name="Google Shape;135;p23"/>
-          <p:cNvSpPr txBox="1"/>
-          <p:nvPr/>
-        </p:nvSpPr>
-        <p:spPr>
-          <a:xfrm>
-            <a:off x="265350" y="663825"/>
-            <a:ext cx="8943000" cy="461900"/>
-          </a:xfrm>
-          <a:prstGeom prst="rect">
-            <a:avLst/>
-          </a:prstGeom>
-          <a:noFill/>
-          <a:ln>
-            <a:noFill/>
-          </a:ln>
-        </p:spPr>
-        <p:txBody>
-          <a:bodyPr anchorCtr="0" anchor="t" bIns="91425" lIns="91425" spcFirstLastPara="1" rIns="91425" wrap="square" tIns="91425">
-            <a:noAutofit/>
-          </a:bodyPr>
-          <a:lstStyle/>
-          <a:p>
-            <a:pPr marL="0" indent="0" algn="l">
-              <a:spcBef>
-                <a:spcPts val="0"/>
-              </a:spcBef>
-              <a:spcAft>
-                <a:spcPts val="0"/>
-              </a:spcAft>
-              <a:buNone/>
-            </a:pPr>
-            <a:r>
-              <a:rPr lang="en-GB" sz="1600" b="0" dirty="0">
-                <a:solidFill>
-                  <a:srgbClr val="000000"/>
-                </a:solidFill>
-                <a:latin typeface="Google Sans Flex Medium"/>
-                <a:ea typeface="Google Sans Flex Medium"/>
-                <a:cs typeface="Google Sans Flex Medium"/>
-                <a:sym typeface="Google Sans Flex Medium"/>
-              </a:rPr>
-              <a:t>Snapshots of the prototype (1/2)</a:t>
-            </a:r>
-            <a:endParaRPr lang="en-GB" sz="1600" dirty="0"/>
-          </a:p>
-        </p:txBody>
-      </p:sp>
-      <p:pic>
-        <p:nvPicPr>
-          <p:cNvPr id="1001" name="Command Center" descr="Command Center"/>
-          <p:cNvPicPr>
-            <a:picLocks noChangeAspect="1"/>
-          </p:cNvPicPr>
-          <p:nvPr/>
-        </p:nvPicPr>
-        <p:blipFill>
-          <a:blip r:embed="rId5"/>
-          <a:stretch>
-            <a:fillRect/>
-          </a:stretch>
-        </p:blipFill>
-        <p:spPr>
-          <a:xfrm>
-            <a:off x="365760" y="1188720"/>
-            <a:ext cx="2606040" cy="1628775"/>
-          </a:xfrm>
-          <a:prstGeom prst="roundRect">
-            <a:avLst>
-              <a:gd name="adj" fmla="val 2807"/>
-            </a:avLst>
-          </a:prstGeom>
-          <a:ln w="9525">
-            <a:solidFill>
-              <a:srgbClr val="DADCE0"/>
-            </a:solidFill>
-          </a:ln>
-          <a:effectLst>
-            <a:outerShdw blurRad="76200" dist="19050" dir="5400000" algn="t" rotWithShape="0">
-              <a:srgbClr val="000000">
-                <a:alpha val="16000"/>
-              </a:srgbClr>
-            </a:outerShdw>
-          </a:effectLst>
-        </p:spPr>
-      </p:pic>
-      <p:sp>
-        <p:nvSpPr>
-          <p:cNvPr id="1002" name="Command Center caption"/>
-          <p:cNvSpPr txBox="1"/>
-          <p:nvPr/>
-        </p:nvSpPr>
-        <p:spPr>
-          <a:xfrm>
-            <a:off x="3081528" y="1188720"/>
-            <a:ext cx="1417320" cy="1628775"/>
-          </a:xfrm>
-          <a:prstGeom prst="rect">
-            <a:avLst/>
-          </a:prstGeom>
-          <a:noFill/>
-          <a:ln>
-            <a:noFill/>
-          </a:ln>
-        </p:spPr>
-        <p:txBody>
-          <a:bodyPr wrap="square" lIns="0" tIns="0" rIns="0" bIns="0" anchor="ctr" rtlCol="0">
-            <a:noAutofit/>
-          </a:bodyPr>
-          <a:lstStyle/>
-          <a:p>
-            <a:pPr marL="0" indent="0" algn="l">
-              <a:spcBef>
-                <a:spcPts val="0"/>
-              </a:spcBef>
-              <a:spcAft>
-                <a:spcPts val="300"/>
-              </a:spcAft>
-              <a:buNone/>
-            </a:pPr>
-            <a:r>
-              <a:rPr lang="en-GB" sz="1200" b="0" dirty="0">
-                <a:solidFill>
-                  <a:srgbClr val="202124"/>
-                </a:solidFill>
-                <a:latin typeface="Google Sans Flex SemiBold"/>
-                <a:ea typeface="Google Sans Flex SemiBold"/>
-                <a:cs typeface="Google Sans Flex SemiBold"/>
-                <a:sym typeface="Google Sans Flex SemiBold"/>
-              </a:rPr>
-              <a:t>Command Center</a:t>
-            </a:r>
-            <a:endParaRPr lang="en-GB" sz="1200" dirty="0"/>
-          </a:p>
-          <a:p>
-            <a:pPr marL="0" indent="0" algn="l">
-              <a:lnSpc>
-                <a:spcPct val="105000"/>
-              </a:lnSpc>
-              <a:spcBef>
-                <a:spcPts val="0"/>
-              </a:spcBef>
-              <a:spcAft>
-                <a:spcPts val="0"/>
-              </a:spcAft>
-              <a:buNone/>
-            </a:pPr>
-            <a:r>
-              <a:rPr lang="en-GB" sz="1050" b="0" dirty="0">
-                <a:solidFill>
-                  <a:srgbClr val="5F6368"/>
-                </a:solidFill>
-                <a:latin typeface="Google Sans Flex"/>
-                <a:ea typeface="Google Sans Flex"/>
-                <a:cs typeface="Google Sans Flex"/>
-                <a:sym typeface="Google Sans Flex"/>
-              </a:rPr>
-              <a:t>The whole plant on one screen during the crisis, with the guided demo panel.</a:t>
-            </a:r>
-            <a:endParaRPr lang="en-GB" sz="1050" dirty="0"/>
-          </a:p>
-        </p:txBody>
-      </p:sp>
-      <p:pic>
-        <p:nvPicPr>
-          <p:cNvPr id="1003" name="AI Operations" descr="AI Operations"/>
-          <p:cNvPicPr>
-            <a:picLocks noChangeAspect="1"/>
-          </p:cNvPicPr>
-          <p:nvPr/>
-        </p:nvPicPr>
-        <p:blipFill>
-          <a:blip r:embed="rId6"/>
-          <a:stretch>
-            <a:fillRect/>
-          </a:stretch>
-        </p:blipFill>
-        <p:spPr>
-          <a:xfrm>
-            <a:off x="4645152" y="1188720"/>
-            <a:ext cx="2606040" cy="1628775"/>
-          </a:xfrm>
-          <a:prstGeom prst="roundRect">
-            <a:avLst>
-              <a:gd name="adj" fmla="val 2807"/>
-            </a:avLst>
-          </a:prstGeom>
-          <a:ln w="9525">
-            <a:solidFill>
-              <a:srgbClr val="DADCE0"/>
-            </a:solidFill>
-          </a:ln>
-          <a:effectLst>
-            <a:outerShdw blurRad="76200" dist="19050" dir="5400000" algn="t" rotWithShape="0">
-              <a:srgbClr val="000000">
-                <a:alpha val="16000"/>
-              </a:srgbClr>
-            </a:outerShdw>
-          </a:effectLst>
-        </p:spPr>
-      </p:pic>
-      <p:sp>
-        <p:nvSpPr>
-          <p:cNvPr id="1004" name="AI Operations caption"/>
-          <p:cNvSpPr txBox="1"/>
-          <p:nvPr/>
-        </p:nvSpPr>
-        <p:spPr>
-          <a:xfrm>
-            <a:off x="7360920" y="1188720"/>
-            <a:ext cx="1417320" cy="1628775"/>
-          </a:xfrm>
-          <a:prstGeom prst="rect">
-            <a:avLst/>
-          </a:prstGeom>
-          <a:noFill/>
-          <a:ln>
-            <a:noFill/>
-          </a:ln>
-        </p:spPr>
-        <p:txBody>
-          <a:bodyPr wrap="square" lIns="0" tIns="0" rIns="0" bIns="0" anchor="ctr" rtlCol="0">
-            <a:noAutofit/>
-          </a:bodyPr>
-          <a:lstStyle/>
-          <a:p>
-            <a:pPr marL="0" indent="0" algn="l">
-              <a:spcBef>
-                <a:spcPts val="0"/>
-              </a:spcBef>
-              <a:spcAft>
-                <a:spcPts val="300"/>
-              </a:spcAft>
-              <a:buNone/>
-            </a:pPr>
-            <a:r>
-              <a:rPr lang="en-GB" sz="1200" b="0" dirty="0">
-                <a:solidFill>
-                  <a:srgbClr val="202124"/>
-                </a:solidFill>
-                <a:latin typeface="Google Sans Flex SemiBold"/>
-                <a:ea typeface="Google Sans Flex SemiBold"/>
-                <a:cs typeface="Google Sans Flex SemiBold"/>
-                <a:sym typeface="Google Sans Flex SemiBold"/>
-              </a:rPr>
-              <a:t>AI Operations</a:t>
-            </a:r>
-            <a:endParaRPr lang="en-GB" sz="1200" dirty="0"/>
-          </a:p>
-          <a:p>
-            <a:pPr marL="0" indent="0" algn="l">
-              <a:lnSpc>
-                <a:spcPct val="105000"/>
-              </a:lnSpc>
-              <a:spcBef>
-                <a:spcPts val="0"/>
-              </a:spcBef>
-              <a:spcAft>
-                <a:spcPts val="0"/>
-              </a:spcAft>
-              <a:buNone/>
-            </a:pPr>
-            <a:r>
-              <a:rPr lang="en-GB" sz="1050" b="0" dirty="0">
-                <a:solidFill>
-                  <a:srgbClr val="5F6368"/>
-                </a:solidFill>
-                <a:latin typeface="Google Sans Flex"/>
-                <a:ea typeface="Google Sans Flex"/>
-                <a:cs typeface="Google Sans Flex"/>
-                <a:sym typeface="Google Sans Flex"/>
-              </a:rPr>
-              <a:t>Six agents stream findings; a trip is predicted about 16 hours ahead.</a:t>
-            </a:r>
-            <a:endParaRPr lang="en-GB" sz="1050" dirty="0"/>
-          </a:p>
-        </p:txBody>
-      </p:sp>
-      <p:pic>
-        <p:nvPicPr>
-          <p:cNvPr id="1005" name="What-If Simulator" descr="What-If Simulator"/>
-          <p:cNvPicPr>
-            <a:picLocks noChangeAspect="1"/>
-          </p:cNvPicPr>
-          <p:nvPr/>
-        </p:nvPicPr>
-        <p:blipFill>
-          <a:blip r:embed="rId7"/>
-          <a:stretch>
-            <a:fillRect/>
-          </a:stretch>
-        </p:blipFill>
-        <p:spPr>
-          <a:xfrm>
-            <a:off x="365760" y="3073527"/>
-            <a:ext cx="2606040" cy="1628775"/>
-          </a:xfrm>
-          <a:prstGeom prst="roundRect">
-            <a:avLst>
-              <a:gd name="adj" fmla="val 2807"/>
-            </a:avLst>
-          </a:prstGeom>
-          <a:ln w="9525">
-            <a:solidFill>
-              <a:srgbClr val="DADCE0"/>
-            </a:solidFill>
-          </a:ln>
-          <a:effectLst>
-            <a:outerShdw blurRad="76200" dist="19050" dir="5400000" algn="t" rotWithShape="0">
-              <a:srgbClr val="000000">
-                <a:alpha val="16000"/>
-              </a:srgbClr>
-            </a:outerShdw>
-          </a:effectLst>
-        </p:spPr>
-      </p:pic>
-      <p:sp>
-        <p:nvSpPr>
-          <p:cNvPr id="1006" name="What-If Simulator caption"/>
-          <p:cNvSpPr txBox="1"/>
-          <p:nvPr/>
-        </p:nvSpPr>
-        <p:spPr>
-          <a:xfrm>
-            <a:off x="3081528" y="3073527"/>
-            <a:ext cx="1417320" cy="1628775"/>
-          </a:xfrm>
-          <a:prstGeom prst="rect">
-            <a:avLst/>
-          </a:prstGeom>
-          <a:noFill/>
-          <a:ln>
-            <a:noFill/>
-          </a:ln>
-        </p:spPr>
-        <p:txBody>
-          <a:bodyPr wrap="square" lIns="0" tIns="0" rIns="0" bIns="0" anchor="ctr" rtlCol="0">
-            <a:noAutofit/>
-          </a:bodyPr>
-          <a:lstStyle/>
-          <a:p>
-            <a:pPr marL="0" indent="0" algn="l">
-              <a:spcBef>
-                <a:spcPts val="0"/>
-              </a:spcBef>
-              <a:spcAft>
-                <a:spcPts val="300"/>
-              </a:spcAft>
-              <a:buNone/>
-            </a:pPr>
-            <a:r>
-              <a:rPr lang="en-GB" sz="1200" b="0" dirty="0">
-                <a:solidFill>
-                  <a:srgbClr val="202124"/>
-                </a:solidFill>
-                <a:latin typeface="Google Sans Flex SemiBold"/>
-                <a:ea typeface="Google Sans Flex SemiBold"/>
-                <a:cs typeface="Google Sans Flex SemiBold"/>
-                <a:sym typeface="Google Sans Flex SemiBold"/>
-              </a:rPr>
-              <a:t>What-If Simulator</a:t>
-            </a:r>
-            <a:endParaRPr lang="en-GB" sz="1200" dirty="0"/>
-          </a:p>
-          <a:p>
-            <a:pPr marL="0" indent="0" algn="l">
-              <a:lnSpc>
-                <a:spcPct val="105000"/>
-              </a:lnSpc>
-              <a:spcBef>
-                <a:spcPts val="0"/>
-              </a:spcBef>
-              <a:spcAft>
-                <a:spcPts val="0"/>
-              </a:spcAft>
-              <a:buNone/>
-            </a:pPr>
-            <a:r>
-              <a:rPr lang="en-GB" sz="1050" b="0" dirty="0">
-                <a:solidFill>
-                  <a:srgbClr val="5F6368"/>
-                </a:solidFill>
-                <a:latin typeface="Google Sans Flex"/>
-                <a:ea typeface="Google Sans Flex"/>
-                <a:cs typeface="Google Sans Flex"/>
-                <a:sym typeface="Google Sans Flex"/>
-              </a:rPr>
-              <a:t>Four plans compared; reroute to Line B + maintain scores 82.2 with no late units.</a:t>
-            </a:r>
-            <a:endParaRPr lang="en-GB" sz="1050" dirty="0"/>
-          </a:p>
-        </p:txBody>
-      </p:sp>
-      <p:pic>
-        <p:nvPicPr>
-          <p:cNvPr id="1007" name="Digital Twin in 3D" descr="Digital Twin in 3D"/>
-          <p:cNvPicPr>
-            <a:picLocks noChangeAspect="1"/>
-          </p:cNvPicPr>
-          <p:nvPr/>
-        </p:nvPicPr>
-        <p:blipFill>
-          <a:blip r:embed="rId8"/>
-          <a:stretch>
-            <a:fillRect/>
-          </a:stretch>
-        </p:blipFill>
-        <p:spPr>
-          <a:xfrm>
-            <a:off x="4645152" y="3073527"/>
-            <a:ext cx="2606040" cy="1628775"/>
-          </a:xfrm>
-          <a:prstGeom prst="roundRect">
-            <a:avLst>
-              <a:gd name="adj" fmla="val 2807"/>
-            </a:avLst>
-          </a:prstGeom>
-          <a:ln w="9525">
-            <a:solidFill>
-              <a:srgbClr val="DADCE0"/>
-            </a:solidFill>
-          </a:ln>
-          <a:effectLst>
-            <a:outerShdw blurRad="76200" dist="19050" dir="5400000" algn="t" rotWithShape="0">
-              <a:srgbClr val="000000">
-                <a:alpha val="16000"/>
-              </a:srgbClr>
-            </a:outerShdw>
-          </a:effectLst>
-        </p:spPr>
-      </p:pic>
-      <p:sp>
-        <p:nvSpPr>
-          <p:cNvPr id="1008" name="Digital Twin in 3D caption"/>
-          <p:cNvSpPr txBox="1"/>
-          <p:nvPr/>
-        </p:nvSpPr>
-        <p:spPr>
-          <a:xfrm>
-            <a:off x="7360920" y="3073527"/>
-            <a:ext cx="1417320" cy="1628775"/>
-          </a:xfrm>
-          <a:prstGeom prst="rect">
-            <a:avLst/>
-          </a:prstGeom>
-          <a:noFill/>
-          <a:ln>
-            <a:noFill/>
-          </a:ln>
-        </p:spPr>
-        <p:txBody>
-          <a:bodyPr wrap="square" lIns="0" tIns="0" rIns="0" bIns="0" anchor="ctr" rtlCol="0">
-            <a:noAutofit/>
-          </a:bodyPr>
-          <a:lstStyle/>
-          <a:p>
-            <a:pPr marL="0" indent="0" algn="l">
-              <a:spcBef>
-                <a:spcPts val="0"/>
-              </a:spcBef>
-              <a:spcAft>
-                <a:spcPts val="300"/>
-              </a:spcAft>
-              <a:buNone/>
-            </a:pPr>
-            <a:r>
-              <a:rPr lang="en-GB" sz="1200" b="0" dirty="0">
-                <a:solidFill>
-                  <a:srgbClr val="202124"/>
-                </a:solidFill>
-                <a:latin typeface="Google Sans Flex SemiBold"/>
-                <a:ea typeface="Google Sans Flex SemiBold"/>
-                <a:cs typeface="Google Sans Flex SemiBold"/>
-                <a:sym typeface="Google Sans Flex SemiBold"/>
-              </a:rPr>
-              <a:t>Digital Twin in 3D</a:t>
-            </a:r>
-            <a:endParaRPr lang="en-GB" sz="1200" dirty="0"/>
-          </a:p>
-          <a:p>
-            <a:pPr marL="0" indent="0" algn="l">
-              <a:lnSpc>
-                <a:spcPct val="105000"/>
-              </a:lnSpc>
-              <a:spcBef>
-                <a:spcPts val="0"/>
-              </a:spcBef>
-              <a:spcAft>
-                <a:spcPts val="0"/>
-              </a:spcAft>
-              <a:buNone/>
-            </a:pPr>
-            <a:r>
-              <a:rPr lang="en-GB" sz="1050" b="0" dirty="0">
-                <a:solidFill>
-                  <a:srgbClr val="5F6368"/>
-                </a:solidFill>
-                <a:latin typeface="Google Sans Flex"/>
-                <a:ea typeface="Google Sans Flex"/>
-                <a:cs typeface="Google Sans Flex"/>
-                <a:sym typeface="Google Sans Flex"/>
-              </a:rPr>
-              <a:t>Orbit the live plant; robots animate and the recommended path is highlighted.</a:t>
-            </a:r>
-            <a:endParaRPr lang="en-GB" sz="1050" dirty="0"/>
           </a:p>
         </p:txBody>
       </p:sp>
@@ -21395,7 +21541,7 @@
                 <a:cs typeface="Google Sans Flex Medium"/>
                 <a:sym typeface="Google Sans Flex Medium"/>
               </a:rPr>
-              <a:t>Snapshots of the prototype (2/2)</a:t>
+              <a:t>Snapshots of the prototype (1/2)</a:t>
             </a:r>
             <a:endParaRPr lang="en-GB" sz="1600" dirty="0"/>
           </a:p>
@@ -21403,7 +21549,7 @@
       </p:sp>
       <p:pic>
         <p:nvPicPr>
-          <p:cNvPr id="1001" name="Approvals" descr="Approvals"/>
+          <p:cNvPr id="1001" name="Command Center" descr="Command Center"/>
           <p:cNvPicPr>
             <a:picLocks noChangeAspect="1"/>
           </p:cNvPicPr>
@@ -21441,7 +21587,7 @@
       </p:pic>
       <p:sp>
         <p:nvSpPr>
-          <p:cNvPr id="1002" name="Approvals caption"/>
+          <p:cNvPr id="1002" name="Command Center caption"/>
           <p:cNvSpPr txBox="1"/>
           <p:nvPr/>
         </p:nvSpPr>
@@ -21483,7 +21629,7 @@
                 <a:cs typeface="Google Sans Flex SemiBold"/>
                 <a:sym typeface="Google Sans Flex SemiBold"/>
               </a:rPr>
-              <a:t>Approvals</a:t>
+              <a:t>Command Center</a:t>
             </a:r>
             <a:endParaRPr lang="en-GB" sz="1200" dirty="0"/>
           </a:p>
@@ -21510,7 +21656,7 @@
                 <a:cs typeface="Google Sans Flex"/>
                 <a:sym typeface="Google Sans Flex"/>
               </a:rPr>
-              <a:t>The approved plan ran: Line B took over and the failing robot is healthy again.</a:t>
+              <a:t>The whole plant on one screen during the crisis, with the guided demo panel.</a:t>
             </a:r>
             <a:endParaRPr lang="en-GB" sz="1050" dirty="0"/>
           </a:p>
@@ -21518,7 +21664,7 @@
       </p:sp>
       <p:pic>
         <p:nvPicPr>
-          <p:cNvPr id="1003" name="Visual Quality" descr="Visual Quality"/>
+          <p:cNvPr id="1003" name="AI Operations" descr="AI Operations"/>
           <p:cNvPicPr>
             <a:picLocks noChangeAspect="1"/>
           </p:cNvPicPr>
@@ -21556,7 +21702,7 @@
       </p:pic>
       <p:sp>
         <p:nvSpPr>
-          <p:cNvPr id="1004" name="Visual Quality caption"/>
+          <p:cNvPr id="1004" name="AI Operations caption"/>
           <p:cNvSpPr txBox="1"/>
           <p:nvPr/>
         </p:nvSpPr>
@@ -21598,7 +21744,7 @@
                 <a:cs typeface="Google Sans Flex SemiBold"/>
                 <a:sym typeface="Google Sans Flex SemiBold"/>
               </a:rPr>
-              <a:t>Visual Quality</a:t>
+              <a:t>AI Operations</a:t>
             </a:r>
             <a:endParaRPr lang="en-GB" sz="1200" dirty="0"/>
           </a:p>
@@ -21625,7 +21771,7 @@
                 <a:cs typeface="Google Sans Flex"/>
                 <a:sym typeface="Google Sans Flex"/>
               </a:rPr>
-              <a:t>FPY, DPMO and defect Pareto; robot vibration tracks Line A rejects (r = 0.89).</a:t>
+              <a:t>Six agents stream findings; a trip is predicted about 16 hours ahead.</a:t>
             </a:r>
             <a:endParaRPr lang="en-GB" sz="1050" dirty="0"/>
           </a:p>
@@ -21633,7 +21779,7 @@
       </p:sp>
       <p:pic>
         <p:nvPicPr>
-          <p:cNvPr id="1005" name="Twin Builder" descr="Twin Builder"/>
+          <p:cNvPr id="1005" name="What-If Simulator" descr="What-If Simulator"/>
           <p:cNvPicPr>
             <a:picLocks noChangeAspect="1"/>
           </p:cNvPicPr>
@@ -21671,7 +21817,7 @@
       </p:pic>
       <p:sp>
         <p:nvSpPr>
-          <p:cNvPr id="1006" name="Twin Builder caption"/>
+          <p:cNvPr id="1006" name="What-If Simulator caption"/>
           <p:cNvSpPr txBox="1"/>
           <p:nvPr/>
         </p:nvSpPr>
@@ -21713,7 +21859,7 @@
                 <a:cs typeface="Google Sans Flex SemiBold"/>
                 <a:sym typeface="Google Sans Flex SemiBold"/>
               </a:rPr>
-              <a:t>Twin Builder</a:t>
+              <a:t>What-If Simulator</a:t>
             </a:r>
             <a:endParaRPr lang="en-GB" sz="1200" dirty="0"/>
           </a:p>
@@ -21740,7 +21886,7 @@
                 <a:cs typeface="Google Sans Flex"/>
                 <a:sym typeface="Google Sans Flex"/>
               </a:rPr>
-              <a:t>Review screen with stages, provenance counts and a live layout preview.</a:t>
+              <a:t>Four plans compared; reroute to Line B + maintain scores 82.2 with no late units.</a:t>
             </a:r>
             <a:endParaRPr lang="en-GB" sz="1050" dirty="0"/>
           </a:p>
@@ -21748,7 +21894,7 @@
       </p:sp>
       <p:pic>
         <p:nvPicPr>
-          <p:cNvPr id="1007" name="Playground" descr="Playground"/>
+          <p:cNvPr id="1007" name="Digital Twin in 3D" descr="Digital Twin in 3D"/>
           <p:cNvPicPr>
             <a:picLocks noChangeAspect="1"/>
           </p:cNvPicPr>
@@ -21786,7 +21932,7 @@
       </p:pic>
       <p:sp>
         <p:nvSpPr>
-          <p:cNvPr id="1008" name="Playground caption"/>
+          <p:cNvPr id="1008" name="Digital Twin in 3D caption"/>
           <p:cNvSpPr txBox="1"/>
           <p:nvPr/>
         </p:nvSpPr>
@@ -21828,7 +21974,7 @@
                 <a:cs typeface="Google Sans Flex SemiBold"/>
                 <a:sym typeface="Google Sans Flex SemiBold"/>
               </a:rPr>
-              <a:t>Playground</a:t>
+              <a:t>Digital Twin in 3D</a:t>
             </a:r>
             <a:endParaRPr lang="en-GB" sz="1200" dirty="0"/>
           </a:p>
@@ -21855,7 +22001,7 @@
                 <a:cs typeface="Google Sans Flex"/>
                 <a:sym typeface="Google Sans Flex"/>
               </a:rPr>
-              <a:t>Place machines and robots on the floor and set automation rules.</a:t>
+              <a:t>Orbit the live plant; robots animate and the recommended path is highlighted.</a:t>
             </a:r>
             <a:endParaRPr lang="en-GB" sz="1050" dirty="0"/>
           </a:p>

</xml_diff>

<commit_message>
docs: add Cloud SQL to Google Cloud technologies on Slide 9
</commit_message>
<xml_diff>
--- a/docs/TwinForge_AI_Builder_Cup.pptx
+++ b/docs/TwinForge_AI_Builder_Cup.pptx
@@ -7005,6 +7005,639 @@
                 <a:cs typeface="Google Sans Flex Medium"/>
                 <a:sym typeface="Google Sans Flex Medium"/>
               </a:rPr>
+              <a:t>Snapshots of the prototype (1/2)</a:t>
+            </a:r>
+            <a:endParaRPr lang="en-GB" sz="1600" dirty="0"/>
+          </a:p>
+        </p:txBody>
+      </p:sp>
+      <p:pic>
+        <p:nvPicPr>
+          <p:cNvPr id="1001" name="Command Center" descr="Command Center"/>
+          <p:cNvPicPr>
+            <a:picLocks noChangeAspect="1"/>
+          </p:cNvPicPr>
+          <p:nvPr/>
+        </p:nvPicPr>
+        <p:blipFill>
+          <a:blip r:embed="rId5"/>
+          <a:stretch>
+            <a:fillRect/>
+          </a:stretch>
+        </p:blipFill>
+        <p:spPr>
+          <a:xfrm>
+            <a:off x="365760" y="1188720"/>
+            <a:ext cx="2606040" cy="1628775"/>
+          </a:xfrm>
+          <a:prstGeom prst="roundRect">
+            <a:avLst>
+              <a:gd name="adj" fmla="val 2807"/>
+            </a:avLst>
+          </a:prstGeom>
+          <a:ln w="9525">
+            <a:solidFill>
+              <a:srgbClr val="DADCE0"/>
+            </a:solidFill>
+          </a:ln>
+          <a:effectLst>
+            <a:outerShdw blurRad="76200" dist="19050" dir="5400000" algn="t" rotWithShape="0">
+              <a:srgbClr val="000000">
+                <a:alpha val="16000"/>
+              </a:srgbClr>
+            </a:outerShdw>
+          </a:effectLst>
+        </p:spPr>
+      </p:pic>
+      <p:sp>
+        <p:nvSpPr>
+          <p:cNvPr id="1002" name="Command Center caption"/>
+          <p:cNvSpPr txBox="1"/>
+          <p:nvPr/>
+        </p:nvSpPr>
+        <p:spPr>
+          <a:xfrm>
+            <a:off x="3081528" y="1188720"/>
+            <a:ext cx="1417320" cy="1628775"/>
+          </a:xfrm>
+          <a:prstGeom prst="rect">
+            <a:avLst/>
+          </a:prstGeom>
+          <a:noFill/>
+          <a:ln>
+            <a:noFill/>
+          </a:ln>
+        </p:spPr>
+        <p:txBody>
+          <a:bodyPr wrap="square" lIns="0" tIns="0" rIns="0" bIns="0" anchor="ctr" rtlCol="0">
+            <a:noAutofit/>
+          </a:bodyPr>
+          <a:lstStyle/>
+          <a:p>
+            <a:pPr marL="0" indent="0" algn="l">
+              <a:spcBef>
+                <a:spcPts val="0"/>
+              </a:spcBef>
+              <a:spcAft>
+                <a:spcPts val="300"/>
+              </a:spcAft>
+              <a:buNone/>
+            </a:pPr>
+            <a:r>
+              <a:rPr lang="en-GB" sz="1200" b="0" dirty="0">
+                <a:solidFill>
+                  <a:srgbClr val="202124"/>
+                </a:solidFill>
+                <a:latin typeface="Google Sans Flex SemiBold"/>
+                <a:ea typeface="Google Sans Flex SemiBold"/>
+                <a:cs typeface="Google Sans Flex SemiBold"/>
+                <a:sym typeface="Google Sans Flex SemiBold"/>
+              </a:rPr>
+              <a:t>Command Center</a:t>
+            </a:r>
+            <a:endParaRPr lang="en-GB" sz="1200" dirty="0"/>
+          </a:p>
+          <a:p>
+            <a:pPr marL="0" indent="0" algn="l">
+              <a:lnSpc>
+                <a:spcPct val="105000"/>
+              </a:lnSpc>
+              <a:spcBef>
+                <a:spcPts val="0"/>
+              </a:spcBef>
+              <a:spcAft>
+                <a:spcPts val="0"/>
+              </a:spcAft>
+              <a:buNone/>
+            </a:pPr>
+            <a:r>
+              <a:rPr lang="en-GB" sz="1050" b="0" dirty="0">
+                <a:solidFill>
+                  <a:srgbClr val="5F6368"/>
+                </a:solidFill>
+                <a:latin typeface="Google Sans Flex"/>
+                <a:ea typeface="Google Sans Flex"/>
+                <a:cs typeface="Google Sans Flex"/>
+                <a:sym typeface="Google Sans Flex"/>
+              </a:rPr>
+              <a:t>The whole plant on one screen during the crisis, with the guided demo panel.</a:t>
+            </a:r>
+            <a:endParaRPr lang="en-GB" sz="1050" dirty="0"/>
+          </a:p>
+        </p:txBody>
+      </p:sp>
+      <p:pic>
+        <p:nvPicPr>
+          <p:cNvPr id="1003" name="AI Operations" descr="AI Operations"/>
+          <p:cNvPicPr>
+            <a:picLocks noChangeAspect="1"/>
+          </p:cNvPicPr>
+          <p:nvPr/>
+        </p:nvPicPr>
+        <p:blipFill>
+          <a:blip r:embed="rId6"/>
+          <a:stretch>
+            <a:fillRect/>
+          </a:stretch>
+        </p:blipFill>
+        <p:spPr>
+          <a:xfrm>
+            <a:off x="4645152" y="1188720"/>
+            <a:ext cx="2606040" cy="1628775"/>
+          </a:xfrm>
+          <a:prstGeom prst="roundRect">
+            <a:avLst>
+              <a:gd name="adj" fmla="val 2807"/>
+            </a:avLst>
+          </a:prstGeom>
+          <a:ln w="9525">
+            <a:solidFill>
+              <a:srgbClr val="DADCE0"/>
+            </a:solidFill>
+          </a:ln>
+          <a:effectLst>
+            <a:outerShdw blurRad="76200" dist="19050" dir="5400000" algn="t" rotWithShape="0">
+              <a:srgbClr val="000000">
+                <a:alpha val="16000"/>
+              </a:srgbClr>
+            </a:outerShdw>
+          </a:effectLst>
+        </p:spPr>
+      </p:pic>
+      <p:sp>
+        <p:nvSpPr>
+          <p:cNvPr id="1004" name="AI Operations caption"/>
+          <p:cNvSpPr txBox="1"/>
+          <p:nvPr/>
+        </p:nvSpPr>
+        <p:spPr>
+          <a:xfrm>
+            <a:off x="7360920" y="1188720"/>
+            <a:ext cx="1417320" cy="1628775"/>
+          </a:xfrm>
+          <a:prstGeom prst="rect">
+            <a:avLst/>
+          </a:prstGeom>
+          <a:noFill/>
+          <a:ln>
+            <a:noFill/>
+          </a:ln>
+        </p:spPr>
+        <p:txBody>
+          <a:bodyPr wrap="square" lIns="0" tIns="0" rIns="0" bIns="0" anchor="ctr" rtlCol="0">
+            <a:noAutofit/>
+          </a:bodyPr>
+          <a:lstStyle/>
+          <a:p>
+            <a:pPr marL="0" indent="0" algn="l">
+              <a:spcBef>
+                <a:spcPts val="0"/>
+              </a:spcBef>
+              <a:spcAft>
+                <a:spcPts val="300"/>
+              </a:spcAft>
+              <a:buNone/>
+            </a:pPr>
+            <a:r>
+              <a:rPr lang="en-GB" sz="1200" b="0" dirty="0">
+                <a:solidFill>
+                  <a:srgbClr val="202124"/>
+                </a:solidFill>
+                <a:latin typeface="Google Sans Flex SemiBold"/>
+                <a:ea typeface="Google Sans Flex SemiBold"/>
+                <a:cs typeface="Google Sans Flex SemiBold"/>
+                <a:sym typeface="Google Sans Flex SemiBold"/>
+              </a:rPr>
+              <a:t>AI Operations</a:t>
+            </a:r>
+            <a:endParaRPr lang="en-GB" sz="1200" dirty="0"/>
+          </a:p>
+          <a:p>
+            <a:pPr marL="0" indent="0" algn="l">
+              <a:lnSpc>
+                <a:spcPct val="105000"/>
+              </a:lnSpc>
+              <a:spcBef>
+                <a:spcPts val="0"/>
+              </a:spcBef>
+              <a:spcAft>
+                <a:spcPts val="0"/>
+              </a:spcAft>
+              <a:buNone/>
+            </a:pPr>
+            <a:r>
+              <a:rPr lang="en-GB" sz="1050" b="0" dirty="0">
+                <a:solidFill>
+                  <a:srgbClr val="5F6368"/>
+                </a:solidFill>
+                <a:latin typeface="Google Sans Flex"/>
+                <a:ea typeface="Google Sans Flex"/>
+                <a:cs typeface="Google Sans Flex"/>
+                <a:sym typeface="Google Sans Flex"/>
+              </a:rPr>
+              <a:t>Six agents stream findings; a trip is predicted about 16 hours ahead.</a:t>
+            </a:r>
+            <a:endParaRPr lang="en-GB" sz="1050" dirty="0"/>
+          </a:p>
+        </p:txBody>
+      </p:sp>
+      <p:pic>
+        <p:nvPicPr>
+          <p:cNvPr id="1005" name="What-If Simulator" descr="What-If Simulator"/>
+          <p:cNvPicPr>
+            <a:picLocks noChangeAspect="1"/>
+          </p:cNvPicPr>
+          <p:nvPr/>
+        </p:nvPicPr>
+        <p:blipFill>
+          <a:blip r:embed="rId7"/>
+          <a:stretch>
+            <a:fillRect/>
+          </a:stretch>
+        </p:blipFill>
+        <p:spPr>
+          <a:xfrm>
+            <a:off x="365760" y="3073527"/>
+            <a:ext cx="2606040" cy="1628775"/>
+          </a:xfrm>
+          <a:prstGeom prst="roundRect">
+            <a:avLst>
+              <a:gd name="adj" fmla="val 2807"/>
+            </a:avLst>
+          </a:prstGeom>
+          <a:ln w="9525">
+            <a:solidFill>
+              <a:srgbClr val="DADCE0"/>
+            </a:solidFill>
+          </a:ln>
+          <a:effectLst>
+            <a:outerShdw blurRad="76200" dist="19050" dir="5400000" algn="t" rotWithShape="0">
+              <a:srgbClr val="000000">
+                <a:alpha val="16000"/>
+              </a:srgbClr>
+            </a:outerShdw>
+          </a:effectLst>
+        </p:spPr>
+      </p:pic>
+      <p:sp>
+        <p:nvSpPr>
+          <p:cNvPr id="1006" name="What-If Simulator caption"/>
+          <p:cNvSpPr txBox="1"/>
+          <p:nvPr/>
+        </p:nvSpPr>
+        <p:spPr>
+          <a:xfrm>
+            <a:off x="3081528" y="3073527"/>
+            <a:ext cx="1417320" cy="1628775"/>
+          </a:xfrm>
+          <a:prstGeom prst="rect">
+            <a:avLst/>
+          </a:prstGeom>
+          <a:noFill/>
+          <a:ln>
+            <a:noFill/>
+          </a:ln>
+        </p:spPr>
+        <p:txBody>
+          <a:bodyPr wrap="square" lIns="0" tIns="0" rIns="0" bIns="0" anchor="ctr" rtlCol="0">
+            <a:noAutofit/>
+          </a:bodyPr>
+          <a:lstStyle/>
+          <a:p>
+            <a:pPr marL="0" indent="0" algn="l">
+              <a:spcBef>
+                <a:spcPts val="0"/>
+              </a:spcBef>
+              <a:spcAft>
+                <a:spcPts val="300"/>
+              </a:spcAft>
+              <a:buNone/>
+            </a:pPr>
+            <a:r>
+              <a:rPr lang="en-GB" sz="1200" b="0" dirty="0">
+                <a:solidFill>
+                  <a:srgbClr val="202124"/>
+                </a:solidFill>
+                <a:latin typeface="Google Sans Flex SemiBold"/>
+                <a:ea typeface="Google Sans Flex SemiBold"/>
+                <a:cs typeface="Google Sans Flex SemiBold"/>
+                <a:sym typeface="Google Sans Flex SemiBold"/>
+              </a:rPr>
+              <a:t>What-If Simulator</a:t>
+            </a:r>
+            <a:endParaRPr lang="en-GB" sz="1200" dirty="0"/>
+          </a:p>
+          <a:p>
+            <a:pPr marL="0" indent="0" algn="l">
+              <a:lnSpc>
+                <a:spcPct val="105000"/>
+              </a:lnSpc>
+              <a:spcBef>
+                <a:spcPts val="0"/>
+              </a:spcBef>
+              <a:spcAft>
+                <a:spcPts val="0"/>
+              </a:spcAft>
+              <a:buNone/>
+            </a:pPr>
+            <a:r>
+              <a:rPr lang="en-GB" sz="1050" b="0" dirty="0">
+                <a:solidFill>
+                  <a:srgbClr val="5F6368"/>
+                </a:solidFill>
+                <a:latin typeface="Google Sans Flex"/>
+                <a:ea typeface="Google Sans Flex"/>
+                <a:cs typeface="Google Sans Flex"/>
+                <a:sym typeface="Google Sans Flex"/>
+              </a:rPr>
+              <a:t>Four plans compared; reroute to Line B + maintain scores 82.2 with no late units.</a:t>
+            </a:r>
+            <a:endParaRPr lang="en-GB" sz="1050" dirty="0"/>
+          </a:p>
+        </p:txBody>
+      </p:sp>
+      <p:pic>
+        <p:nvPicPr>
+          <p:cNvPr id="1007" name="Digital Twin in 3D" descr="Digital Twin in 3D"/>
+          <p:cNvPicPr>
+            <a:picLocks noChangeAspect="1"/>
+          </p:cNvPicPr>
+          <p:nvPr/>
+        </p:nvPicPr>
+        <p:blipFill>
+          <a:blip r:embed="rId8"/>
+          <a:stretch>
+            <a:fillRect/>
+          </a:stretch>
+        </p:blipFill>
+        <p:spPr>
+          <a:xfrm>
+            <a:off x="4645152" y="3073527"/>
+            <a:ext cx="2606040" cy="1628775"/>
+          </a:xfrm>
+          <a:prstGeom prst="roundRect">
+            <a:avLst>
+              <a:gd name="adj" fmla="val 2807"/>
+            </a:avLst>
+          </a:prstGeom>
+          <a:ln w="9525">
+            <a:solidFill>
+              <a:srgbClr val="DADCE0"/>
+            </a:solidFill>
+          </a:ln>
+          <a:effectLst>
+            <a:outerShdw blurRad="76200" dist="19050" dir="5400000" algn="t" rotWithShape="0">
+              <a:srgbClr val="000000">
+                <a:alpha val="16000"/>
+              </a:srgbClr>
+            </a:outerShdw>
+          </a:effectLst>
+        </p:spPr>
+      </p:pic>
+      <p:sp>
+        <p:nvSpPr>
+          <p:cNvPr id="1008" name="Digital Twin in 3D caption"/>
+          <p:cNvSpPr txBox="1"/>
+          <p:nvPr/>
+        </p:nvSpPr>
+        <p:spPr>
+          <a:xfrm>
+            <a:off x="7360920" y="3073527"/>
+            <a:ext cx="1417320" cy="1628775"/>
+          </a:xfrm>
+          <a:prstGeom prst="rect">
+            <a:avLst/>
+          </a:prstGeom>
+          <a:noFill/>
+          <a:ln>
+            <a:noFill/>
+          </a:ln>
+        </p:spPr>
+        <p:txBody>
+          <a:bodyPr wrap="square" lIns="0" tIns="0" rIns="0" bIns="0" anchor="ctr" rtlCol="0">
+            <a:noAutofit/>
+          </a:bodyPr>
+          <a:lstStyle/>
+          <a:p>
+            <a:pPr marL="0" indent="0" algn="l">
+              <a:spcBef>
+                <a:spcPts val="0"/>
+              </a:spcBef>
+              <a:spcAft>
+                <a:spcPts val="300"/>
+              </a:spcAft>
+              <a:buNone/>
+            </a:pPr>
+            <a:r>
+              <a:rPr lang="en-GB" sz="1200" b="0" dirty="0">
+                <a:solidFill>
+                  <a:srgbClr val="202124"/>
+                </a:solidFill>
+                <a:latin typeface="Google Sans Flex SemiBold"/>
+                <a:ea typeface="Google Sans Flex SemiBold"/>
+                <a:cs typeface="Google Sans Flex SemiBold"/>
+                <a:sym typeface="Google Sans Flex SemiBold"/>
+              </a:rPr>
+              <a:t>Digital Twin in 3D</a:t>
+            </a:r>
+            <a:endParaRPr lang="en-GB" sz="1200" dirty="0"/>
+          </a:p>
+          <a:p>
+            <a:pPr marL="0" indent="0" algn="l">
+              <a:lnSpc>
+                <a:spcPct val="105000"/>
+              </a:lnSpc>
+              <a:spcBef>
+                <a:spcPts val="0"/>
+              </a:spcBef>
+              <a:spcAft>
+                <a:spcPts val="0"/>
+              </a:spcAft>
+              <a:buNone/>
+            </a:pPr>
+            <a:r>
+              <a:rPr lang="en-GB" sz="1050" b="0" dirty="0">
+                <a:solidFill>
+                  <a:srgbClr val="5F6368"/>
+                </a:solidFill>
+                <a:latin typeface="Google Sans Flex"/>
+                <a:ea typeface="Google Sans Flex"/>
+                <a:cs typeface="Google Sans Flex"/>
+                <a:sym typeface="Google Sans Flex"/>
+              </a:rPr>
+              <a:t>Orbit the live plant; robots animate and the recommended path is highlighted.</a:t>
+            </a:r>
+            <a:endParaRPr lang="en-GB" sz="1050" dirty="0"/>
+          </a:p>
+        </p:txBody>
+      </p:sp>
+    </p:spTree>
+  </p:cSld>
+  <p:clrMapOvr>
+    <a:masterClrMapping/>
+  </p:clrMapOvr>
+</p:sld>
+</file>
+
+<file path=ppt/slides/slide11.xml><?xml version="1.0" encoding="utf-8"?>
+<p:sld xmlns:a="http://schemas.openxmlformats.org/drawingml/2006/main" xmlns:r="http://schemas.openxmlformats.org/officeDocument/2006/relationships" xmlns:mc="http://schemas.openxmlformats.org/markup-compatibility/2006" xmlns:mv="urn:schemas-microsoft-com:mac:vml" xmlns:p="http://schemas.openxmlformats.org/presentationml/2006/main" xmlns:c="http://schemas.openxmlformats.org/drawingml/2006/chart" xmlns:dgm="http://schemas.openxmlformats.org/drawingml/2006/diagram" xmlns:o="urn:schemas-microsoft-com:office:office" xmlns:v="urn:schemas-microsoft-com:vml" xmlns:pvml="urn:schemas-microsoft-com:office:powerpoint" xmlns:com="http://schemas.openxmlformats.org/drawingml/2006/compatibility" xmlns:p14="http://schemas.microsoft.com/office/powerpoint/2010/main" xmlns:p15="http://schemas.microsoft.com/office/powerpoint/2012/main" xmlns:ahyp="http://schemas.microsoft.com/office/drawing/2018/hyperlinkcolor">
+  <p:cSld>
+    <p:spTree>
+      <p:nvGrpSpPr>
+        <p:cNvPr id="131" name="Shape 131"/>
+        <p:cNvGrpSpPr/>
+        <p:nvPr/>
+      </p:nvGrpSpPr>
+      <p:grpSpPr>
+        <a:xfrm>
+          <a:off x="0" y="0"/>
+          <a:ext cx="0" cy="0"/>
+          <a:chOff x="0" y="0"/>
+          <a:chExt cx="0" cy="0"/>
+        </a:xfrm>
+      </p:grpSpPr>
+      <p:pic>
+        <p:nvPicPr>
+          <p:cNvPr id="132" name="Google Shape;132;p23" title="Frame 144.png"/>
+          <p:cNvPicPr preferRelativeResize="0"/>
+          <p:nvPr/>
+        </p:nvPicPr>
+        <p:blipFill rotWithShape="1">
+          <a:blip r:embed="rId3">
+            <a:alphaModFix/>
+          </a:blip>
+          <a:srcRect b="98001" l="0" r="0" t="0"/>
+          <a:stretch/>
+        </p:blipFill>
+        <p:spPr>
+          <a:xfrm>
+            <a:off x="0" y="5093562"/>
+            <a:ext cx="9144000" cy="54275"/>
+          </a:xfrm>
+          <a:prstGeom prst="rect">
+            <a:avLst/>
+          </a:prstGeom>
+          <a:noFill/>
+          <a:ln>
+            <a:noFill/>
+          </a:ln>
+        </p:spPr>
+      </p:pic>
+      <p:pic>
+        <p:nvPicPr>
+          <p:cNvPr id="133" name="Google Shape;133;p23" title="Group 427319979.png"/>
+          <p:cNvPicPr preferRelativeResize="0"/>
+          <p:nvPr/>
+        </p:nvPicPr>
+        <p:blipFill>
+          <a:blip r:embed="rId4">
+            <a:alphaModFix/>
+          </a:blip>
+          <a:stretch>
+            <a:fillRect/>
+          </a:stretch>
+        </p:blipFill>
+        <p:spPr>
+          <a:xfrm>
+            <a:off x="0" y="1"/>
+            <a:ext cx="9144000" cy="507359"/>
+          </a:xfrm>
+          <a:prstGeom prst="rect">
+            <a:avLst/>
+          </a:prstGeom>
+          <a:noFill/>
+          <a:ln>
+            <a:noFill/>
+          </a:ln>
+        </p:spPr>
+      </p:pic>
+      <p:sp>
+        <p:nvSpPr>
+          <p:cNvPr id="134" name="Google Shape;134;p23"/>
+          <p:cNvSpPr/>
+          <p:nvPr/>
+        </p:nvSpPr>
+        <p:spPr>
+          <a:xfrm>
+            <a:off x="-29250" y="5071875"/>
+            <a:ext cx="9173400" cy="97800"/>
+          </a:xfrm>
+          <a:prstGeom prst="rect">
+            <a:avLst/>
+          </a:prstGeom>
+          <a:solidFill>
+            <a:schemeClr val="dk1"/>
+          </a:solidFill>
+          <a:ln>
+            <a:noFill/>
+          </a:ln>
+        </p:spPr>
+        <p:txBody>
+          <a:bodyPr anchorCtr="0" anchor="ctr" bIns="91425" lIns="91425" spcFirstLastPara="1" rIns="91425" wrap="square" tIns="91425">
+            <a:noAutofit/>
+          </a:bodyPr>
+          <a:lstStyle/>
+          <a:p>
+            <a:pPr indent="0" lvl="0" marL="0" rtl="0" algn="ctr">
+              <a:spcBef>
+                <a:spcPts val="0"/>
+              </a:spcBef>
+              <a:spcAft>
+                <a:spcPts val="0"/>
+              </a:spcAft>
+              <a:buNone/>
+            </a:pPr>
+            <a:r>
+              <a:t/>
+            </a:r>
+            <a:endParaRPr/>
+          </a:p>
+        </p:txBody>
+      </p:sp>
+      <p:sp>
+        <p:nvSpPr>
+          <p:cNvPr id="135" name="Google Shape;135;p23"/>
+          <p:cNvSpPr txBox="1"/>
+          <p:nvPr/>
+        </p:nvSpPr>
+        <p:spPr>
+          <a:xfrm>
+            <a:off x="265350" y="663825"/>
+            <a:ext cx="8943000" cy="461900"/>
+          </a:xfrm>
+          <a:prstGeom prst="rect">
+            <a:avLst/>
+          </a:prstGeom>
+          <a:noFill/>
+          <a:ln>
+            <a:noFill/>
+          </a:ln>
+        </p:spPr>
+        <p:txBody>
+          <a:bodyPr anchorCtr="0" anchor="t" bIns="91425" lIns="91425" spcFirstLastPara="1" rIns="91425" wrap="square" tIns="91425">
+            <a:noAutofit/>
+          </a:bodyPr>
+          <a:lstStyle/>
+          <a:p>
+            <a:pPr marL="0" indent="0" algn="l">
+              <a:spcBef>
+                <a:spcPts val="0"/>
+              </a:spcBef>
+              <a:spcAft>
+                <a:spcPts val="0"/>
+              </a:spcAft>
+              <a:buNone/>
+            </a:pPr>
+            <a:r>
+              <a:rPr lang="en-GB" sz="1600" b="0" dirty="0">
+                <a:solidFill>
+                  <a:srgbClr val="000000"/>
+                </a:solidFill>
+                <a:latin typeface="Google Sans Flex Medium"/>
+                <a:ea typeface="Google Sans Flex Medium"/>
+                <a:cs typeface="Google Sans Flex Medium"/>
+                <a:sym typeface="Google Sans Flex Medium"/>
+              </a:rPr>
               <a:t>Snapshots of the prototype (2/2)</a:t>
             </a:r>
             <a:endParaRPr lang="en-GB" sz="1600" dirty="0"/>
@@ -7479,7 +8112,7 @@
 </p:sld>
 </file>
 
-<file path=ppt/slides/slide11.xml><?xml version="1.0" encoding="utf-8"?>
+<file path=ppt/slides/slide12.xml><?xml version="1.0" encoding="utf-8"?>
 <p:sld xmlns:a="http://schemas.openxmlformats.org/drawingml/2006/main" xmlns:r="http://schemas.openxmlformats.org/officeDocument/2006/relationships" xmlns:mc="http://schemas.openxmlformats.org/markup-compatibility/2006" xmlns:mv="urn:schemas-microsoft-com:mac:vml" xmlns:p="http://schemas.openxmlformats.org/presentationml/2006/main" xmlns:c="http://schemas.openxmlformats.org/drawingml/2006/chart" xmlns:dgm="http://schemas.openxmlformats.org/drawingml/2006/diagram" xmlns:o="urn:schemas-microsoft-com:office:office" xmlns:v="urn:schemas-microsoft-com:vml" xmlns:pvml="urn:schemas-microsoft-com:office:powerpoint" xmlns:com="http://schemas.openxmlformats.org/drawingml/2006/compatibility" xmlns:p14="http://schemas.microsoft.com/office/powerpoint/2010/main" xmlns:p15="http://schemas.microsoft.com/office/powerpoint/2012/main" xmlns:ahyp="http://schemas.microsoft.com/office/drawing/2018/hyperlinkcolor">
   <p:cSld>
     <p:spTree>
@@ -10164,7 +10797,7 @@
 </p:sld>
 </file>
 
-<file path=ppt/slides/slide12.xml><?xml version="1.0" encoding="utf-8"?>
+<file path=ppt/slides/slide13.xml><?xml version="1.0" encoding="utf-8"?>
 <p:sld xmlns:a="http://schemas.openxmlformats.org/drawingml/2006/main" xmlns:r="http://schemas.openxmlformats.org/officeDocument/2006/relationships" xmlns:mc="http://schemas.openxmlformats.org/markup-compatibility/2006" xmlns:mv="urn:schemas-microsoft-com:mac:vml" xmlns:p="http://schemas.openxmlformats.org/presentationml/2006/main" xmlns:c="http://schemas.openxmlformats.org/drawingml/2006/chart" xmlns:dgm="http://schemas.openxmlformats.org/drawingml/2006/diagram" xmlns:o="urn:schemas-microsoft-com:office:office" xmlns:v="urn:schemas-microsoft-com:vml" xmlns:pvml="urn:schemas-microsoft-com:office:powerpoint" xmlns:com="http://schemas.openxmlformats.org/drawingml/2006/compatibility" xmlns:p14="http://schemas.microsoft.com/office/powerpoint/2010/main" xmlns:p15="http://schemas.microsoft.com/office/powerpoint/2012/main" xmlns:ahyp="http://schemas.microsoft.com/office/drawing/2018/hyperlinkcolor">
   <p:cSld>
     <p:spTree>
@@ -11471,7 +12104,7 @@
 </p:sld>
 </file>
 
-<file path=ppt/slides/slide13.xml><?xml version="1.0" encoding="utf-8"?>
+<file path=ppt/slides/slide14.xml><?xml version="1.0" encoding="utf-8"?>
 <p:sld xmlns:a="http://schemas.openxmlformats.org/drawingml/2006/main" xmlns:r="http://schemas.openxmlformats.org/officeDocument/2006/relationships" xmlns:mc="http://schemas.openxmlformats.org/markup-compatibility/2006" xmlns:mv="urn:schemas-microsoft-com:mac:vml" xmlns:p="http://schemas.openxmlformats.org/presentationml/2006/main" xmlns:c="http://schemas.openxmlformats.org/drawingml/2006/chart" xmlns:dgm="http://schemas.openxmlformats.org/drawingml/2006/diagram" xmlns:o="urn:schemas-microsoft-com:office:office" xmlns:v="urn:schemas-microsoft-com:vml" xmlns:pvml="urn:schemas-microsoft-com:office:powerpoint" xmlns:com="http://schemas.openxmlformats.org/drawingml/2006/compatibility" xmlns:p14="http://schemas.microsoft.com/office/powerpoint/2010/main" xmlns:p15="http://schemas.microsoft.com/office/powerpoint/2012/main" xmlns:ahyp="http://schemas.microsoft.com/office/drawing/2018/hyperlinkcolor">
   <p:cSld>
     <p:spTree>
@@ -12213,7 +12846,7 @@
 </p:sld>
 </file>
 
-<file path=ppt/slides/slide14.xml><?xml version="1.0" encoding="utf-8"?>
+<file path=ppt/slides/slide15.xml><?xml version="1.0" encoding="utf-8"?>
 <p:sld xmlns:a="http://schemas.openxmlformats.org/drawingml/2006/main" xmlns:r="http://schemas.openxmlformats.org/officeDocument/2006/relationships" xmlns:mc="http://schemas.openxmlformats.org/markup-compatibility/2006" xmlns:mv="urn:schemas-microsoft-com:mac:vml" xmlns:p="http://schemas.openxmlformats.org/presentationml/2006/main" xmlns:c="http://schemas.openxmlformats.org/drawingml/2006/chart" xmlns:dgm="http://schemas.openxmlformats.org/drawingml/2006/diagram" xmlns:o="urn:schemas-microsoft-com:office:office" xmlns:v="urn:schemas-microsoft-com:vml" xmlns:pvml="urn:schemas-microsoft-com:office:powerpoint" xmlns:com="http://schemas.openxmlformats.org/drawingml/2006/compatibility" xmlns:p14="http://schemas.microsoft.com/office/powerpoint/2010/main" xmlns:p15="http://schemas.microsoft.com/office/powerpoint/2012/main" xmlns:ahyp="http://schemas.microsoft.com/office/drawing/2018/hyperlinkcolor">
   <p:cSld>
     <p:spTree>
@@ -12283,199 +12916,6 @@
           <a:ln>
             <a:noFill/>
           </a:ln>
-        </p:spPr>
-      </p:pic>
-    </p:spTree>
-  </p:cSld>
-  <p:clrMapOvr>
-    <a:masterClrMapping/>
-  </p:clrMapOvr>
-</p:sld>
-</file>
-
-<file path=ppt/slides/slide15.xml><?xml version="1.0" encoding="utf-8"?>
-<p:sld xmlns:a="http://schemas.openxmlformats.org/drawingml/2006/main" xmlns:p="http://schemas.openxmlformats.org/presentationml/2006/main" xmlns:r="http://schemas.openxmlformats.org/officeDocument/2006/relationships">
-  <p:cSld>
-    <p:spTree>
-      <p:nvGrpSpPr>
-        <p:cNvPr id="1" name=""/>
-        <p:cNvGrpSpPr/>
-        <p:nvPr/>
-      </p:nvGrpSpPr>
-      <p:grpSpPr/>
-      <p:pic>
-        <p:nvPicPr>
-          <p:cNvPr id="2" name="Picture 1" descr="image.png"/>
-          <p:cNvPicPr>
-            <a:picLocks noChangeAspect="1"/>
-          </p:cNvPicPr>
-          <p:nvPr/>
-        </p:nvPicPr>
-        <p:blipFill>
-          <a:blip r:embed="rId2"/>
-          <a:stretch>
-            <a:fillRect/>
-          </a:stretch>
-        </p:blipFill>
-        <p:spPr>
-          <a:xfrm>
-            <a:off x="0" y="1"/>
-            <a:ext cx="9144000" cy="507359"/>
-          </a:xfrm>
-          <a:prstGeom prst="rect">
-            <a:avLst/>
-          </a:prstGeom>
-        </p:spPr>
-      </p:pic>
-      <p:pic>
-        <p:nvPicPr>
-          <p:cNvPr id="3" name="Picture 2" descr="image.png"/>
-          <p:cNvPicPr>
-            <a:picLocks noChangeAspect="1"/>
-          </p:cNvPicPr>
-          <p:nvPr/>
-        </p:nvPicPr>
-        <p:blipFill>
-          <a:blip r:embed="rId3"/>
-          <a:stretch>
-            <a:fillRect/>
-          </a:stretch>
-        </p:blipFill>
-        <p:spPr>
-          <a:xfrm>
-            <a:off x="0" y="5093562"/>
-            <a:ext cx="9144000" cy="54275"/>
-          </a:xfrm>
-          <a:prstGeom prst="rect">
-            <a:avLst/>
-          </a:prstGeom>
-        </p:spPr>
-      </p:pic>
-      <p:sp>
-        <p:nvSpPr>
-          <p:cNvPr id="110" name="Google Shape;110;p20"/>
-          <p:cNvSpPr/>
-          <p:nvPr/>
-        </p:nvSpPr>
-        <p:spPr>
-          <a:xfrm>
-            <a:off x="-29250" y="5071875"/>
-            <a:ext cx="9173400" cy="97800"/>
-          </a:xfrm>
-          <a:prstGeom prst="rect">
-            <a:avLst/>
-          </a:prstGeom>
-          <a:solidFill>
-            <a:schemeClr val="dk1"/>
-          </a:solidFill>
-          <a:ln>
-            <a:noFill/>
-          </a:ln>
-        </p:spPr>
-        <p:txBody>
-          <a:bodyPr anchorCtr="0" anchor="ctr" bIns="91425" lIns="91425" spcFirstLastPara="1" rIns="91425" wrap="square" tIns="91425">
-            <a:noAutofit/>
-          </a:bodyPr>
-          <a:lstStyle/>
-          <a:p>
-            <a:pPr indent="0" lvl="0" marL="0" rtl="0" algn="ctr">
-              <a:spcBef>
-                <a:spcPts val="0"/>
-              </a:spcBef>
-              <a:spcAft>
-                <a:spcPts val="0"/>
-              </a:spcAft>
-              <a:buNone/>
-            </a:pPr>
-            <a:r>
-              <a:t/>
-            </a:r>
-            <a:endParaRPr/>
-          </a:p>
-        </p:txBody>
-      </p:sp>
-      <p:sp>
-        <p:nvSpPr>
-          <p:cNvPr id="111" name="TextBox 110"/>
-          <p:cNvSpPr txBox="1"/>
-          <p:nvPr/>
-        </p:nvSpPr>
-        <p:spPr>
-          <a:xfrm>
-            <a:off x="265350" y="663825"/>
-            <a:ext cx="8943000" cy="461900"/>
-          </a:xfrm>
-          <a:prstGeom prst="rect">
-            <a:avLst/>
-          </a:prstGeom>
-          <a:noFill/>
-        </p:spPr>
-        <p:txBody>
-          <a:bodyPr wrap="none">
-            <a:spAutoFit/>
-          </a:bodyPr>
-          <a:lstStyle/>
-          <a:p>
-            <a:pPr>
-              <a:defRPr sz="1600">
-                <a:solidFill>
-                  <a:srgbClr val="000000"/>
-                </a:solidFill>
-                <a:latin typeface="Google Sans Flex"/>
-              </a:defRPr>
-            </a:pPr>
-            <a:r>
-              <a:t>Architecture diagrams of individual features (2/2)</a:t>
-            </a:r>
-          </a:p>
-        </p:txBody>
-      </p:sp>
-      <p:pic>
-        <p:nvPicPr>
-          <p:cNvPr id="112" name="Picture 111" descr="image.jpg"/>
-          <p:cNvPicPr>
-            <a:picLocks noChangeAspect="1"/>
-          </p:cNvPicPr>
-          <p:nvPr/>
-        </p:nvPicPr>
-        <p:blipFill>
-          <a:blip r:embed="rId4"/>
-          <a:stretch>
-            <a:fillRect/>
-          </a:stretch>
-        </p:blipFill>
-        <p:spPr>
-          <a:xfrm>
-            <a:off x="200000" y="1420000"/>
-            <a:ext cx="4282000" cy="2851879"/>
-          </a:xfrm>
-          <a:prstGeom prst="rect">
-            <a:avLst/>
-          </a:prstGeom>
-        </p:spPr>
-      </p:pic>
-      <p:pic>
-        <p:nvPicPr>
-          <p:cNvPr id="113" name="Picture 112" descr="image.jpg"/>
-          <p:cNvPicPr>
-            <a:picLocks noChangeAspect="1"/>
-          </p:cNvPicPr>
-          <p:nvPr/>
-        </p:nvPicPr>
-        <p:blipFill>
-          <a:blip r:embed="rId5"/>
-          <a:stretch>
-            <a:fillRect/>
-          </a:stretch>
-        </p:blipFill>
-        <p:spPr>
-          <a:xfrm>
-            <a:off x="4662000" y="1420000"/>
-            <a:ext cx="4282000" cy="2851879"/>
-          </a:xfrm>
-          <a:prstGeom prst="rect">
-            <a:avLst/>
-          </a:prstGeom>
         </p:spPr>
       </p:pic>
     </p:spTree>
@@ -17069,6 +17509,199 @@
 </file>
 
 <file path=ppt/slides/slide8.xml><?xml version="1.0" encoding="utf-8"?>
+<p:sld xmlns:a="http://schemas.openxmlformats.org/drawingml/2006/main" xmlns:p="http://schemas.openxmlformats.org/presentationml/2006/main" xmlns:r="http://schemas.openxmlformats.org/officeDocument/2006/relationships">
+  <p:cSld>
+    <p:spTree>
+      <p:nvGrpSpPr>
+        <p:cNvPr id="1" name=""/>
+        <p:cNvGrpSpPr/>
+        <p:nvPr/>
+      </p:nvGrpSpPr>
+      <p:grpSpPr/>
+      <p:pic>
+        <p:nvPicPr>
+          <p:cNvPr id="2" name="Picture 1" descr="image.png"/>
+          <p:cNvPicPr>
+            <a:picLocks noChangeAspect="1"/>
+          </p:cNvPicPr>
+          <p:nvPr/>
+        </p:nvPicPr>
+        <p:blipFill>
+          <a:blip r:embed="rId2"/>
+          <a:stretch>
+            <a:fillRect/>
+          </a:stretch>
+        </p:blipFill>
+        <p:spPr>
+          <a:xfrm>
+            <a:off x="0" y="1"/>
+            <a:ext cx="9144000" cy="507359"/>
+          </a:xfrm>
+          <a:prstGeom prst="rect">
+            <a:avLst/>
+          </a:prstGeom>
+        </p:spPr>
+      </p:pic>
+      <p:pic>
+        <p:nvPicPr>
+          <p:cNvPr id="3" name="Picture 2" descr="image.png"/>
+          <p:cNvPicPr>
+            <a:picLocks noChangeAspect="1"/>
+          </p:cNvPicPr>
+          <p:nvPr/>
+        </p:nvPicPr>
+        <p:blipFill>
+          <a:blip r:embed="rId3"/>
+          <a:stretch>
+            <a:fillRect/>
+          </a:stretch>
+        </p:blipFill>
+        <p:spPr>
+          <a:xfrm>
+            <a:off x="0" y="5093562"/>
+            <a:ext cx="9144000" cy="54275"/>
+          </a:xfrm>
+          <a:prstGeom prst="rect">
+            <a:avLst/>
+          </a:prstGeom>
+        </p:spPr>
+      </p:pic>
+      <p:sp>
+        <p:nvSpPr>
+          <p:cNvPr id="110" name="Google Shape;110;p20"/>
+          <p:cNvSpPr/>
+          <p:nvPr/>
+        </p:nvSpPr>
+        <p:spPr>
+          <a:xfrm>
+            <a:off x="-29250" y="5071875"/>
+            <a:ext cx="9173400" cy="97800"/>
+          </a:xfrm>
+          <a:prstGeom prst="rect">
+            <a:avLst/>
+          </a:prstGeom>
+          <a:solidFill>
+            <a:schemeClr val="dk1"/>
+          </a:solidFill>
+          <a:ln>
+            <a:noFill/>
+          </a:ln>
+        </p:spPr>
+        <p:txBody>
+          <a:bodyPr anchorCtr="0" anchor="ctr" bIns="91425" lIns="91425" spcFirstLastPara="1" rIns="91425" wrap="square" tIns="91425">
+            <a:noAutofit/>
+          </a:bodyPr>
+          <a:lstStyle/>
+          <a:p>
+            <a:pPr indent="0" lvl="0" marL="0" rtl="0" algn="ctr">
+              <a:spcBef>
+                <a:spcPts val="0"/>
+              </a:spcBef>
+              <a:spcAft>
+                <a:spcPts val="0"/>
+              </a:spcAft>
+              <a:buNone/>
+            </a:pPr>
+            <a:r>
+              <a:t/>
+            </a:r>
+            <a:endParaRPr/>
+          </a:p>
+        </p:txBody>
+      </p:sp>
+      <p:sp>
+        <p:nvSpPr>
+          <p:cNvPr id="111" name="TextBox 110"/>
+          <p:cNvSpPr txBox="1"/>
+          <p:nvPr/>
+        </p:nvSpPr>
+        <p:spPr>
+          <a:xfrm>
+            <a:off x="265350" y="663825"/>
+            <a:ext cx="8943000" cy="461900"/>
+          </a:xfrm>
+          <a:prstGeom prst="rect">
+            <a:avLst/>
+          </a:prstGeom>
+          <a:noFill/>
+        </p:spPr>
+        <p:txBody>
+          <a:bodyPr wrap="none">
+            <a:spAutoFit/>
+          </a:bodyPr>
+          <a:lstStyle/>
+          <a:p>
+            <a:pPr>
+              <a:defRPr sz="1600">
+                <a:solidFill>
+                  <a:srgbClr val="000000"/>
+                </a:solidFill>
+                <a:latin typeface="Google Sans Flex"/>
+              </a:defRPr>
+            </a:pPr>
+            <a:r>
+              <a:t>Architecture diagrams of individual features (2/2)</a:t>
+            </a:r>
+          </a:p>
+        </p:txBody>
+      </p:sp>
+      <p:pic>
+        <p:nvPicPr>
+          <p:cNvPr id="112" name="Picture 111" descr="image.jpg"/>
+          <p:cNvPicPr>
+            <a:picLocks noChangeAspect="1"/>
+          </p:cNvPicPr>
+          <p:nvPr/>
+        </p:nvPicPr>
+        <p:blipFill>
+          <a:blip r:embed="rId4"/>
+          <a:stretch>
+            <a:fillRect/>
+          </a:stretch>
+        </p:blipFill>
+        <p:spPr>
+          <a:xfrm>
+            <a:off x="200000" y="1420000"/>
+            <a:ext cx="4282000" cy="2851879"/>
+          </a:xfrm>
+          <a:prstGeom prst="rect">
+            <a:avLst/>
+          </a:prstGeom>
+        </p:spPr>
+      </p:pic>
+      <p:pic>
+        <p:nvPicPr>
+          <p:cNvPr id="113" name="Picture 112" descr="image.jpg"/>
+          <p:cNvPicPr>
+            <a:picLocks noChangeAspect="1"/>
+          </p:cNvPicPr>
+          <p:nvPr/>
+        </p:nvPicPr>
+        <p:blipFill>
+          <a:blip r:embed="rId5"/>
+          <a:stretch>
+            <a:fillRect/>
+          </a:stretch>
+        </p:blipFill>
+        <p:spPr>
+          <a:xfrm>
+            <a:off x="4662000" y="1420000"/>
+            <a:ext cx="4282000" cy="2851879"/>
+          </a:xfrm>
+          <a:prstGeom prst="rect">
+            <a:avLst/>
+          </a:prstGeom>
+        </p:spPr>
+      </p:pic>
+    </p:spTree>
+  </p:cSld>
+  <p:clrMapOvr>
+    <a:masterClrMapping/>
+  </p:clrMapOvr>
+</p:sld>
+</file>
+
+<file path=ppt/slides/slide9.xml><?xml version="1.0" encoding="utf-8"?>
 <p:sld xmlns:a="http://schemas.openxmlformats.org/drawingml/2006/main" xmlns:r="http://schemas.openxmlformats.org/officeDocument/2006/relationships" xmlns:mc="http://schemas.openxmlformats.org/markup-compatibility/2006" xmlns:mv="urn:schemas-microsoft-com:mac:vml" xmlns:p="http://schemas.openxmlformats.org/presentationml/2006/main" xmlns:c="http://schemas.openxmlformats.org/drawingml/2006/chart" xmlns:dgm="http://schemas.openxmlformats.org/drawingml/2006/diagram" xmlns:o="urn:schemas-microsoft-com:office:office" xmlns:v="urn:schemas-microsoft-com:vml" xmlns:pvml="urn:schemas-microsoft-com:office:powerpoint" xmlns:com="http://schemas.openxmlformats.org/drawingml/2006/compatibility" xmlns:p14="http://schemas.microsoft.com/office/powerpoint/2010/main" xmlns:p15="http://schemas.microsoft.com/office/powerpoint/2012/main" xmlns:ahyp="http://schemas.microsoft.com/office/drawing/2018/hyperlinkcolor">
   <p:cSld>
     <p:spTree>
@@ -21374,636 +22007,106 @@
           </a:p>
         </p:txBody>
       </p:sp>
-    </p:spTree>
-  </p:cSld>
-  <p:clrMapOvr>
-    <a:masterClrMapping/>
-  </p:clrMapOvr>
-</p:sld>
-</file>
-
-<file path=ppt/slides/slide9.xml><?xml version="1.0" encoding="utf-8"?>
-<p:sld xmlns:a="http://schemas.openxmlformats.org/drawingml/2006/main" xmlns:r="http://schemas.openxmlformats.org/officeDocument/2006/relationships" xmlns:mc="http://schemas.openxmlformats.org/markup-compatibility/2006" xmlns:mv="urn:schemas-microsoft-com:mac:vml" xmlns:p="http://schemas.openxmlformats.org/presentationml/2006/main" xmlns:c="http://schemas.openxmlformats.org/drawingml/2006/chart" xmlns:dgm="http://schemas.openxmlformats.org/drawingml/2006/diagram" xmlns:o="urn:schemas-microsoft-com:office:office" xmlns:v="urn:schemas-microsoft-com:vml" xmlns:pvml="urn:schemas-microsoft-com:office:powerpoint" xmlns:com="http://schemas.openxmlformats.org/drawingml/2006/compatibility" xmlns:p14="http://schemas.microsoft.com/office/powerpoint/2010/main" xmlns:p15="http://schemas.microsoft.com/office/powerpoint/2012/main" xmlns:ahyp="http://schemas.microsoft.com/office/drawing/2018/hyperlinkcolor">
-  <p:cSld>
-    <p:spTree>
-      <p:nvGrpSpPr>
-        <p:cNvPr id="131" name="Shape 131"/>
-        <p:cNvGrpSpPr/>
-        <p:nvPr/>
-      </p:nvGrpSpPr>
-      <p:grpSpPr>
-        <a:xfrm>
-          <a:off x="0" y="0"/>
-          <a:ext cx="0" cy="0"/>
-          <a:chOff x="0" y="0"/>
-          <a:chExt cx="0" cy="0"/>
-        </a:xfrm>
-      </p:grpSpPr>
+      <p:sp>
+        <p:nvSpPr>
+          <p:cNvPr id="1109" name="Cloud SQL chip"/>
+          <p:cNvSpPr/>
+          <p:nvPr/>
+        </p:nvSpPr>
+        <p:spPr>
+          <a:xfrm>
+            <a:off x="7608305" y="2322576"/>
+            <a:ext cx="1030000" cy="274320"/>
+          </a:xfrm>
+          <a:prstGeom prst="roundRect">
+            <a:avLst/>
+          </a:prstGeom>
+          <a:solidFill>
+            <a:srgbClr val="FFFFFF"/>
+          </a:solidFill>
+          <a:ln w="9525">
+            <a:solidFill>
+              <a:srgbClr val="DADCE0"/>
+            </a:solidFill>
+          </a:ln>
+        </p:spPr>
+        <p:style>
+          <a:lnRef idx="1">
+            <a:schemeClr val="accent1"/>
+          </a:lnRef>
+          <a:fillRef idx="3">
+            <a:schemeClr val="accent1"/>
+          </a:fillRef>
+          <a:effectRef idx="2">
+            <a:schemeClr val="accent1"/>
+          </a:effectRef>
+          <a:fontRef idx="minor">
+            <a:schemeClr val="lt1"/>
+          </a:fontRef>
+        </p:style>
+        <p:txBody>
+          <a:bodyPr rtlCol="0" anchor="ctr"/>
+          <a:lstStyle/>
+          <a:p>
+            <a:pPr algn="ctr"/>
+          </a:p>
+        </p:txBody>
+      </p:sp>
       <p:pic>
         <p:nvPicPr>
-          <p:cNvPr id="132" name="Google Shape;132;p23" title="Frame 144.png"/>
-          <p:cNvPicPr preferRelativeResize="0"/>
-          <p:nvPr/>
-        </p:nvPicPr>
-        <p:blipFill rotWithShape="1">
-          <a:blip r:embed="rId3">
-            <a:alphaModFix/>
-          </a:blip>
-          <a:srcRect b="98001" l="0" r="0" t="0"/>
-          <a:stretch/>
-        </p:blipFill>
-        <p:spPr>
-          <a:xfrm>
-            <a:off x="0" y="5093562"/>
-            <a:ext cx="9144000" cy="54275"/>
-          </a:xfrm>
-          <a:prstGeom prst="rect">
-            <a:avLst/>
-          </a:prstGeom>
-          <a:noFill/>
-          <a:ln>
-            <a:noFill/>
-          </a:ln>
-        </p:spPr>
-      </p:pic>
-      <p:pic>
-        <p:nvPicPr>
-          <p:cNvPr id="133" name="Google Shape;133;p23" title="Group 427319979.png"/>
-          <p:cNvPicPr preferRelativeResize="0"/>
+          <p:cNvPr id="1110" name="Cloud SQL logo" descr="cloud_sql.png"/>
+          <p:cNvPicPr>
+            <a:picLocks noChangeAspect="1"/>
+          </p:cNvPicPr>
           <p:nvPr/>
         </p:nvPicPr>
         <p:blipFill>
-          <a:blip r:embed="rId4">
-            <a:alphaModFix/>
-          </a:blip>
+          <a:blip r:embed="rId33"/>
           <a:stretch>
             <a:fillRect/>
           </a:stretch>
         </p:blipFill>
         <p:spPr>
           <a:xfrm>
-            <a:off x="0" y="1"/>
-            <a:ext cx="9144000" cy="507359"/>
+            <a:off x="7718033" y="2377440"/>
+            <a:ext cx="164592" cy="164592"/>
+          </a:xfrm>
+          <a:prstGeom prst="rect">
+            <a:avLst/>
+          </a:prstGeom>
+        </p:spPr>
+      </p:pic>
+      <p:sp>
+        <p:nvSpPr>
+          <p:cNvPr id="1111" name="Cloud SQL label"/>
+          <p:cNvSpPr txBox="1"/>
+          <p:nvPr/>
+        </p:nvSpPr>
+        <p:spPr>
+          <a:xfrm>
+            <a:off x="7946633" y="2322576"/>
+            <a:ext cx="600000" cy="274320"/>
           </a:xfrm>
           <a:prstGeom prst="rect">
             <a:avLst/>
           </a:prstGeom>
           <a:noFill/>
-          <a:ln>
-            <a:noFill/>
-          </a:ln>
-        </p:spPr>
-      </p:pic>
-      <p:sp>
-        <p:nvSpPr>
-          <p:cNvPr id="134" name="Google Shape;134;p23"/>
-          <p:cNvSpPr/>
-          <p:nvPr/>
-        </p:nvSpPr>
-        <p:spPr>
-          <a:xfrm>
-            <a:off x="-29250" y="5071875"/>
-            <a:ext cx="9173400" cy="97800"/>
-          </a:xfrm>
-          <a:prstGeom prst="rect">
-            <a:avLst/>
-          </a:prstGeom>
-          <a:solidFill>
-            <a:schemeClr val="dk1"/>
-          </a:solidFill>
-          <a:ln>
-            <a:noFill/>
-          </a:ln>
-        </p:spPr>
-        <p:txBody>
-          <a:bodyPr anchorCtr="0" anchor="ctr" bIns="91425" lIns="91425" spcFirstLastPara="1" rIns="91425" wrap="square" tIns="91425">
-            <a:noAutofit/>
-          </a:bodyPr>
-          <a:lstStyle/>
-          <a:p>
-            <a:pPr indent="0" lvl="0" marL="0" rtl="0" algn="ctr">
-              <a:spcBef>
-                <a:spcPts val="0"/>
-              </a:spcBef>
-              <a:spcAft>
-                <a:spcPts val="0"/>
-              </a:spcAft>
-              <a:buNone/>
-            </a:pPr>
+        </p:spPr>
+        <p:txBody>
+          <a:bodyPr wrap="none" lIns="0" rIns="0" tIns="0" bIns="0" anchor="ctr">
+            <a:spAutoFit/>
+          </a:bodyPr>
+          <a:lstStyle/>
+          <a:p>
             <a:r>
-              <a:t/>
-            </a:r>
-            <a:endParaRPr/>
-          </a:p>
-        </p:txBody>
-      </p:sp>
-      <p:sp>
-        <p:nvSpPr>
-          <p:cNvPr id="135" name="Google Shape;135;p23"/>
-          <p:cNvSpPr txBox="1"/>
-          <p:nvPr/>
-        </p:nvSpPr>
-        <p:spPr>
-          <a:xfrm>
-            <a:off x="265350" y="663825"/>
-            <a:ext cx="8943000" cy="461900"/>
-          </a:xfrm>
-          <a:prstGeom prst="rect">
-            <a:avLst/>
-          </a:prstGeom>
-          <a:noFill/>
-          <a:ln>
-            <a:noFill/>
-          </a:ln>
-        </p:spPr>
-        <p:txBody>
-          <a:bodyPr anchorCtr="0" anchor="t" bIns="91425" lIns="91425" spcFirstLastPara="1" rIns="91425" wrap="square" tIns="91425">
-            <a:noAutofit/>
-          </a:bodyPr>
-          <a:lstStyle/>
-          <a:p>
-            <a:pPr marL="0" indent="0" algn="l">
-              <a:spcBef>
-                <a:spcPts val="0"/>
-              </a:spcBef>
-              <a:spcAft>
-                <a:spcPts val="0"/>
-              </a:spcAft>
-              <a:buNone/>
-            </a:pPr>
-            <a:r>
-              <a:rPr lang="en-GB" sz="1600" b="0" dirty="0">
-                <a:solidFill>
-                  <a:srgbClr val="000000"/>
-                </a:solidFill>
-                <a:latin typeface="Google Sans Flex Medium"/>
-                <a:ea typeface="Google Sans Flex Medium"/>
-                <a:cs typeface="Google Sans Flex Medium"/>
-                <a:sym typeface="Google Sans Flex Medium"/>
-              </a:rPr>
-              <a:t>Snapshots of the prototype (1/2)</a:t>
-            </a:r>
-            <a:endParaRPr lang="en-GB" sz="1600" dirty="0"/>
-          </a:p>
-        </p:txBody>
-      </p:sp>
-      <p:pic>
-        <p:nvPicPr>
-          <p:cNvPr id="1001" name="Command Center" descr="Command Center"/>
-          <p:cNvPicPr>
-            <a:picLocks noChangeAspect="1"/>
-          </p:cNvPicPr>
-          <p:nvPr/>
-        </p:nvPicPr>
-        <p:blipFill>
-          <a:blip r:embed="rId5"/>
-          <a:stretch>
-            <a:fillRect/>
-          </a:stretch>
-        </p:blipFill>
-        <p:spPr>
-          <a:xfrm>
-            <a:off x="365760" y="1188720"/>
-            <a:ext cx="2606040" cy="1628775"/>
-          </a:xfrm>
-          <a:prstGeom prst="roundRect">
-            <a:avLst>
-              <a:gd name="adj" fmla="val 2807"/>
-            </a:avLst>
-          </a:prstGeom>
-          <a:ln w="9525">
-            <a:solidFill>
-              <a:srgbClr val="DADCE0"/>
-            </a:solidFill>
-          </a:ln>
-          <a:effectLst>
-            <a:outerShdw blurRad="76200" dist="19050" dir="5400000" algn="t" rotWithShape="0">
-              <a:srgbClr val="000000">
-                <a:alpha val="16000"/>
-              </a:srgbClr>
-            </a:outerShdw>
-          </a:effectLst>
-        </p:spPr>
-      </p:pic>
-      <p:sp>
-        <p:nvSpPr>
-          <p:cNvPr id="1002" name="Command Center caption"/>
-          <p:cNvSpPr txBox="1"/>
-          <p:nvPr/>
-        </p:nvSpPr>
-        <p:spPr>
-          <a:xfrm>
-            <a:off x="3081528" y="1188720"/>
-            <a:ext cx="1417320" cy="1628775"/>
-          </a:xfrm>
-          <a:prstGeom prst="rect">
-            <a:avLst/>
-          </a:prstGeom>
-          <a:noFill/>
-          <a:ln>
-            <a:noFill/>
-          </a:ln>
-        </p:spPr>
-        <p:txBody>
-          <a:bodyPr wrap="square" lIns="0" tIns="0" rIns="0" bIns="0" anchor="ctr" rtlCol="0">
-            <a:noAutofit/>
-          </a:bodyPr>
-          <a:lstStyle/>
-          <a:p>
-            <a:pPr marL="0" indent="0" algn="l">
-              <a:spcBef>
-                <a:spcPts val="0"/>
-              </a:spcBef>
-              <a:spcAft>
-                <a:spcPts val="300"/>
-              </a:spcAft>
-              <a:buNone/>
-            </a:pPr>
-            <a:r>
-              <a:rPr lang="en-GB" sz="1200" b="0" dirty="0">
+              <a:rPr sz="1050" b="0">
                 <a:solidFill>
                   <a:srgbClr val="202124"/>
                 </a:solidFill>
-                <a:latin typeface="Google Sans Flex SemiBold"/>
-                <a:ea typeface="Google Sans Flex SemiBold"/>
-                <a:cs typeface="Google Sans Flex SemiBold"/>
-                <a:sym typeface="Google Sans Flex SemiBold"/>
+                <a:latin typeface="Google Sans Flex Medium"/>
               </a:rPr>
-              <a:t>Command Center</a:t>
+              <a:t>Cloud SQL</a:t>
             </a:r>
-            <a:endParaRPr lang="en-GB" sz="1200" dirty="0"/>
-          </a:p>
-          <a:p>
-            <a:pPr marL="0" indent="0" algn="l">
-              <a:lnSpc>
-                <a:spcPct val="105000"/>
-              </a:lnSpc>
-              <a:spcBef>
-                <a:spcPts val="0"/>
-              </a:spcBef>
-              <a:spcAft>
-                <a:spcPts val="0"/>
-              </a:spcAft>
-              <a:buNone/>
-            </a:pPr>
-            <a:r>
-              <a:rPr lang="en-GB" sz="1050" b="0" dirty="0">
-                <a:solidFill>
-                  <a:srgbClr val="5F6368"/>
-                </a:solidFill>
-                <a:latin typeface="Google Sans Flex"/>
-                <a:ea typeface="Google Sans Flex"/>
-                <a:cs typeface="Google Sans Flex"/>
-                <a:sym typeface="Google Sans Flex"/>
-              </a:rPr>
-              <a:t>The whole plant on one screen during the crisis, with the guided demo panel.</a:t>
-            </a:r>
-            <a:endParaRPr lang="en-GB" sz="1050" dirty="0"/>
-          </a:p>
-        </p:txBody>
-      </p:sp>
-      <p:pic>
-        <p:nvPicPr>
-          <p:cNvPr id="1003" name="AI Operations" descr="AI Operations"/>
-          <p:cNvPicPr>
-            <a:picLocks noChangeAspect="1"/>
-          </p:cNvPicPr>
-          <p:nvPr/>
-        </p:nvPicPr>
-        <p:blipFill>
-          <a:blip r:embed="rId6"/>
-          <a:stretch>
-            <a:fillRect/>
-          </a:stretch>
-        </p:blipFill>
-        <p:spPr>
-          <a:xfrm>
-            <a:off x="4645152" y="1188720"/>
-            <a:ext cx="2606040" cy="1628775"/>
-          </a:xfrm>
-          <a:prstGeom prst="roundRect">
-            <a:avLst>
-              <a:gd name="adj" fmla="val 2807"/>
-            </a:avLst>
-          </a:prstGeom>
-          <a:ln w="9525">
-            <a:solidFill>
-              <a:srgbClr val="DADCE0"/>
-            </a:solidFill>
-          </a:ln>
-          <a:effectLst>
-            <a:outerShdw blurRad="76200" dist="19050" dir="5400000" algn="t" rotWithShape="0">
-              <a:srgbClr val="000000">
-                <a:alpha val="16000"/>
-              </a:srgbClr>
-            </a:outerShdw>
-          </a:effectLst>
-        </p:spPr>
-      </p:pic>
-      <p:sp>
-        <p:nvSpPr>
-          <p:cNvPr id="1004" name="AI Operations caption"/>
-          <p:cNvSpPr txBox="1"/>
-          <p:nvPr/>
-        </p:nvSpPr>
-        <p:spPr>
-          <a:xfrm>
-            <a:off x="7360920" y="1188720"/>
-            <a:ext cx="1417320" cy="1628775"/>
-          </a:xfrm>
-          <a:prstGeom prst="rect">
-            <a:avLst/>
-          </a:prstGeom>
-          <a:noFill/>
-          <a:ln>
-            <a:noFill/>
-          </a:ln>
-        </p:spPr>
-        <p:txBody>
-          <a:bodyPr wrap="square" lIns="0" tIns="0" rIns="0" bIns="0" anchor="ctr" rtlCol="0">
-            <a:noAutofit/>
-          </a:bodyPr>
-          <a:lstStyle/>
-          <a:p>
-            <a:pPr marL="0" indent="0" algn="l">
-              <a:spcBef>
-                <a:spcPts val="0"/>
-              </a:spcBef>
-              <a:spcAft>
-                <a:spcPts val="300"/>
-              </a:spcAft>
-              <a:buNone/>
-            </a:pPr>
-            <a:r>
-              <a:rPr lang="en-GB" sz="1200" b="0" dirty="0">
-                <a:solidFill>
-                  <a:srgbClr val="202124"/>
-                </a:solidFill>
-                <a:latin typeface="Google Sans Flex SemiBold"/>
-                <a:ea typeface="Google Sans Flex SemiBold"/>
-                <a:cs typeface="Google Sans Flex SemiBold"/>
-                <a:sym typeface="Google Sans Flex SemiBold"/>
-              </a:rPr>
-              <a:t>AI Operations</a:t>
-            </a:r>
-            <a:endParaRPr lang="en-GB" sz="1200" dirty="0"/>
-          </a:p>
-          <a:p>
-            <a:pPr marL="0" indent="0" algn="l">
-              <a:lnSpc>
-                <a:spcPct val="105000"/>
-              </a:lnSpc>
-              <a:spcBef>
-                <a:spcPts val="0"/>
-              </a:spcBef>
-              <a:spcAft>
-                <a:spcPts val="0"/>
-              </a:spcAft>
-              <a:buNone/>
-            </a:pPr>
-            <a:r>
-              <a:rPr lang="en-GB" sz="1050" b="0" dirty="0">
-                <a:solidFill>
-                  <a:srgbClr val="5F6368"/>
-                </a:solidFill>
-                <a:latin typeface="Google Sans Flex"/>
-                <a:ea typeface="Google Sans Flex"/>
-                <a:cs typeface="Google Sans Flex"/>
-                <a:sym typeface="Google Sans Flex"/>
-              </a:rPr>
-              <a:t>Six agents stream findings; a trip is predicted about 16 hours ahead.</a:t>
-            </a:r>
-            <a:endParaRPr lang="en-GB" sz="1050" dirty="0"/>
-          </a:p>
-        </p:txBody>
-      </p:sp>
-      <p:pic>
-        <p:nvPicPr>
-          <p:cNvPr id="1005" name="What-If Simulator" descr="What-If Simulator"/>
-          <p:cNvPicPr>
-            <a:picLocks noChangeAspect="1"/>
-          </p:cNvPicPr>
-          <p:nvPr/>
-        </p:nvPicPr>
-        <p:blipFill>
-          <a:blip r:embed="rId7"/>
-          <a:stretch>
-            <a:fillRect/>
-          </a:stretch>
-        </p:blipFill>
-        <p:spPr>
-          <a:xfrm>
-            <a:off x="365760" y="3073527"/>
-            <a:ext cx="2606040" cy="1628775"/>
-          </a:xfrm>
-          <a:prstGeom prst="roundRect">
-            <a:avLst>
-              <a:gd name="adj" fmla="val 2807"/>
-            </a:avLst>
-          </a:prstGeom>
-          <a:ln w="9525">
-            <a:solidFill>
-              <a:srgbClr val="DADCE0"/>
-            </a:solidFill>
-          </a:ln>
-          <a:effectLst>
-            <a:outerShdw blurRad="76200" dist="19050" dir="5400000" algn="t" rotWithShape="0">
-              <a:srgbClr val="000000">
-                <a:alpha val="16000"/>
-              </a:srgbClr>
-            </a:outerShdw>
-          </a:effectLst>
-        </p:spPr>
-      </p:pic>
-      <p:sp>
-        <p:nvSpPr>
-          <p:cNvPr id="1006" name="What-If Simulator caption"/>
-          <p:cNvSpPr txBox="1"/>
-          <p:nvPr/>
-        </p:nvSpPr>
-        <p:spPr>
-          <a:xfrm>
-            <a:off x="3081528" y="3073527"/>
-            <a:ext cx="1417320" cy="1628775"/>
-          </a:xfrm>
-          <a:prstGeom prst="rect">
-            <a:avLst/>
-          </a:prstGeom>
-          <a:noFill/>
-          <a:ln>
-            <a:noFill/>
-          </a:ln>
-        </p:spPr>
-        <p:txBody>
-          <a:bodyPr wrap="square" lIns="0" tIns="0" rIns="0" bIns="0" anchor="ctr" rtlCol="0">
-            <a:noAutofit/>
-          </a:bodyPr>
-          <a:lstStyle/>
-          <a:p>
-            <a:pPr marL="0" indent="0" algn="l">
-              <a:spcBef>
-                <a:spcPts val="0"/>
-              </a:spcBef>
-              <a:spcAft>
-                <a:spcPts val="300"/>
-              </a:spcAft>
-              <a:buNone/>
-            </a:pPr>
-            <a:r>
-              <a:rPr lang="en-GB" sz="1200" b="0" dirty="0">
-                <a:solidFill>
-                  <a:srgbClr val="202124"/>
-                </a:solidFill>
-                <a:latin typeface="Google Sans Flex SemiBold"/>
-                <a:ea typeface="Google Sans Flex SemiBold"/>
-                <a:cs typeface="Google Sans Flex SemiBold"/>
-                <a:sym typeface="Google Sans Flex SemiBold"/>
-              </a:rPr>
-              <a:t>What-If Simulator</a:t>
-            </a:r>
-            <a:endParaRPr lang="en-GB" sz="1200" dirty="0"/>
-          </a:p>
-          <a:p>
-            <a:pPr marL="0" indent="0" algn="l">
-              <a:lnSpc>
-                <a:spcPct val="105000"/>
-              </a:lnSpc>
-              <a:spcBef>
-                <a:spcPts val="0"/>
-              </a:spcBef>
-              <a:spcAft>
-                <a:spcPts val="0"/>
-              </a:spcAft>
-              <a:buNone/>
-            </a:pPr>
-            <a:r>
-              <a:rPr lang="en-GB" sz="1050" b="0" dirty="0">
-                <a:solidFill>
-                  <a:srgbClr val="5F6368"/>
-                </a:solidFill>
-                <a:latin typeface="Google Sans Flex"/>
-                <a:ea typeface="Google Sans Flex"/>
-                <a:cs typeface="Google Sans Flex"/>
-                <a:sym typeface="Google Sans Flex"/>
-              </a:rPr>
-              <a:t>Four plans compared; reroute to Line B + maintain scores 82.2 with no late units.</a:t>
-            </a:r>
-            <a:endParaRPr lang="en-GB" sz="1050" dirty="0"/>
-          </a:p>
-        </p:txBody>
-      </p:sp>
-      <p:pic>
-        <p:nvPicPr>
-          <p:cNvPr id="1007" name="Digital Twin in 3D" descr="Digital Twin in 3D"/>
-          <p:cNvPicPr>
-            <a:picLocks noChangeAspect="1"/>
-          </p:cNvPicPr>
-          <p:nvPr/>
-        </p:nvPicPr>
-        <p:blipFill>
-          <a:blip r:embed="rId8"/>
-          <a:stretch>
-            <a:fillRect/>
-          </a:stretch>
-        </p:blipFill>
-        <p:spPr>
-          <a:xfrm>
-            <a:off x="4645152" y="3073527"/>
-            <a:ext cx="2606040" cy="1628775"/>
-          </a:xfrm>
-          <a:prstGeom prst="roundRect">
-            <a:avLst>
-              <a:gd name="adj" fmla="val 2807"/>
-            </a:avLst>
-          </a:prstGeom>
-          <a:ln w="9525">
-            <a:solidFill>
-              <a:srgbClr val="DADCE0"/>
-            </a:solidFill>
-          </a:ln>
-          <a:effectLst>
-            <a:outerShdw blurRad="76200" dist="19050" dir="5400000" algn="t" rotWithShape="0">
-              <a:srgbClr val="000000">
-                <a:alpha val="16000"/>
-              </a:srgbClr>
-            </a:outerShdw>
-          </a:effectLst>
-        </p:spPr>
-      </p:pic>
-      <p:sp>
-        <p:nvSpPr>
-          <p:cNvPr id="1008" name="Digital Twin in 3D caption"/>
-          <p:cNvSpPr txBox="1"/>
-          <p:nvPr/>
-        </p:nvSpPr>
-        <p:spPr>
-          <a:xfrm>
-            <a:off x="7360920" y="3073527"/>
-            <a:ext cx="1417320" cy="1628775"/>
-          </a:xfrm>
-          <a:prstGeom prst="rect">
-            <a:avLst/>
-          </a:prstGeom>
-          <a:noFill/>
-          <a:ln>
-            <a:noFill/>
-          </a:ln>
-        </p:spPr>
-        <p:txBody>
-          <a:bodyPr wrap="square" lIns="0" tIns="0" rIns="0" bIns="0" anchor="ctr" rtlCol="0">
-            <a:noAutofit/>
-          </a:bodyPr>
-          <a:lstStyle/>
-          <a:p>
-            <a:pPr marL="0" indent="0" algn="l">
-              <a:spcBef>
-                <a:spcPts val="0"/>
-              </a:spcBef>
-              <a:spcAft>
-                <a:spcPts val="300"/>
-              </a:spcAft>
-              <a:buNone/>
-            </a:pPr>
-            <a:r>
-              <a:rPr lang="en-GB" sz="1200" b="0" dirty="0">
-                <a:solidFill>
-                  <a:srgbClr val="202124"/>
-                </a:solidFill>
-                <a:latin typeface="Google Sans Flex SemiBold"/>
-                <a:ea typeface="Google Sans Flex SemiBold"/>
-                <a:cs typeface="Google Sans Flex SemiBold"/>
-                <a:sym typeface="Google Sans Flex SemiBold"/>
-              </a:rPr>
-              <a:t>Digital Twin in 3D</a:t>
-            </a:r>
-            <a:endParaRPr lang="en-GB" sz="1200" dirty="0"/>
-          </a:p>
-          <a:p>
-            <a:pPr marL="0" indent="0" algn="l">
-              <a:lnSpc>
-                <a:spcPct val="105000"/>
-              </a:lnSpc>
-              <a:spcBef>
-                <a:spcPts val="0"/>
-              </a:spcBef>
-              <a:spcAft>
-                <a:spcPts val="0"/>
-              </a:spcAft>
-              <a:buNone/>
-            </a:pPr>
-            <a:r>
-              <a:rPr lang="en-GB" sz="1050" b="0" dirty="0">
-                <a:solidFill>
-                  <a:srgbClr val="5F6368"/>
-                </a:solidFill>
-                <a:latin typeface="Google Sans Flex"/>
-                <a:ea typeface="Google Sans Flex"/>
-                <a:cs typeface="Google Sans Flex"/>
-                <a:sym typeface="Google Sans Flex"/>
-              </a:rPr>
-              <a:t>Orbit the live plant; robots animate and the recommended path is highlighted.</a:t>
-            </a:r>
-            <a:endParaRPr lang="en-GB" sz="1050" dirty="0"/>
           </a:p>
         </p:txBody>
       </p:sp>

</xml_diff>

<commit_message>
docs: replace architecture diagram on Slide 6 with updated system diagram containing 4 intelligent features and Cloud SQL
</commit_message>
<xml_diff>
--- a/docs/TwinForge_AI_Builder_Cup.pptx
+++ b/docs/TwinForge_AI_Builder_Cup.pptx
@@ -17002,30 +17002,6 @@
           </a:p>
         </p:txBody>
       </p:sp>
-      <p:pic>
-        <p:nvPicPr>
-          <p:cNvPr id="1001" name="Architecture diagram" descr="TwinForge AI on Google Cloud: system context"/>
-          <p:cNvPicPr>
-            <a:picLocks noChangeAspect="1"/>
-          </p:cNvPicPr>
-          <p:nvPr/>
-        </p:nvPicPr>
-        <p:blipFill>
-          <a:blip r:embed="rId5"/>
-          <a:stretch>
-            <a:fillRect/>
-          </a:stretch>
-        </p:blipFill>
-        <p:spPr>
-          <a:xfrm>
-            <a:off x="365760" y="1115568"/>
-            <a:ext cx="5898774" cy="3703320"/>
-          </a:xfrm>
-          <a:prstGeom prst="rect">
-            <a:avLst/>
-          </a:prstGeom>
-        </p:spPr>
-      </p:pic>
       <p:sp>
         <p:nvSpPr>
           <p:cNvPr id="1002" name="Architecture notes"/>
@@ -17034,8 +17010,8 @@
         </p:nvSpPr>
         <p:spPr>
           <a:xfrm>
-            <a:off x="6465702" y="1115568"/>
-            <a:ext cx="2312538" cy="3703320"/>
+            <a:off x="5720000" y="1115568"/>
+            <a:ext cx="3058240" cy="3703320"/>
           </a:xfrm>
           <a:prstGeom prst="rect">
             <a:avLst/>
@@ -17307,6 +17283,30 @@
           </a:p>
         </p:txBody>
       </p:sp>
+      <p:pic>
+        <p:nvPicPr>
+          <p:cNvPr id="1003" name="Architecture diagram" descr="proposed_solution_architecture.png"/>
+          <p:cNvPicPr>
+            <a:picLocks noChangeAspect="1"/>
+          </p:cNvPicPr>
+          <p:nvPr/>
+        </p:nvPicPr>
+        <p:blipFill>
+          <a:blip r:embed="rId6"/>
+          <a:stretch>
+            <a:fillRect/>
+          </a:stretch>
+        </p:blipFill>
+        <p:spPr>
+          <a:xfrm>
+            <a:off x="365760" y="1115568"/>
+            <a:ext cx="5113625" cy="3703320"/>
+          </a:xfrm>
+          <a:prstGeom prst="rect">
+            <a:avLst/>
+          </a:prstGeom>
+        </p:spPr>
+      </p:pic>
     </p:spTree>
   </p:cSld>
   <p:clrMapOvr>

</xml_diff>

<commit_message>
docs: update Slide 13 with comprehensive current scope and streamlined roadmap
</commit_message>
<xml_diff>
--- a/docs/TwinForge_AI_Builder_Cup.pptx
+++ b/docs/TwinForge_AI_Builder_Cup.pptx
@@ -10971,7 +10971,7 @@
         <p:spPr>
           <a:xfrm>
             <a:off x="365760" y="1143000"/>
-            <a:ext cx="3063240" cy="3383280"/>
+            <a:ext cx="4300000" cy="3700000"/>
           </a:xfrm>
           <a:prstGeom prst="roundRect">
             <a:avLst>
@@ -11003,7 +11003,7 @@
         </p:nvSpPr>
         <p:spPr>
           <a:xfrm>
-            <a:off x="548640" y="1325880"/>
+            <a:off x="500000" y="1260000"/>
             <a:ext cx="384048" cy="384048"/>
           </a:xfrm>
           <a:prstGeom prst="ellipse">
@@ -11042,7 +11042,7 @@
         </p:blipFill>
         <p:spPr>
           <a:xfrm>
-            <a:off x="633131" y="1410371"/>
+            <a:off x="584491" y="1344491"/>
             <a:ext cx="215067" cy="215067"/>
           </a:xfrm>
           <a:prstGeom prst="rect">
@@ -11058,8 +11058,8 @@
         </p:nvSpPr>
         <p:spPr>
           <a:xfrm>
-            <a:off x="1024128" y="1325880"/>
-            <a:ext cx="2286000" cy="384048"/>
+            <a:off x="960000" y="1260000"/>
+            <a:ext cx="3500000" cy="384048"/>
           </a:xfrm>
           <a:prstGeom prst="rect">
             <a:avLst/>
@@ -11108,8 +11108,8 @@
         </p:nvSpPr>
         <p:spPr>
           <a:xfrm>
-            <a:off x="548640" y="1892808"/>
-            <a:ext cx="2724912" cy="2788920"/>
+            <a:off x="720000" y="1750000"/>
+            <a:ext cx="3800000" cy="3000000"/>
           </a:xfrm>
           <a:prstGeom prst="rect">
             <a:avLst/>
@@ -11133,7 +11133,7 @@
                 <a:spcPts val="0"/>
               </a:spcBef>
               <a:spcAft>
-                <a:spcPts val="800"/>
+                <a:spcPts val="350"/>
               </a:spcAft>
               <a:buClr>
                 <a:srgbClr val="5F6368"/>
@@ -11143,14 +11143,11 @@
               <a:buChar char="•"/>
             </a:pPr>
             <a:r>
-              <a:rPr lang="en-GB" sz="1100" b="0" dirty="0">
+              <a:rPr sz="850">
                 <a:solidFill>
                   <a:srgbClr val="3C4043"/>
                 </a:solidFill>
                 <a:latin typeface="Google Sans Flex"/>
-                <a:ea typeface="Google Sans Flex"/>
-                <a:cs typeface="Google Sans Flex"/>
-                <a:sym typeface="Google Sans Flex"/>
               </a:rPr>
               <a:t>Runs on a modelled plant with sample data, so results are estimates.</a:t>
             </a:r>
@@ -11165,7 +11162,7 @@
                 <a:spcPts val="0"/>
               </a:spcBef>
               <a:spcAft>
-                <a:spcPts val="800"/>
+                <a:spcPts val="350"/>
               </a:spcAft>
               <a:buClr>
                 <a:srgbClr val="5F6368"/>
@@ -11175,18 +11172,14 @@
               <a:buChar char="•"/>
             </a:pPr>
             <a:r>
-              <a:rPr lang="en-GB" sz="1100" b="0" dirty="0">
+              <a:rPr sz="850">
                 <a:solidFill>
                   <a:srgbClr val="3C4043"/>
                 </a:solidFill>
                 <a:latin typeface="Google Sans Flex"/>
-                <a:ea typeface="Google Sans Flex"/>
-                <a:cs typeface="Google Sans Flex"/>
-                <a:sym typeface="Google Sans Flex"/>
               </a:rPr>
               <a:t>One factory per deployment; state is held per instance.</a:t>
             </a:r>
-            <a:endParaRPr lang="en-GB" sz="1100" dirty="0"/>
           </a:p>
           <a:p>
             <a:pPr marL="155448" indent="-155448" algn="l">
@@ -11197,7 +11190,7 @@
                 <a:spcPts val="0"/>
               </a:spcBef>
               <a:spcAft>
-                <a:spcPts val="800"/>
+                <a:spcPts val="350"/>
               </a:spcAft>
               <a:buClr>
                 <a:srgbClr val="5F6368"/>
@@ -11207,18 +11200,14 @@
               <a:buChar char="•"/>
             </a:pPr>
             <a:r>
-              <a:rPr lang="en-GB" sz="1100" b="0" dirty="0">
+              <a:rPr sz="850">
                 <a:solidFill>
                   <a:srgbClr val="3C4043"/>
                 </a:solidFill>
                 <a:latin typeface="Google Sans Flex"/>
-                <a:ea typeface="Google Sans Flex"/>
-                <a:cs typeface="Google Sans Flex"/>
-                <a:sym typeface="Google Sans Flex"/>
               </a:rPr>
-              <a:t>Live telemetry arrives through Pub/Sub today; OPC UA, Modbus and MQTT need an edge gateway.</a:t>
+              <a:t>Live telemetry arrives through Pub/Sub today; OPC UA, Modbus, and MQTT require an edge gateway.</a:t>
             </a:r>
-            <a:endParaRPr lang="en-GB" sz="1100" dirty="0"/>
           </a:p>
           <a:p>
             <a:pPr marL="155448" indent="-155448" algn="l">
@@ -11229,7 +11218,7 @@
                 <a:spcPts val="0"/>
               </a:spcBef>
               <a:spcAft>
-                <a:spcPts val="800"/>
+                <a:spcPts val="350"/>
               </a:spcAft>
               <a:buClr>
                 <a:srgbClr val="5F6368"/>
@@ -11239,18 +11228,162 @@
               <a:buChar char="•"/>
             </a:pPr>
             <a:r>
-              <a:rPr lang="en-GB" sz="1100" b="0" dirty="0">
+              <a:rPr sz="850">
                 <a:solidFill>
                   <a:srgbClr val="3C4043"/>
                 </a:solidFill>
                 <a:latin typeface="Google Sans Flex"/>
-                <a:ea typeface="Google Sans Flex"/>
-                <a:cs typeface="Google Sans Flex"/>
-                <a:sym typeface="Google Sans Flex"/>
               </a:rPr>
-              <a:t>Camera footage in the demo is licensed video of other facilities.</a:t>
+              <a:t>Camera footage in the demo is licensed video from other facilities.</a:t>
             </a:r>
-            <a:endParaRPr lang="en-GB" sz="1100" dirty="0"/>
+          </a:p>
+          <a:p>
+            <a:pPr marL="155448" indent="-155448" algn="l">
+              <a:lnSpc>
+                <a:spcPct val="105000"/>
+              </a:lnSpc>
+              <a:spcBef>
+                <a:spcPts val="0"/>
+              </a:spcBef>
+              <a:spcAft>
+                <a:spcPts val="350"/>
+              </a:spcAft>
+              <a:buClr>
+                <a:srgbClr val="5F6368"/>
+              </a:buClr>
+              <a:buSzPct val="100000"/>
+              <a:buFont typeface="Arial"/>
+              <a:buChar char="•"/>
+            </a:pPr>
+            <a:r>
+              <a:rPr sz="850" b="1">
+                <a:solidFill>
+                  <a:srgbClr val="202124"/>
+                </a:solidFill>
+                <a:latin typeface="Google Sans Flex"/>
+              </a:rPr>
+              <a:t>Predictive Maintenance: </a:t>
+            </a:r>
+            <a:r>
+              <a:rPr sz="850" b="0">
+                <a:solidFill>
+                  <a:srgbClr val="5F6368"/>
+                </a:solidFill>
+                <a:latin typeface="Google Sans Flex"/>
+              </a:rPr>
+              <a:t>Demonstrates equipment health monitoring and failure-risk predictions using available sample data.</a:t>
+            </a:r>
+          </a:p>
+          <a:p>
+            <a:pPr marL="155448" indent="-155448" algn="l">
+              <a:lnSpc>
+                <a:spcPct val="105000"/>
+              </a:lnSpc>
+              <a:spcBef>
+                <a:spcPts val="0"/>
+              </a:spcBef>
+              <a:spcAft>
+                <a:spcPts val="350"/>
+              </a:spcAft>
+              <a:buClr>
+                <a:srgbClr val="5F6368"/>
+              </a:buClr>
+              <a:buSzPct val="100000"/>
+              <a:buFont typeface="Arial"/>
+              <a:buChar char="•"/>
+            </a:pPr>
+            <a:r>
+              <a:rPr sz="850" b="1">
+                <a:solidFill>
+                  <a:srgbClr val="202124"/>
+                </a:solidFill>
+                <a:latin typeface="Google Sans Flex"/>
+              </a:rPr>
+              <a:t>Supply Chain Intelligence: </a:t>
+            </a:r>
+            <a:r>
+              <a:rPr sz="850" b="0">
+                <a:solidFill>
+                  <a:srgbClr val="5F6368"/>
+                </a:solidFill>
+                <a:latin typeface="Google Sans Flex"/>
+              </a:rPr>
+              <a:t>Demonstrates supply chain visibility, disruption analysis, and recommendations using modelled data.</a:t>
+            </a:r>
+          </a:p>
+          <a:p>
+            <a:pPr marL="155448" indent="-155448" algn="l">
+              <a:lnSpc>
+                <a:spcPct val="105000"/>
+              </a:lnSpc>
+              <a:spcBef>
+                <a:spcPts val="0"/>
+              </a:spcBef>
+              <a:spcAft>
+                <a:spcPts val="350"/>
+              </a:spcAft>
+              <a:buClr>
+                <a:srgbClr val="5F6368"/>
+              </a:buClr>
+              <a:buSzPct val="100000"/>
+              <a:buFont typeface="Arial"/>
+              <a:buChar char="•"/>
+            </a:pPr>
+            <a:r>
+              <a:rPr sz="850" b="1">
+                <a:solidFill>
+                  <a:srgbClr val="202124"/>
+                </a:solidFill>
+                <a:latin typeface="Google Sans Flex"/>
+              </a:rPr>
+              <a:t>Demand Forecasting: </a:t>
+            </a:r>
+            <a:r>
+              <a:rPr sz="850" b="0">
+                <a:solidFill>
+                  <a:srgbClr val="5F6368"/>
+                </a:solidFill>
+                <a:latin typeface="Google Sans Flex"/>
+              </a:rPr>
+              <a:t>Generates demand forecasts and production planning recommendations based on sample data.</a:t>
+            </a:r>
+          </a:p>
+          <a:p>
+            <a:pPr marL="155448" indent="-155448" algn="l">
+              <a:lnSpc>
+                <a:spcPct val="105000"/>
+              </a:lnSpc>
+              <a:spcBef>
+                <a:spcPts val="0"/>
+              </a:spcBef>
+              <a:spcAft>
+                <a:spcPts val="350"/>
+              </a:spcAft>
+              <a:buClr>
+                <a:srgbClr val="5F6368"/>
+              </a:buClr>
+              <a:buSzPct val="100000"/>
+              <a:buFont typeface="Arial"/>
+              <a:buChar char="•"/>
+            </a:pPr>
+            <a:r>
+              <a:rPr sz="850" b="1">
+                <a:solidFill>
+                  <a:srgbClr val="202124"/>
+                </a:solidFill>
+                <a:latin typeface="Google Sans Flex"/>
+              </a:rPr>
+              <a:t>Visual Quality Inspection: </a:t>
+            </a:r>
+            <a:r>
+              <a:rPr sz="850" b="0">
+                <a:solidFill>
+                  <a:srgbClr val="5F6368"/>
+                </a:solidFill>
+                <a:latin typeface="Google Sans Flex"/>
+              </a:rPr>
+              <a:t>Demonstrates AI-assisted defect detection and quality metrics; inspection results require validation against real production images before operational use.</a:t>
+            </a:r>
           </a:p>
         </p:txBody>
       </p:sp>
@@ -11262,8 +11395,8 @@
         </p:nvSpPr>
         <p:spPr>
           <a:xfrm>
-            <a:off x="3657600" y="1143000"/>
-            <a:ext cx="5120640" cy="384048"/>
+            <a:off x="4950000" y="1143000"/>
+            <a:ext cx="3800000" cy="384048"/>
           </a:xfrm>
           <a:prstGeom prst="rect">
             <a:avLst/>
@@ -11312,7 +11445,7 @@
         </p:nvSpPr>
         <p:spPr>
           <a:xfrm>
-            <a:off x="3657600" y="1645920"/>
+            <a:off x="4950000" y="1700000"/>
             <a:ext cx="347472" cy="347472"/>
           </a:xfrm>
           <a:prstGeom prst="ellipse">
@@ -11351,7 +11484,7 @@
         </p:blipFill>
         <p:spPr>
           <a:xfrm>
-            <a:off x="3734044" y="1722364"/>
+            <a:off x="5026444" y="1776444"/>
             <a:ext cx="194584" cy="194584"/>
           </a:xfrm>
           <a:prstGeom prst="rect">
@@ -11367,8 +11500,8 @@
         </p:nvSpPr>
         <p:spPr>
           <a:xfrm>
-            <a:off x="4114800" y="1627632"/>
-            <a:ext cx="2057400" cy="1005840"/>
+            <a:off x="5420000" y="1681712"/>
+            <a:ext cx="3350000" cy="800000"/>
           </a:xfrm>
           <a:prstGeom prst="rect">
             <a:avLst/>
@@ -11394,7 +11527,7 @@
               <a:buNone/>
             </a:pPr>
             <a:r>
-              <a:rPr lang="en-GB" sz="1150" b="0" dirty="0">
+              <a:rPr lang="en-GB" sz="950" b="0" dirty="0">
                 <a:solidFill>
                   <a:srgbClr val="202124"/>
                 </a:solidFill>
@@ -11421,7 +11554,7 @@
               <a:buNone/>
             </a:pPr>
             <a:r>
-              <a:rPr lang="en-GB" sz="1050" b="0" dirty="0">
+              <a:rPr lang="en-GB" sz="950" b="0" dirty="0">
                 <a:solidFill>
                   <a:srgbClr val="5F6368"/>
                 </a:solidFill>
@@ -11444,7 +11577,7 @@
         </p:nvSpPr>
         <p:spPr>
           <a:xfrm>
-            <a:off x="6263640" y="1645920"/>
+            <a:off x="4950000" y="2750000"/>
             <a:ext cx="347472" cy="347472"/>
           </a:xfrm>
           <a:prstGeom prst="ellipse">
@@ -11483,7 +11616,7 @@
         </p:blipFill>
         <p:spPr>
           <a:xfrm>
-            <a:off x="6340084" y="1722364"/>
+            <a:off x="5026444" y="2826444"/>
             <a:ext cx="194584" cy="194584"/>
           </a:xfrm>
           <a:prstGeom prst="rect">
@@ -11499,8 +11632,8 @@
         </p:nvSpPr>
         <p:spPr>
           <a:xfrm>
-            <a:off x="6720840" y="1627632"/>
-            <a:ext cx="2057400" cy="1005840"/>
+            <a:off x="5420000" y="2731712"/>
+            <a:ext cx="3350000" cy="800000"/>
           </a:xfrm>
           <a:prstGeom prst="rect">
             <a:avLst/>
@@ -11526,7 +11659,7 @@
               <a:buNone/>
             </a:pPr>
             <a:r>
-              <a:rPr lang="en-GB" sz="1150" b="0" dirty="0">
+              <a:rPr lang="en-GB" sz="950" b="0" dirty="0">
                 <a:solidFill>
                   <a:srgbClr val="202124"/>
                 </a:solidFill>
@@ -11553,7 +11686,7 @@
               <a:buNone/>
             </a:pPr>
             <a:r>
-              <a:rPr lang="en-GB" sz="1050" b="0" dirty="0">
+              <a:rPr lang="en-GB" sz="950" b="0" dirty="0">
                 <a:solidFill>
                   <a:srgbClr val="5F6368"/>
                 </a:solidFill>
@@ -11570,277 +11703,13 @@
       </p:sp>
       <p:sp>
         <p:nvSpPr>
-          <p:cNvPr id="1013" name="Server-side clock circle"/>
-          <p:cNvSpPr/>
-          <p:nvPr/>
-        </p:nvSpPr>
-        <p:spPr>
-          <a:xfrm>
-            <a:off x="3657600" y="2706624"/>
-            <a:ext cx="347472" cy="347472"/>
-          </a:xfrm>
-          <a:prstGeom prst="ellipse">
-            <a:avLst/>
-          </a:prstGeom>
-          <a:solidFill>
-            <a:srgbClr val="1A73E8"/>
-          </a:solidFill>
-          <a:ln>
-            <a:noFill/>
-          </a:ln>
-        </p:spPr>
-        <p:txBody>
-          <a:bodyPr wrap="square" lIns="73152" tIns="73152" rIns="73152" bIns="73152" anchor="ctr" rtlCol="0">
-            <a:noAutofit/>
-          </a:bodyPr>
-          <a:lstStyle/>
-          <a:p>
-            <a:endParaRPr lang="en-GB"/>
-          </a:p>
-        </p:txBody>
-      </p:sp>
-      <p:pic>
-        <p:nvPicPr>
-          <p:cNvPr id="1014" name="Server-side clock" descr=""/>
-          <p:cNvPicPr>
-            <a:picLocks noChangeAspect="1"/>
-          </p:cNvPicPr>
-          <p:nvPr/>
-        </p:nvPicPr>
-        <p:blipFill>
-          <a:blip r:embed="rId8"/>
-          <a:stretch>
-            <a:fillRect/>
-          </a:stretch>
-        </p:blipFill>
-        <p:spPr>
-          <a:xfrm>
-            <a:off x="3734044" y="2783068"/>
-            <a:ext cx="194584" cy="194584"/>
-          </a:xfrm>
-          <a:prstGeom prst="rect">
-            <a:avLst/>
-          </a:prstGeom>
-        </p:spPr>
-      </p:pic>
-      <p:sp>
-        <p:nvSpPr>
-          <p:cNvPr id="1015" name="Server-side clock text"/>
-          <p:cNvSpPr txBox="1"/>
-          <p:nvPr/>
-        </p:nvSpPr>
-        <p:spPr>
-          <a:xfrm>
-            <a:off x="4114800" y="2688336"/>
-            <a:ext cx="2057400" cy="1005840"/>
-          </a:xfrm>
-          <a:prstGeom prst="rect">
-            <a:avLst/>
-          </a:prstGeom>
-          <a:noFill/>
-          <a:ln>
-            <a:noFill/>
-          </a:ln>
-        </p:spPr>
-        <p:txBody>
-          <a:bodyPr wrap="square" lIns="0" tIns="0" rIns="0" bIns="0" anchor="t" rtlCol="0">
-            <a:noAutofit/>
-          </a:bodyPr>
-          <a:lstStyle/>
-          <a:p>
-            <a:pPr marL="0" indent="0" algn="l">
-              <a:spcBef>
-                <a:spcPts val="0"/>
-              </a:spcBef>
-              <a:spcAft>
-                <a:spcPts val="200"/>
-              </a:spcAft>
-              <a:buNone/>
-            </a:pPr>
-            <a:r>
-              <a:rPr lang="en-GB" sz="1150" b="0" dirty="0">
-                <a:solidFill>
-                  <a:srgbClr val="202124"/>
-                </a:solidFill>
-                <a:latin typeface="Google Sans Flex SemiBold"/>
-                <a:ea typeface="Google Sans Flex SemiBold"/>
-                <a:cs typeface="Google Sans Flex SemiBold"/>
-                <a:sym typeface="Google Sans Flex SemiBold"/>
-              </a:rPr>
-              <a:t>Server-side clock</a:t>
-            </a:r>
-            <a:endParaRPr lang="en-GB" sz="1150" dirty="0"/>
-          </a:p>
-          <a:p>
-            <a:pPr marL="0" indent="0" algn="l">
-              <a:lnSpc>
-                <a:spcPct val="105000"/>
-              </a:lnSpc>
-              <a:spcBef>
-                <a:spcPts val="0"/>
-              </a:spcBef>
-              <a:spcAft>
-                <a:spcPts val="0"/>
-              </a:spcAft>
-              <a:buNone/>
-            </a:pPr>
-            <a:r>
-              <a:rPr lang="en-GB" sz="1050" b="0" dirty="0">
-                <a:solidFill>
-                  <a:srgbClr val="5F6368"/>
-                </a:solidFill>
-                <a:latin typeface="Google Sans Flex"/>
-                <a:ea typeface="Google Sans Flex"/>
-                <a:cs typeface="Google Sans Flex"/>
-                <a:sym typeface="Google Sans Flex"/>
-              </a:rPr>
-              <a:t>Cloud Scheduler drives the plant clock, with no instance cap.</a:t>
-            </a:r>
-            <a:endParaRPr lang="en-GB" sz="1050" dirty="0"/>
-          </a:p>
-        </p:txBody>
-      </p:sp>
-      <p:sp>
-        <p:nvSpPr>
-          <p:cNvPr id="1016" name="Smarter Twin Builder circle"/>
-          <p:cNvSpPr/>
-          <p:nvPr/>
-        </p:nvSpPr>
-        <p:spPr>
-          <a:xfrm>
-            <a:off x="6263640" y="2706624"/>
-            <a:ext cx="347472" cy="347472"/>
-          </a:xfrm>
-          <a:prstGeom prst="ellipse">
-            <a:avLst/>
-          </a:prstGeom>
-          <a:solidFill>
-            <a:srgbClr val="1A73E8"/>
-          </a:solidFill>
-          <a:ln>
-            <a:noFill/>
-          </a:ln>
-        </p:spPr>
-        <p:txBody>
-          <a:bodyPr wrap="square" lIns="73152" tIns="73152" rIns="73152" bIns="73152" anchor="ctr" rtlCol="0">
-            <a:noAutofit/>
-          </a:bodyPr>
-          <a:lstStyle/>
-          <a:p>
-            <a:endParaRPr lang="en-GB"/>
-          </a:p>
-        </p:txBody>
-      </p:sp>
-      <p:pic>
-        <p:nvPicPr>
-          <p:cNvPr id="1017" name="Smarter Twin Builder" descr=""/>
-          <p:cNvPicPr>
-            <a:picLocks noChangeAspect="1"/>
-          </p:cNvPicPr>
-          <p:nvPr/>
-        </p:nvPicPr>
-        <p:blipFill>
-          <a:blip r:embed="rId9"/>
-          <a:stretch>
-            <a:fillRect/>
-          </a:stretch>
-        </p:blipFill>
-        <p:spPr>
-          <a:xfrm>
-            <a:off x="6340084" y="2783068"/>
-            <a:ext cx="194584" cy="194584"/>
-          </a:xfrm>
-          <a:prstGeom prst="rect">
-            <a:avLst/>
-          </a:prstGeom>
-        </p:spPr>
-      </p:pic>
-      <p:sp>
-        <p:nvSpPr>
-          <p:cNvPr id="1018" name="Smarter Twin Builder text"/>
-          <p:cNvSpPr txBox="1"/>
-          <p:nvPr/>
-        </p:nvSpPr>
-        <p:spPr>
-          <a:xfrm>
-            <a:off x="6720840" y="2688336"/>
-            <a:ext cx="2057400" cy="1005840"/>
-          </a:xfrm>
-          <a:prstGeom prst="rect">
-            <a:avLst/>
-          </a:prstGeom>
-          <a:noFill/>
-          <a:ln>
-            <a:noFill/>
-          </a:ln>
-        </p:spPr>
-        <p:txBody>
-          <a:bodyPr wrap="square" lIns="0" tIns="0" rIns="0" bIns="0" anchor="t" rtlCol="0">
-            <a:noAutofit/>
-          </a:bodyPr>
-          <a:lstStyle/>
-          <a:p>
-            <a:pPr marL="0" indent="0" algn="l">
-              <a:spcBef>
-                <a:spcPts val="0"/>
-              </a:spcBef>
-              <a:spcAft>
-                <a:spcPts val="200"/>
-              </a:spcAft>
-              <a:buNone/>
-            </a:pPr>
-            <a:r>
-              <a:rPr lang="en-GB" sz="1150" b="0" dirty="0">
-                <a:solidFill>
-                  <a:srgbClr val="202124"/>
-                </a:solidFill>
-                <a:latin typeface="Google Sans Flex SemiBold"/>
-                <a:ea typeface="Google Sans Flex SemiBold"/>
-                <a:cs typeface="Google Sans Flex SemiBold"/>
-                <a:sym typeface="Google Sans Flex SemiBold"/>
-              </a:rPr>
-              <a:t>Smarter Twin Builder</a:t>
-            </a:r>
-            <a:endParaRPr lang="en-GB" sz="1150" dirty="0"/>
-          </a:p>
-          <a:p>
-            <a:pPr marL="0" indent="0" algn="l">
-              <a:lnSpc>
-                <a:spcPct val="105000"/>
-              </a:lnSpc>
-              <a:spcBef>
-                <a:spcPts val="0"/>
-              </a:spcBef>
-              <a:spcAft>
-                <a:spcPts val="0"/>
-              </a:spcAft>
-              <a:buNone/>
-            </a:pPr>
-            <a:r>
-              <a:rPr lang="en-GB" sz="1050" b="0" dirty="0">
-                <a:solidFill>
-                  <a:srgbClr val="5F6368"/>
-                </a:solidFill>
-                <a:latin typeface="Google Sans Flex"/>
-                <a:ea typeface="Google Sans Flex"/>
-                <a:cs typeface="Google Sans Flex"/>
-                <a:sym typeface="Google Sans Flex"/>
-              </a:rPr>
-              <a:t>A self-correction loop on ADK; Agent Engine hosting for the Python agent.</a:t>
-            </a:r>
-            <a:endParaRPr lang="en-GB" sz="1050" dirty="0"/>
-          </a:p>
-        </p:txBody>
-      </p:sp>
-      <p:sp>
-        <p:nvSpPr>
           <p:cNvPr id="1019" name="Learned inspection circle"/>
           <p:cNvSpPr/>
           <p:nvPr/>
         </p:nvSpPr>
         <p:spPr>
           <a:xfrm>
-            <a:off x="3657600" y="3767328"/>
+            <a:off x="4950000" y="3800000"/>
             <a:ext cx="347472" cy="347472"/>
           </a:xfrm>
           <a:prstGeom prst="ellipse">
@@ -11879,7 +11748,7 @@
         </p:blipFill>
         <p:spPr>
           <a:xfrm>
-            <a:off x="3734044" y="3843772"/>
+            <a:off x="5026444" y="3876444"/>
             <a:ext cx="194584" cy="194584"/>
           </a:xfrm>
           <a:prstGeom prst="rect">
@@ -11895,8 +11764,8 @@
         </p:nvSpPr>
         <p:spPr>
           <a:xfrm>
-            <a:off x="4114800" y="3749040"/>
-            <a:ext cx="2057400" cy="1005840"/>
+            <a:off x="5420000" y="3781712"/>
+            <a:ext cx="3350000" cy="800000"/>
           </a:xfrm>
           <a:prstGeom prst="rect">
             <a:avLst/>
@@ -11922,7 +11791,7 @@
               <a:buNone/>
             </a:pPr>
             <a:r>
-              <a:rPr lang="en-GB" sz="1150" b="0" dirty="0">
+              <a:rPr lang="en-GB" sz="950" b="0" dirty="0">
                 <a:solidFill>
                   <a:srgbClr val="202124"/>
                 </a:solidFill>
@@ -11949,7 +11818,7 @@
               <a:buNone/>
             </a:pPr>
             <a:r>
-              <a:rPr lang="en-GB" sz="1050" b="0" dirty="0">
+              <a:rPr lang="en-GB" sz="950" b="0" dirty="0">
                 <a:solidFill>
                   <a:srgbClr val="5F6368"/>
                 </a:solidFill>
@@ -11959,138 +11828,6 @@
                 <a:sym typeface="Google Sans Flex"/>
               </a:rPr>
               <a:t>Trained inspection models, validated with a measurement-system study before use.</a:t>
-            </a:r>
-            <a:endParaRPr lang="en-GB" sz="1050" dirty="0"/>
-          </a:p>
-        </p:txBody>
-      </p:sp>
-      <p:sp>
-        <p:nvSpPr>
-          <p:cNvPr id="1022" name="Agent-to-agent circle"/>
-          <p:cNvSpPr/>
-          <p:nvPr/>
-        </p:nvSpPr>
-        <p:spPr>
-          <a:xfrm>
-            <a:off x="6263640" y="3767328"/>
-            <a:ext cx="347472" cy="347472"/>
-          </a:xfrm>
-          <a:prstGeom prst="ellipse">
-            <a:avLst/>
-          </a:prstGeom>
-          <a:solidFill>
-            <a:srgbClr val="1A73E8"/>
-          </a:solidFill>
-          <a:ln>
-            <a:noFill/>
-          </a:ln>
-        </p:spPr>
-        <p:txBody>
-          <a:bodyPr wrap="square" lIns="73152" tIns="73152" rIns="73152" bIns="73152" anchor="ctr" rtlCol="0">
-            <a:noAutofit/>
-          </a:bodyPr>
-          <a:lstStyle/>
-          <a:p>
-            <a:endParaRPr lang="en-GB"/>
-          </a:p>
-        </p:txBody>
-      </p:sp>
-      <p:pic>
-        <p:nvPicPr>
-          <p:cNvPr id="1023" name="Agent-to-agent" descr=""/>
-          <p:cNvPicPr>
-            <a:picLocks noChangeAspect="1"/>
-          </p:cNvPicPr>
-          <p:nvPr/>
-        </p:nvPicPr>
-        <p:blipFill>
-          <a:blip r:embed="rId11"/>
-          <a:stretch>
-            <a:fillRect/>
-          </a:stretch>
-        </p:blipFill>
-        <p:spPr>
-          <a:xfrm>
-            <a:off x="6340084" y="3843772"/>
-            <a:ext cx="194584" cy="194584"/>
-          </a:xfrm>
-          <a:prstGeom prst="rect">
-            <a:avLst/>
-          </a:prstGeom>
-        </p:spPr>
-      </p:pic>
-      <p:sp>
-        <p:nvSpPr>
-          <p:cNvPr id="1024" name="Agent-to-agent text"/>
-          <p:cNvSpPr txBox="1"/>
-          <p:nvPr/>
-        </p:nvSpPr>
-        <p:spPr>
-          <a:xfrm>
-            <a:off x="6720840" y="3749040"/>
-            <a:ext cx="2057400" cy="1005840"/>
-          </a:xfrm>
-          <a:prstGeom prst="rect">
-            <a:avLst/>
-          </a:prstGeom>
-          <a:noFill/>
-          <a:ln>
-            <a:noFill/>
-          </a:ln>
-        </p:spPr>
-        <p:txBody>
-          <a:bodyPr wrap="square" lIns="0" tIns="0" rIns="0" bIns="0" anchor="t" rtlCol="0">
-            <a:noAutofit/>
-          </a:bodyPr>
-          <a:lstStyle/>
-          <a:p>
-            <a:pPr marL="0" indent="0" algn="l">
-              <a:spcBef>
-                <a:spcPts val="0"/>
-              </a:spcBef>
-              <a:spcAft>
-                <a:spcPts val="200"/>
-              </a:spcAft>
-              <a:buNone/>
-            </a:pPr>
-            <a:r>
-              <a:rPr lang="en-GB" sz="1150" b="0" dirty="0">
-                <a:solidFill>
-                  <a:srgbClr val="202124"/>
-                </a:solidFill>
-                <a:latin typeface="Google Sans Flex SemiBold"/>
-                <a:ea typeface="Google Sans Flex SemiBold"/>
-                <a:cs typeface="Google Sans Flex SemiBold"/>
-                <a:sym typeface="Google Sans Flex SemiBold"/>
-              </a:rPr>
-              <a:t>Agent-to-agent</a:t>
-            </a:r>
-            <a:endParaRPr lang="en-GB" sz="1150" dirty="0"/>
-          </a:p>
-          <a:p>
-            <a:pPr marL="0" indent="0" algn="l">
-              <a:lnSpc>
-                <a:spcPct val="105000"/>
-              </a:lnSpc>
-              <a:spcBef>
-                <a:spcPts val="0"/>
-              </a:spcBef>
-              <a:spcAft>
-                <a:spcPts val="0"/>
-              </a:spcAft>
-              <a:buNone/>
-            </a:pPr>
-            <a:r>
-              <a:rPr lang="en-GB" sz="1050" b="0" dirty="0">
-                <a:solidFill>
-                  <a:srgbClr val="5F6368"/>
-                </a:solidFill>
-                <a:latin typeface="Google Sans Flex"/>
-                <a:ea typeface="Google Sans Flex"/>
-                <a:cs typeface="Google Sans Flex"/>
-                <a:sym typeface="Google Sans Flex"/>
-              </a:rPr>
-              <a:t>An A2A endpoint so enterprise agents can delegate work to TwinForge.</a:t>
             </a:r>
             <a:endParaRPr lang="en-GB" sz="1050" dirty="0"/>
           </a:p>

</xml_diff>

<commit_message>
docs: add A2A Enterprise and Mobile app roadmap items to Slide 13
</commit_message>
<xml_diff>
--- a/docs/TwinForge_AI_Builder_Cup.pptx
+++ b/docs/TwinForge_AI_Builder_Cup.pptx
@@ -11445,7 +11445,7 @@
         </p:nvSpPr>
         <p:spPr>
           <a:xfrm>
-            <a:off x="4950000" y="1700000"/>
+            <a:off x="4950000" y="1600000"/>
             <a:ext cx="347472" cy="347472"/>
           </a:xfrm>
           <a:prstGeom prst="ellipse">
@@ -11484,7 +11484,7 @@
         </p:blipFill>
         <p:spPr>
           <a:xfrm>
-            <a:off x="5026444" y="1776444"/>
+            <a:off x="5026444" y="1676444"/>
             <a:ext cx="194584" cy="194584"/>
           </a:xfrm>
           <a:prstGeom prst="rect">
@@ -11500,8 +11500,8 @@
         </p:nvSpPr>
         <p:spPr>
           <a:xfrm>
-            <a:off x="5420000" y="1681712"/>
-            <a:ext cx="3350000" cy="800000"/>
+            <a:off x="5420000" y="1582000"/>
+            <a:ext cx="3450000" cy="600000"/>
           </a:xfrm>
           <a:prstGeom prst="rect">
             <a:avLst/>
@@ -11577,7 +11577,7 @@
         </p:nvSpPr>
         <p:spPr>
           <a:xfrm>
-            <a:off x="4950000" y="2750000"/>
+            <a:off x="4950000" y="2250000"/>
             <a:ext cx="347472" cy="347472"/>
           </a:xfrm>
           <a:prstGeom prst="ellipse">
@@ -11616,7 +11616,7 @@
         </p:blipFill>
         <p:spPr>
           <a:xfrm>
-            <a:off x="5026444" y="2826444"/>
+            <a:off x="5026444" y="2326444"/>
             <a:ext cx="194584" cy="194584"/>
           </a:xfrm>
           <a:prstGeom prst="rect">
@@ -11632,8 +11632,8 @@
         </p:nvSpPr>
         <p:spPr>
           <a:xfrm>
-            <a:off x="5420000" y="2731712"/>
-            <a:ext cx="3350000" cy="800000"/>
+            <a:off x="5420000" y="2232000"/>
+            <a:ext cx="3450000" cy="600000"/>
           </a:xfrm>
           <a:prstGeom prst="rect">
             <a:avLst/>
@@ -11709,7 +11709,7 @@
         </p:nvSpPr>
         <p:spPr>
           <a:xfrm>
-            <a:off x="4950000" y="3800000"/>
+            <a:off x="4950000" y="2900000"/>
             <a:ext cx="347472" cy="347472"/>
           </a:xfrm>
           <a:prstGeom prst="ellipse">
@@ -11748,7 +11748,7 @@
         </p:blipFill>
         <p:spPr>
           <a:xfrm>
-            <a:off x="5026444" y="3876444"/>
+            <a:off x="5026444" y="2976444"/>
             <a:ext cx="194584" cy="194584"/>
           </a:xfrm>
           <a:prstGeom prst="rect">
@@ -11764,8 +11764,8 @@
         </p:nvSpPr>
         <p:spPr>
           <a:xfrm>
-            <a:off x="5420000" y="3781712"/>
-            <a:ext cx="3350000" cy="800000"/>
+            <a:off x="5420000" y="2882000"/>
+            <a:ext cx="3450000" cy="600000"/>
           </a:xfrm>
           <a:prstGeom prst="rect">
             <a:avLst/>
@@ -11830,6 +11830,250 @@
               <a:t>Trained inspection models, validated with a measurement-system study before use.</a:t>
             </a:r>
             <a:endParaRPr lang="en-GB" sz="1050" dirty="0"/>
+          </a:p>
+        </p:txBody>
+      </p:sp>
+      <p:sp>
+        <p:nvSpPr>
+          <p:cNvPr id="1022" name="A2A Enterprise circle"/>
+          <p:cNvSpPr/>
+          <p:nvPr/>
+        </p:nvSpPr>
+        <p:spPr>
+          <a:xfrm>
+            <a:off x="4950000" y="3550000"/>
+            <a:ext cx="347472" cy="347472"/>
+          </a:xfrm>
+          <a:prstGeom prst="ellipse">
+            <a:avLst/>
+          </a:prstGeom>
+          <a:solidFill>
+            <a:srgbClr val="1A73E8"/>
+          </a:solidFill>
+          <a:ln>
+            <a:noFill/>
+          </a:ln>
+        </p:spPr>
+        <p:style>
+          <a:lnRef idx="1">
+            <a:schemeClr val="accent1"/>
+          </a:lnRef>
+          <a:fillRef idx="3">
+            <a:schemeClr val="accent1"/>
+          </a:fillRef>
+          <a:effectRef idx="2">
+            <a:schemeClr val="accent1"/>
+          </a:effectRef>
+          <a:fontRef idx="minor">
+            <a:schemeClr val="lt1"/>
+          </a:fontRef>
+        </p:style>
+        <p:txBody>
+          <a:bodyPr rtlCol="0" anchor="ctr"/>
+          <a:lstStyle/>
+          <a:p>
+            <a:pPr algn="ctr"/>
+          </a:p>
+        </p:txBody>
+      </p:sp>
+      <p:pic>
+        <p:nvPicPr>
+          <p:cNvPr id="1023" name="A2A Enterprise pic" descr="image.png"/>
+          <p:cNvPicPr>
+            <a:picLocks noChangeAspect="1"/>
+          </p:cNvPicPr>
+          <p:nvPr/>
+        </p:nvPicPr>
+        <p:blipFill>
+          <a:blip r:embed="rId11"/>
+          <a:stretch>
+            <a:fillRect/>
+          </a:stretch>
+        </p:blipFill>
+        <p:spPr>
+          <a:xfrm>
+            <a:off x="5026444" y="3626444"/>
+            <a:ext cx="194584" cy="194584"/>
+          </a:xfrm>
+          <a:prstGeom prst="rect">
+            <a:avLst/>
+          </a:prstGeom>
+        </p:spPr>
+      </p:pic>
+      <p:sp>
+        <p:nvSpPr>
+          <p:cNvPr id="1024" name="A2A Enterprise text"/>
+          <p:cNvSpPr txBox="1"/>
+          <p:nvPr/>
+        </p:nvSpPr>
+        <p:spPr>
+          <a:xfrm>
+            <a:off x="5420000" y="3532000"/>
+            <a:ext cx="3450000" cy="600000"/>
+          </a:xfrm>
+          <a:prstGeom prst="rect">
+            <a:avLst/>
+          </a:prstGeom>
+          <a:noFill/>
+        </p:spPr>
+        <p:txBody>
+          <a:bodyPr wrap="square" lIns="0" rIns="0" tIns="0" bIns="0">
+            <a:spAutoFit/>
+          </a:bodyPr>
+          <a:lstStyle/>
+          <a:p>
+            <a:pPr>
+              <a:spcAft>
+                <a:spcPts val="200"/>
+              </a:spcAft>
+            </a:pPr>
+            <a:r>
+              <a:rPr sz="1000" b="0">
+                <a:solidFill>
+                  <a:srgbClr val="202124"/>
+                </a:solidFill>
+                <a:latin typeface="Google Sans Flex SemiBold"/>
+              </a:rPr>
+              <a:t>A2A Enterprise and Cloud Scheduler</a:t>
+            </a:r>
+          </a:p>
+          <a:p>
+            <a:pPr>
+              <a:spcAft>
+                <a:spcPts val="0"/>
+              </a:spcAft>
+            </a:pPr>
+            <a:r>
+              <a:rPr sz="900" b="0">
+                <a:solidFill>
+                  <a:srgbClr val="5F6368"/>
+                </a:solidFill>
+                <a:latin typeface="Google Sans Flex"/>
+              </a:rPr>
+              <a:t>Cloud Scheduler drives the plant clock, with no instance cap; an Agent-to-Agent (A2A) endpoint enables enterprise agents to communicate between factories.</a:t>
+            </a:r>
+          </a:p>
+        </p:txBody>
+      </p:sp>
+      <p:sp>
+        <p:nvSpPr>
+          <p:cNvPr id="1025" name="Mobile app circle"/>
+          <p:cNvSpPr/>
+          <p:nvPr/>
+        </p:nvSpPr>
+        <p:spPr>
+          <a:xfrm>
+            <a:off x="4950000" y="4200000"/>
+            <a:ext cx="347472" cy="347472"/>
+          </a:xfrm>
+          <a:prstGeom prst="ellipse">
+            <a:avLst/>
+          </a:prstGeom>
+          <a:solidFill>
+            <a:srgbClr val="1A73E8"/>
+          </a:solidFill>
+          <a:ln>
+            <a:noFill/>
+          </a:ln>
+        </p:spPr>
+        <p:style>
+          <a:lnRef idx="1">
+            <a:schemeClr val="accent1"/>
+          </a:lnRef>
+          <a:fillRef idx="3">
+            <a:schemeClr val="accent1"/>
+          </a:fillRef>
+          <a:effectRef idx="2">
+            <a:schemeClr val="accent1"/>
+          </a:effectRef>
+          <a:fontRef idx="minor">
+            <a:schemeClr val="lt1"/>
+          </a:fontRef>
+        </p:style>
+        <p:txBody>
+          <a:bodyPr rtlCol="0" anchor="ctr"/>
+          <a:lstStyle/>
+          <a:p>
+            <a:pPr algn="ctr"/>
+          </a:p>
+        </p:txBody>
+      </p:sp>
+      <p:pic>
+        <p:nvPicPr>
+          <p:cNvPr id="1026" name="Mobile app pic" descr="tf_mobile.png"/>
+          <p:cNvPicPr>
+            <a:picLocks noChangeAspect="1"/>
+          </p:cNvPicPr>
+          <p:nvPr/>
+        </p:nvPicPr>
+        <p:blipFill>
+          <a:blip r:embed="rId12"/>
+          <a:stretch>
+            <a:fillRect/>
+          </a:stretch>
+        </p:blipFill>
+        <p:spPr>
+          <a:xfrm>
+            <a:off x="5026444" y="4276444"/>
+            <a:ext cx="194584" cy="194584"/>
+          </a:xfrm>
+          <a:prstGeom prst="rect">
+            <a:avLst/>
+          </a:prstGeom>
+        </p:spPr>
+      </p:pic>
+      <p:sp>
+        <p:nvSpPr>
+          <p:cNvPr id="1027" name="Mobile app text"/>
+          <p:cNvSpPr txBox="1"/>
+          <p:nvPr/>
+        </p:nvSpPr>
+        <p:spPr>
+          <a:xfrm>
+            <a:off x="5420000" y="4182000"/>
+            <a:ext cx="3450000" cy="600000"/>
+          </a:xfrm>
+          <a:prstGeom prst="rect">
+            <a:avLst/>
+          </a:prstGeom>
+          <a:noFill/>
+        </p:spPr>
+        <p:txBody>
+          <a:bodyPr wrap="square" lIns="0" rIns="0" tIns="0" bIns="0">
+            <a:spAutoFit/>
+          </a:bodyPr>
+          <a:lstStyle/>
+          <a:p>
+            <a:pPr>
+              <a:spcAft>
+                <a:spcPts val="200"/>
+              </a:spcAft>
+            </a:pPr>
+            <a:r>
+              <a:rPr sz="1000" b="0">
+                <a:solidFill>
+                  <a:srgbClr val="202124"/>
+                </a:solidFill>
+                <a:latin typeface="Google Sans Flex SemiBold"/>
+              </a:rPr>
+              <a:t>Mobile app</a:t>
+            </a:r>
+          </a:p>
+          <a:p>
+            <a:pPr>
+              <a:spcAft>
+                <a:spcPts val="0"/>
+              </a:spcAft>
+            </a:pPr>
+            <a:r>
+              <a:rPr sz="900" b="0">
+                <a:solidFill>
+                  <a:srgbClr val="5F6368"/>
+                </a:solidFill>
+                <a:latin typeface="Google Sans Flex"/>
+              </a:rPr>
+              <a:t>A companion mobile app for plant teams, with real-time alerts and push notifications, on-the-go monitoring of machines and KPIs.</a:t>
+            </a:r>
           </a:p>
         </p:txBody>
       </p:sp>

</xml_diff>

<commit_message>
docs: add demo video link and standardize card styling on Slide 14
</commit_message>
<xml_diff>
--- a/docs/TwinForge_AI_Builder_Cup.pptx
+++ b/docs/TwinForge_AI_Builder_Cup.pptx
@@ -12456,12 +12456,10 @@
             </a:avLst>
           </a:prstGeom>
           <a:solidFill>
-            <a:srgbClr val="FCE8E6"/>
+            <a:srgbClr val="F1F3F4"/>
           </a:solidFill>
           <a:ln w="12700">
-            <a:solidFill>
-              <a:srgbClr val="C5221F"/>
-            </a:solidFill>
+            <a:noFill/>
             <a:prstDash val="dash"/>
           </a:ln>
         </p:spPr>
@@ -12615,16 +12613,14 @@
               <a:buNone/>
             </a:pPr>
             <a:r>
-              <a:rPr lang="en-GB" sz="1200" b="0" dirty="0">
+              <a:rPr sz="1300" b="0">
                 <a:solidFill>
-                  <a:srgbClr val="C5221F"/>
+                  <a:srgbClr val="1A73E8"/>
                 </a:solidFill>
                 <a:latin typeface="Google Sans Flex Medium"/>
-                <a:ea typeface="Google Sans Flex Medium"/>
-                <a:cs typeface="Google Sans Flex Medium"/>
-                <a:sym typeface="Google Sans Flex Medium"/>
+                <a:hlinkClick r:id="rId10"/>
               </a:rPr>
-              <a:t>Add the public YouTube, Vimeo or Google Drive link before submitting</a:t>
+              <a:t>https://drive.google.com/drive/folders/1_74Eehjv1zZRxFji0yO3JNsuIztxNazU?usp=share_link</a:t>
             </a:r>
             <a:endParaRPr lang="en-GB" sz="1300" dirty="0"/>
           </a:p>

</xml_diff>